<commit_message>
Changes for K8S 1.21 and improved dockerfile slides
</commit_message>
<xml_diff>
--- a/kubernetes/01_k8s_core_components.pptx
+++ b/kubernetes/01_k8s_core_components.pptx
@@ -1507,14 +1507,14 @@
     <dgm:cxn modelId="{4CC0F50F-E639-46A7-BA9B-C38C48A8E5A7}" type="presOf" srcId="{FB9AAE57-5715-4E83-B795-233F80C28DD5}" destId="{5BFFEAEE-23B1-4DBB-A971-39909A154747}" srcOrd="0" destOrd="0" presId="urn:microsoft.com/office/officeart/2005/8/layout/hProcess4"/>
     <dgm:cxn modelId="{19129A15-A57B-4CA4-956E-3249B877D054}" srcId="{5F7701CA-FAE9-401E-8919-DA68891591F1}" destId="{06A4AA28-4648-46CF-81EC-A9DC778D7A58}" srcOrd="0" destOrd="0" parTransId="{DDE15C73-0CA4-4049-B9B1-41E65338FCA2}" sibTransId="{2DD8EFFD-B8DF-4DDF-B0A0-46123496D507}"/>
     <dgm:cxn modelId="{4D81CC28-0FE3-49F8-8446-3F350EEFCA66}" srcId="{3511B0DC-F6D6-48BD-9E3E-8060DA330747}" destId="{C6CB76E7-A6D6-4352-91C0-0ADD32857D4B}" srcOrd="1" destOrd="0" parTransId="{DC5DAB65-CE0D-449E-8136-60B6B6D7A8C1}" sibTransId="{60AE151D-67FE-4C59-8C08-CD278EDDCF9E}"/>
+    <dgm:cxn modelId="{2AB9E25B-F590-47F7-B0D3-691E1853FC1F}" type="presOf" srcId="{E78D1906-0CE8-4399-8C8D-E3C236BEACE3}" destId="{2100B73E-41CC-441C-BAC0-823A501FB953}" srcOrd="0" destOrd="2" presId="urn:microsoft.com/office/officeart/2005/8/layout/hProcess4"/>
+    <dgm:cxn modelId="{95085E67-5884-441F-B103-8E71061E819E}" type="presOf" srcId="{1E496758-F884-4589-8FBC-E44F78EEE5A6}" destId="{DE045CBA-ECA2-453C-BFCF-A4743461A41D}" srcOrd="0" destOrd="0" presId="urn:microsoft.com/office/officeart/2005/8/layout/hProcess4"/>
     <dgm:cxn modelId="{CD5E4348-559C-4A1D-B671-C271C78CE60C}" type="presOf" srcId="{4DA7C20A-7791-417E-8B3D-4A6E6D60BD33}" destId="{97C182FE-34B2-4A5F-BF6F-C8F658CF5256}" srcOrd="0" destOrd="0" presId="urn:microsoft.com/office/officeart/2005/8/layout/hProcess4"/>
+    <dgm:cxn modelId="{022BC16C-04DC-482D-9D4B-FA96E08F940C}" srcId="{3511B0DC-F6D6-48BD-9E3E-8060DA330747}" destId="{B2CD7ED9-4770-4D36-8561-1FBD7A58A734}" srcOrd="0" destOrd="0" parTransId="{BFC98D57-6DD8-4ED9-AB9C-ACEC6CAD1AC3}" sibTransId="{CA6AF4FE-8A82-4760-8116-56336E1EFEAA}"/>
     <dgm:cxn modelId="{370A7950-74C6-46AC-BD6B-CFC6FA4385FB}" type="presOf" srcId="{06A4AA28-4648-46CF-81EC-A9DC778D7A58}" destId="{76AF6D70-EF0F-4D94-8B10-5B3008C85ED0}" srcOrd="0" destOrd="0" presId="urn:microsoft.com/office/officeart/2005/8/layout/hProcess4"/>
+    <dgm:cxn modelId="{FD2FA777-862B-4D2E-BB7D-92BEC9536E89}" srcId="{5F7701CA-FAE9-401E-8919-DA68891591F1}" destId="{045C94F8-2FB8-4591-9445-135ADC651512}" srcOrd="1" destOrd="0" parTransId="{2DAE4E03-5591-4C7C-AEFB-59F1267FBB7D}" sibTransId="{F0692511-A122-4957-BB26-F4BA9C66E1B7}"/>
     <dgm:cxn modelId="{61AA9D58-A016-4FBC-9C02-0633F5D95AC3}" type="presOf" srcId="{5F7701CA-FAE9-401E-8919-DA68891591F1}" destId="{8740B661-5258-4F6A-BBF1-9BC2872E0547}" srcOrd="0" destOrd="0" presId="urn:microsoft.com/office/officeart/2005/8/layout/hProcess4"/>
     <dgm:cxn modelId="{A6BBB958-741B-42BD-9B0E-CFBC186A3C54}" type="presOf" srcId="{E78D1906-0CE8-4399-8C8D-E3C236BEACE3}" destId="{BDE1A59F-632B-4E78-BDBB-6B8F36D66ACD}" srcOrd="1" destOrd="2" presId="urn:microsoft.com/office/officeart/2005/8/layout/hProcess4"/>
-    <dgm:cxn modelId="{2AB9E25B-F590-47F7-B0D3-691E1853FC1F}" type="presOf" srcId="{E78D1906-0CE8-4399-8C8D-E3C236BEACE3}" destId="{2100B73E-41CC-441C-BAC0-823A501FB953}" srcOrd="0" destOrd="2" presId="urn:microsoft.com/office/officeart/2005/8/layout/hProcess4"/>
-    <dgm:cxn modelId="{95085E67-5884-441F-B103-8E71061E819E}" type="presOf" srcId="{1E496758-F884-4589-8FBC-E44F78EEE5A6}" destId="{DE045CBA-ECA2-453C-BFCF-A4743461A41D}" srcOrd="0" destOrd="0" presId="urn:microsoft.com/office/officeart/2005/8/layout/hProcess4"/>
-    <dgm:cxn modelId="{022BC16C-04DC-482D-9D4B-FA96E08F940C}" srcId="{3511B0DC-F6D6-48BD-9E3E-8060DA330747}" destId="{B2CD7ED9-4770-4D36-8561-1FBD7A58A734}" srcOrd="0" destOrd="0" parTransId="{BFC98D57-6DD8-4ED9-AB9C-ACEC6CAD1AC3}" sibTransId="{CA6AF4FE-8A82-4760-8116-56336E1EFEAA}"/>
-    <dgm:cxn modelId="{FD2FA777-862B-4D2E-BB7D-92BEC9536E89}" srcId="{5F7701CA-FAE9-401E-8919-DA68891591F1}" destId="{045C94F8-2FB8-4591-9445-135ADC651512}" srcOrd="1" destOrd="0" parTransId="{2DAE4E03-5591-4C7C-AEFB-59F1267FBB7D}" sibTransId="{F0692511-A122-4957-BB26-F4BA9C66E1B7}"/>
     <dgm:cxn modelId="{4BAFAA84-A6FF-4EC7-9584-C02E3A6BB20F}" type="presOf" srcId="{B2CD7ED9-4770-4D36-8561-1FBD7A58A734}" destId="{2100B73E-41CC-441C-BAC0-823A501FB953}" srcOrd="0" destOrd="0" presId="urn:microsoft.com/office/officeart/2005/8/layout/hProcess4"/>
     <dgm:cxn modelId="{3DD8D885-928A-45E9-B1CE-E985BD54F0ED}" type="presOf" srcId="{045C94F8-2FB8-4591-9445-135ADC651512}" destId="{59F1278C-608A-40AD-AE92-1B1BA4D0FD3D}" srcOrd="1" destOrd="1" presId="urn:microsoft.com/office/officeart/2005/8/layout/hProcess4"/>
     <dgm:cxn modelId="{52C41288-D24D-4335-ACEA-B7BB0A819297}" type="presOf" srcId="{3511B0DC-F6D6-48BD-9E3E-8060DA330747}" destId="{77134645-C330-4227-A436-590F23FB91E4}" srcOrd="0" destOrd="0" presId="urn:microsoft.com/office/officeart/2005/8/layout/hProcess4"/>
@@ -3835,7 +3835,7 @@
             <a:fld id="{47855BD9-AF71-426C-9B9B-B0E52B88852E}" type="slidenum">
               <a:rPr lang="de-DE" sz="1000" smtClean="0"/>
               <a:pPr algn="ctr"/>
-              <a:t>‹Nr.›</a:t>
+              <a:t>‹#›</a:t>
             </a:fld>
             <a:endParaRPr lang="de-DE" sz="1000" dirty="0"/>
           </a:p>
@@ -3984,7 +3984,7 @@
             <a:fld id="{7D8C2C35-2B8A-446E-BEC0-FD36716C29AC}" type="slidenum">
               <a:rPr lang="de-DE" smtClean="0"/>
               <a:pPr/>
-              <a:t>‹Nr.›</a:t>
+              <a:t>‹#›</a:t>
             </a:fld>
             <a:endParaRPr lang="de-DE" dirty="0"/>
           </a:p>
@@ -4240,12 +4240,8 @@
           <a:lstStyle/>
           <a:p>
             <a:r>
-              <a:rPr lang="de-DE" dirty="0" err="1"/>
-              <a:t>beta</a:t>
-            </a:r>
-            <a:r>
-              <a:rPr lang="de-DE" dirty="0"/>
-              <a:t>: </a:t>
+              <a:rPr lang="en-US" noProof="0" dirty="0"/>
+              <a:t>beta: </a:t>
             </a:r>
           </a:p>
           <a:p>
@@ -4254,36 +4250,8 @@
               <a:buChar char="-"/>
             </a:pPr>
             <a:r>
-              <a:rPr lang="de-DE" dirty="0" err="1"/>
-              <a:t>aims</a:t>
-            </a:r>
-            <a:r>
-              <a:rPr lang="de-DE" dirty="0"/>
-              <a:t> </a:t>
-            </a:r>
-            <a:r>
-              <a:rPr lang="de-DE" dirty="0" err="1"/>
-              <a:t>for</a:t>
-            </a:r>
-            <a:r>
-              <a:rPr lang="de-DE" dirty="0"/>
-              <a:t> </a:t>
-            </a:r>
-            <a:r>
-              <a:rPr lang="de-DE" dirty="0" err="1"/>
-              <a:t>backwards</a:t>
-            </a:r>
-            <a:r>
-              <a:rPr lang="de-DE" dirty="0"/>
-              <a:t> </a:t>
-            </a:r>
-            <a:r>
-              <a:rPr lang="de-DE" dirty="0" err="1"/>
-              <a:t>compatibility</a:t>
-            </a:r>
-            <a:r>
-              <a:rPr lang="de-DE" dirty="0"/>
-              <a:t>, </a:t>
+              <a:rPr lang="en-US" noProof="0" dirty="0"/>
+              <a:t>aims for backwards compatibility, </a:t>
             </a:r>
           </a:p>
           <a:p>
@@ -4292,26 +4260,9 @@
               <a:buChar char="-"/>
             </a:pPr>
             <a:r>
-              <a:rPr lang="de-DE" dirty="0" err="1"/>
-              <a:t>may</a:t>
-            </a:r>
-            <a:r>
-              <a:rPr lang="de-DE" dirty="0"/>
-              <a:t> </a:t>
-            </a:r>
-            <a:r>
-              <a:rPr lang="de-DE" dirty="0" err="1"/>
-              <a:t>have</a:t>
-            </a:r>
-            <a:r>
-              <a:rPr lang="de-DE" dirty="0"/>
-              <a:t> </a:t>
-            </a:r>
-            <a:r>
-              <a:rPr lang="de-DE" dirty="0" err="1"/>
-              <a:t>bugs</a:t>
-            </a:r>
-            <a:endParaRPr lang="de-DE" dirty="0"/>
+              <a:rPr lang="en-US" noProof="0" dirty="0"/>
+              <a:t>may have bugs</a:t>
+            </a:r>
           </a:p>
           <a:p>
             <a:pPr marL="285750" indent="-285750">
@@ -4319,41 +4270,16 @@
               <a:buChar char="-"/>
             </a:pPr>
             <a:r>
-              <a:rPr lang="de-DE" dirty="0" err="1"/>
-              <a:t>used</a:t>
-            </a:r>
-            <a:r>
-              <a:rPr lang="de-DE" dirty="0"/>
-              <a:t> in </a:t>
-            </a:r>
-            <a:r>
-              <a:rPr lang="de-DE" dirty="0" err="1"/>
-              <a:t>production</a:t>
-            </a:r>
-            <a:r>
-              <a:rPr lang="de-DE" dirty="0"/>
-              <a:t> </a:t>
-            </a:r>
-            <a:r>
-              <a:rPr lang="de-DE" dirty="0" err="1"/>
-              <a:t>with</a:t>
-            </a:r>
-            <a:r>
-              <a:rPr lang="de-DE" dirty="0"/>
-              <a:t> </a:t>
-            </a:r>
-            <a:r>
-              <a:rPr lang="de-DE" dirty="0" err="1"/>
-              <a:t>caution</a:t>
-            </a:r>
-            <a:endParaRPr lang="de-DE" dirty="0"/>
+              <a:rPr lang="en-US" noProof="0" dirty="0"/>
+              <a:t>used in production with caution</a:t>
+            </a:r>
           </a:p>
           <a:p>
             <a:pPr marL="285750" indent="-285750">
               <a:buFontTx/>
               <a:buChar char="-"/>
             </a:pPr>
-            <a:endParaRPr lang="de-DE" dirty="0"/>
+            <a:endParaRPr lang="en-US" noProof="0" dirty="0"/>
           </a:p>
           <a:p>
             <a:pPr marL="0" indent="0">
@@ -4361,7 +4287,7 @@
               <a:buNone/>
             </a:pPr>
             <a:r>
-              <a:rPr lang="de-DE" dirty="0"/>
+              <a:rPr lang="en-US" noProof="0" dirty="0"/>
               <a:t>v1 / GA:</a:t>
             </a:r>
           </a:p>
@@ -4371,34 +4297,9 @@
               <a:buChar char="-"/>
             </a:pPr>
             <a:r>
-              <a:rPr lang="de-DE" dirty="0" err="1"/>
-              <a:t>no</a:t>
-            </a:r>
-            <a:r>
-              <a:rPr lang="de-DE" dirty="0"/>
-              <a:t> </a:t>
-            </a:r>
-            <a:r>
-              <a:rPr lang="de-DE" dirty="0" err="1"/>
-              <a:t>bugs</a:t>
-            </a:r>
-            <a:r>
-              <a:rPr lang="de-DE" dirty="0"/>
-              <a:t> </a:t>
-            </a:r>
-            <a:r>
-              <a:rPr lang="de-DE" dirty="0" err="1"/>
-              <a:t>of</a:t>
-            </a:r>
-            <a:r>
-              <a:rPr lang="de-DE" dirty="0"/>
-              <a:t> </a:t>
-            </a:r>
-            <a:r>
-              <a:rPr lang="de-DE" dirty="0" err="1"/>
-              <a:t>course</a:t>
-            </a:r>
-            <a:endParaRPr lang="de-DE" dirty="0"/>
+              <a:rPr lang="en-US" noProof="0" dirty="0"/>
+              <a:t>no bugs of course</a:t>
+            </a:r>
           </a:p>
           <a:p>
             <a:pPr marL="285750" indent="-285750">
@@ -4406,61 +4307,20 @@
               <a:buChar char="-"/>
             </a:pPr>
             <a:r>
-              <a:rPr lang="de-DE" dirty="0" err="1"/>
-              <a:t>available</a:t>
-            </a:r>
-            <a:r>
-              <a:rPr lang="de-DE" dirty="0"/>
-              <a:t> </a:t>
-            </a:r>
-            <a:r>
-              <a:rPr lang="de-DE" dirty="0" err="1"/>
-              <a:t>until</a:t>
-            </a:r>
-            <a:r>
-              <a:rPr lang="de-DE" dirty="0"/>
-              <a:t> </a:t>
-            </a:r>
-            <a:r>
-              <a:rPr lang="de-DE" dirty="0" err="1"/>
-              <a:t>deprecated</a:t>
-            </a:r>
-            <a:r>
-              <a:rPr lang="de-DE" dirty="0"/>
-              <a:t> (3 </a:t>
-            </a:r>
-            <a:r>
-              <a:rPr lang="de-DE" dirty="0" err="1"/>
-              <a:t>releases</a:t>
-            </a:r>
-            <a:r>
-              <a:rPr lang="de-DE" dirty="0"/>
-              <a:t> </a:t>
-            </a:r>
-            <a:r>
-              <a:rPr lang="de-DE" dirty="0" err="1"/>
-              <a:t>or</a:t>
-            </a:r>
-            <a:r>
-              <a:rPr lang="de-DE" dirty="0"/>
-              <a:t> </a:t>
-            </a:r>
-            <a:r>
-              <a:rPr lang="de-DE" dirty="0" err="1"/>
-              <a:t>max</a:t>
-            </a:r>
-            <a:r>
-              <a:rPr lang="de-DE" dirty="0"/>
-              <a:t> 1 </a:t>
-            </a:r>
-            <a:r>
-              <a:rPr lang="de-DE" dirty="0" err="1"/>
-              <a:t>year</a:t>
-            </a:r>
-            <a:r>
-              <a:rPr lang="de-DE" dirty="0"/>
-              <a:t>)</a:t>
-            </a:r>
+              <a:rPr lang="en-US" noProof="0" dirty="0"/>
+              <a:t>available until deprecated (Kubernetes has a very strictly defined policy for deprecating features, in general 3 releases or max 1 year, see https://kubernetes.io/docs/reference/using-api/</a:t>
+            </a:r>
+            <a:r>
+              <a:rPr lang="en-US" noProof="0"/>
+              <a:t>deprecation-policy/)</a:t>
+            </a:r>
+          </a:p>
+          <a:p>
+            <a:pPr marL="285750" indent="-285750">
+              <a:buFontTx/>
+              <a:buChar char="-"/>
+            </a:pPr>
+            <a:endParaRPr lang="en-US" noProof="0" dirty="0"/>
           </a:p>
         </p:txBody>
       </p:sp>
@@ -14312,7 +14172,7 @@
               <a:pPr marL="0" lvl="0" indent="0" algn="r">
                 <a:buNone/>
               </a:pPr>
-              <a:t>‹Nr.›</a:t>
+              <a:t>‹#›</a:t>
             </a:fld>
             <a:endParaRPr lang="en-US" sz="900" noProof="0" dirty="0"/>
           </a:p>
@@ -15236,82 +15096,35 @@
           <a:bodyPr/>
           <a:lstStyle/>
           <a:p>
-            <a:r>
-              <a:rPr lang="de-DE" sz="2900" dirty="0"/>
-              <a:t>v1alpha1	</a:t>
-            </a:r>
-            <a:r>
-              <a:rPr lang="de-DE" sz="2900" dirty="0">
+            <a:pPr marL="2511425" indent="-2511425" defTabSz="989013">
+              <a:tabLst>
+                <a:tab pos="1885950" algn="l"/>
+              </a:tabLst>
+            </a:pPr>
+            <a:r>
+              <a:rPr lang="en-US" sz="2900" dirty="0"/>
+              <a:t>v1</a:t>
+            </a:r>
+            <a:r>
+              <a:rPr lang="en-US" sz="2900" b="1" dirty="0"/>
+              <a:t>alpha</a:t>
+            </a:r>
+            <a:r>
+              <a:rPr lang="en-US" sz="2900" dirty="0"/>
+              <a:t>1	</a:t>
+            </a:r>
+            <a:r>
+              <a:rPr lang="en-US" sz="2900" dirty="0">
                 <a:solidFill>
                   <a:schemeClr val="tx1">
                     <a:lumMod val="75000"/>
                   </a:schemeClr>
                 </a:solidFill>
               </a:rPr>
-              <a:t>-- </a:t>
-            </a:r>
-            <a:r>
-              <a:rPr lang="de-DE" sz="2900" dirty="0" err="1">
-                <a:solidFill>
-                  <a:schemeClr val="tx1">
-                    <a:lumMod val="75000"/>
-                  </a:schemeClr>
-                </a:solidFill>
-              </a:rPr>
-              <a:t>cluster</a:t>
-            </a:r>
-            <a:r>
-              <a:rPr lang="de-DE" sz="2900" dirty="0">
-                <a:solidFill>
-                  <a:schemeClr val="tx1">
-                    <a:lumMod val="75000"/>
-                  </a:schemeClr>
-                </a:solidFill>
-              </a:rPr>
-              <a:t> </a:t>
-            </a:r>
-            <a:r>
-              <a:rPr lang="de-DE" sz="2900" dirty="0" err="1">
-                <a:solidFill>
-                  <a:schemeClr val="tx1">
-                    <a:lumMod val="75000"/>
-                  </a:schemeClr>
-                </a:solidFill>
-              </a:rPr>
-              <a:t>may</a:t>
-            </a:r>
-            <a:r>
-              <a:rPr lang="de-DE" sz="2900" dirty="0">
-                <a:solidFill>
-                  <a:schemeClr val="tx1">
-                    <a:lumMod val="75000"/>
-                  </a:schemeClr>
-                </a:solidFill>
-              </a:rPr>
-              <a:t> </a:t>
-            </a:r>
-            <a:r>
-              <a:rPr lang="de-DE" sz="2900" dirty="0" err="1">
-                <a:solidFill>
-                  <a:schemeClr val="tx1">
-                    <a:lumMod val="75000"/>
-                  </a:schemeClr>
-                </a:solidFill>
-              </a:rPr>
-              <a:t>explode</a:t>
-            </a:r>
-            <a:r>
-              <a:rPr lang="de-DE" sz="2900" dirty="0">
-                <a:solidFill>
-                  <a:schemeClr val="tx1">
-                    <a:lumMod val="75000"/>
-                  </a:schemeClr>
-                </a:solidFill>
-              </a:rPr>
-              <a:t>, volatile </a:t>
-            </a:r>
-            <a:r>
-              <a:rPr lang="de-DE" sz="2900" dirty="0" err="1">
+              <a:t>-- 	cluster may explode, volatile </a:t>
+            </a:r>
+            <a:r>
+              <a:rPr lang="en-US" sz="2900" dirty="0" err="1">
                 <a:solidFill>
                   <a:schemeClr val="tx1">
                     <a:lumMod val="75000"/>
@@ -15321,179 +15134,65 @@
               <a:t>api</a:t>
             </a:r>
             <a:r>
-              <a:rPr lang="de-DE" sz="2900" dirty="0">
+              <a:rPr lang="en-US" sz="2900" dirty="0">
                 <a:solidFill>
                   <a:schemeClr val="tx1">
                     <a:lumMod val="75000"/>
                   </a:schemeClr>
                 </a:solidFill>
               </a:rPr>
-              <a:t> </a:t>
-            </a:r>
-            <a:r>
-              <a:rPr lang="de-DE" sz="2900" dirty="0" err="1">
+              <a:t> changes expected</a:t>
+            </a:r>
+          </a:p>
+          <a:p>
+            <a:pPr marL="2511425" indent="-2511425" defTabSz="989013">
+              <a:tabLst>
+                <a:tab pos="1885950" algn="l"/>
+              </a:tabLst>
+            </a:pPr>
+            <a:r>
+              <a:rPr lang="en-US" sz="2900" dirty="0"/>
+              <a:t>v1</a:t>
+            </a:r>
+            <a:r>
+              <a:rPr lang="en-US" sz="2900" b="1" dirty="0"/>
+              <a:t>beta</a:t>
+            </a:r>
+            <a:r>
+              <a:rPr lang="en-US" sz="2900" dirty="0"/>
+              <a:t>1	</a:t>
+            </a:r>
+            <a:r>
+              <a:rPr lang="en-US" sz="2900" dirty="0">
                 <a:solidFill>
                   <a:schemeClr val="tx1">
                     <a:lumMod val="75000"/>
                   </a:schemeClr>
                 </a:solidFill>
               </a:rPr>
-              <a:t>changes</a:t>
-            </a:r>
-            <a:r>
-              <a:rPr lang="de-DE" sz="2900" dirty="0">
+              <a:t>-- 	well tested and generally stable,  API semantics may still change in an incompatible fashion</a:t>
+            </a:r>
+          </a:p>
+          <a:p>
+            <a:pPr marL="2511425" indent="-2511425" defTabSz="989013">
+              <a:tabLst>
+                <a:tab pos="1885950" algn="l"/>
+              </a:tabLst>
+            </a:pPr>
+            <a:r>
+              <a:rPr lang="en-US" sz="2900" dirty="0"/>
+              <a:t>v1	</a:t>
+            </a:r>
+            <a:r>
+              <a:rPr lang="en-US" sz="2900" dirty="0">
                 <a:solidFill>
                   <a:schemeClr val="tx1">
                     <a:lumMod val="75000"/>
                   </a:schemeClr>
                 </a:solidFill>
               </a:rPr>
-              <a:t> </a:t>
-            </a:r>
-            <a:r>
-              <a:rPr lang="de-DE" sz="2900" dirty="0" err="1">
-                <a:solidFill>
-                  <a:schemeClr val="tx1">
-                    <a:lumMod val="75000"/>
-                  </a:schemeClr>
-                </a:solidFill>
-              </a:rPr>
-              <a:t>expected</a:t>
-            </a:r>
-            <a:br>
-              <a:rPr lang="de-DE" sz="2900" dirty="0"/>
-            </a:br>
-            <a:br>
-              <a:rPr lang="de-DE" sz="2900" dirty="0"/>
-            </a:br>
-            <a:r>
-              <a:rPr lang="de-DE" sz="2900" dirty="0"/>
-              <a:t>v1beta1	</a:t>
-            </a:r>
-            <a:r>
-              <a:rPr lang="de-DE" sz="2900" dirty="0">
-                <a:solidFill>
-                  <a:schemeClr val="tx1">
-                    <a:lumMod val="75000"/>
-                  </a:schemeClr>
-                </a:solidFill>
-              </a:rPr>
-              <a:t>-- </a:t>
-            </a:r>
-            <a:r>
-              <a:rPr lang="de-DE" sz="2900" dirty="0" err="1">
-                <a:solidFill>
-                  <a:schemeClr val="tx1">
-                    <a:lumMod val="75000"/>
-                  </a:schemeClr>
-                </a:solidFill>
-              </a:rPr>
-              <a:t>generally</a:t>
-            </a:r>
-            <a:r>
-              <a:rPr lang="de-DE" sz="2900" dirty="0">
-                <a:solidFill>
-                  <a:schemeClr val="tx1">
-                    <a:lumMod val="75000"/>
-                  </a:schemeClr>
-                </a:solidFill>
-              </a:rPr>
-              <a:t> </a:t>
-            </a:r>
-            <a:r>
-              <a:rPr lang="de-DE" sz="2900" dirty="0" err="1">
-                <a:solidFill>
-                  <a:schemeClr val="tx1">
-                    <a:lumMod val="75000"/>
-                  </a:schemeClr>
-                </a:solidFill>
-              </a:rPr>
-              <a:t>stable</a:t>
-            </a:r>
-            <a:br>
-              <a:rPr lang="de-DE" sz="2900" dirty="0">
-                <a:solidFill>
-                  <a:schemeClr val="tx1">
-                    <a:lumMod val="75000"/>
-                  </a:schemeClr>
-                </a:solidFill>
-              </a:rPr>
-            </a:br>
-            <a:br>
-              <a:rPr lang="de-DE" sz="2900" dirty="0">
-                <a:solidFill>
-                  <a:schemeClr val="tx1">
-                    <a:lumMod val="75000"/>
-                  </a:schemeClr>
-                </a:solidFill>
-              </a:rPr>
-            </a:br>
-            <a:r>
-              <a:rPr lang="de-DE" sz="2900" dirty="0"/>
-              <a:t>v1		</a:t>
-            </a:r>
-            <a:r>
-              <a:rPr lang="de-DE" sz="2900" dirty="0">
-                <a:solidFill>
-                  <a:schemeClr val="tx1">
-                    <a:lumMod val="75000"/>
-                  </a:schemeClr>
-                </a:solidFill>
-              </a:rPr>
-              <a:t>-- GA (</a:t>
-            </a:r>
-            <a:r>
-              <a:rPr lang="de-DE" sz="2900" dirty="0" err="1">
-                <a:solidFill>
-                  <a:schemeClr val="tx1">
-                    <a:lumMod val="75000"/>
-                  </a:schemeClr>
-                </a:solidFill>
-              </a:rPr>
-              <a:t>general</a:t>
-            </a:r>
-            <a:r>
-              <a:rPr lang="de-DE" sz="2900" dirty="0">
-                <a:solidFill>
-                  <a:schemeClr val="tx1">
-                    <a:lumMod val="75000"/>
-                  </a:schemeClr>
-                </a:solidFill>
-              </a:rPr>
-              <a:t> </a:t>
-            </a:r>
-            <a:r>
-              <a:rPr lang="de-DE" sz="2900" dirty="0" err="1">
-                <a:solidFill>
-                  <a:schemeClr val="tx1">
-                    <a:lumMod val="75000"/>
-                  </a:schemeClr>
-                </a:solidFill>
-              </a:rPr>
-              <a:t>availability</a:t>
-            </a:r>
-            <a:r>
-              <a:rPr lang="de-DE" sz="2900" dirty="0">
-                <a:solidFill>
-                  <a:schemeClr val="tx1">
-                    <a:lumMod val="75000"/>
-                  </a:schemeClr>
-                </a:solidFill>
-              </a:rPr>
-              <a:t>)</a:t>
-            </a:r>
-          </a:p>
-          <a:p>
-            <a:endParaRPr lang="de-DE" sz="2400" dirty="0">
-              <a:solidFill>
-                <a:schemeClr val="tx1">
-                  <a:lumMod val="75000"/>
-                </a:schemeClr>
-              </a:solidFill>
-            </a:endParaRPr>
-          </a:p>
-          <a:p>
-            <a:endParaRPr lang="de-DE" sz="2400" dirty="0"/>
+              <a:t>-- 	GA (general availability)</a:t>
+            </a:r>
           </a:p>
         </p:txBody>
       </p:sp>
@@ -15519,14 +15218,9 @@
           <a:lstStyle/>
           <a:p>
             <a:r>
-              <a:rPr lang="de-DE" dirty="0"/>
-              <a:t>API </a:t>
-            </a:r>
-            <a:r>
-              <a:rPr lang="de-DE" dirty="0" err="1"/>
-              <a:t>Versioning</a:t>
-            </a:r>
-            <a:endParaRPr lang="de-DE" dirty="0"/>
+              <a:rPr lang="en-US" dirty="0"/>
+              <a:t>API Versioning</a:t>
+            </a:r>
           </a:p>
         </p:txBody>
       </p:sp>
@@ -30796,420 +30490,138 @@
           <a:lstStyle/>
           <a:p>
             <a:r>
-              <a:rPr lang="de-DE" dirty="0"/>
+              <a:rPr lang="en-US" dirty="0"/>
               <a:t>/</a:t>
             </a:r>
             <a:r>
-              <a:rPr lang="de-DE" dirty="0" err="1"/>
+              <a:rPr lang="en-US" dirty="0" err="1"/>
               <a:t>api</a:t>
             </a:r>
             <a:r>
-              <a:rPr lang="de-DE" dirty="0"/>
+              <a:rPr lang="en-US" dirty="0"/>
               <a:t>/v1/			</a:t>
             </a:r>
             <a:r>
-              <a:rPr lang="de-DE" dirty="0">
+              <a:rPr lang="en-US" dirty="0">
                 <a:solidFill>
                   <a:schemeClr val="tx1">
                     <a:lumMod val="75000"/>
                   </a:schemeClr>
                 </a:solidFill>
               </a:rPr>
-              <a:t>-- </a:t>
-            </a:r>
-            <a:r>
-              <a:rPr lang="de-DE" dirty="0" err="1">
+              <a:t>-- core objects like pods or services</a:t>
+            </a:r>
+          </a:p>
+          <a:p>
+            <a:r>
+              <a:rPr lang="en-US" dirty="0"/>
+              <a:t>/</a:t>
+            </a:r>
+            <a:r>
+              <a:rPr lang="en-US" dirty="0" err="1"/>
+              <a:t>api</a:t>
+            </a:r>
+            <a:r>
+              <a:rPr lang="en-US" dirty="0"/>
+              <a:t>/&lt;</a:t>
+            </a:r>
+            <a:r>
+              <a:rPr lang="en-US" dirty="0" err="1"/>
+              <a:t>apigroup</a:t>
+            </a:r>
+            <a:r>
+              <a:rPr lang="en-US" dirty="0"/>
+              <a:t>&gt; 		</a:t>
+            </a:r>
+            <a:r>
+              <a:rPr lang="en-US" dirty="0">
                 <a:solidFill>
                   <a:schemeClr val="tx1">
                     <a:lumMod val="75000"/>
                   </a:schemeClr>
                 </a:solidFill>
               </a:rPr>
-              <a:t>core</a:t>
-            </a:r>
-            <a:r>
-              <a:rPr lang="de-DE" dirty="0">
-                <a:solidFill>
-                  <a:schemeClr val="tx1">
-                    <a:lumMod val="75000"/>
-                  </a:schemeClr>
-                </a:solidFill>
-              </a:rPr>
-              <a:t> </a:t>
-            </a:r>
-            <a:r>
-              <a:rPr lang="de-DE" dirty="0" err="1">
-                <a:solidFill>
-                  <a:schemeClr val="tx1">
-                    <a:lumMod val="75000"/>
-                  </a:schemeClr>
-                </a:solidFill>
-              </a:rPr>
-              <a:t>objects</a:t>
-            </a:r>
-            <a:r>
-              <a:rPr lang="de-DE" dirty="0">
-                <a:solidFill>
-                  <a:schemeClr val="tx1">
-                    <a:lumMod val="75000"/>
-                  </a:schemeClr>
-                </a:solidFill>
-              </a:rPr>
-              <a:t> like </a:t>
-            </a:r>
-            <a:r>
-              <a:rPr lang="de-DE" dirty="0" err="1">
-                <a:solidFill>
-                  <a:schemeClr val="tx1">
-                    <a:lumMod val="75000"/>
-                  </a:schemeClr>
-                </a:solidFill>
-              </a:rPr>
-              <a:t>pods</a:t>
-            </a:r>
-            <a:r>
-              <a:rPr lang="de-DE" dirty="0">
-                <a:solidFill>
-                  <a:schemeClr val="tx1">
-                    <a:lumMod val="75000"/>
-                  </a:schemeClr>
-                </a:solidFill>
-              </a:rPr>
-              <a:t> </a:t>
-            </a:r>
-            <a:r>
-              <a:rPr lang="de-DE" dirty="0" err="1">
-                <a:solidFill>
-                  <a:schemeClr val="tx1">
-                    <a:lumMod val="75000"/>
-                  </a:schemeClr>
-                </a:solidFill>
-              </a:rPr>
-              <a:t>or</a:t>
-            </a:r>
-            <a:r>
-              <a:rPr lang="de-DE" dirty="0">
-                <a:solidFill>
-                  <a:schemeClr val="tx1">
-                    <a:lumMod val="75000"/>
-                  </a:schemeClr>
-                </a:solidFill>
-              </a:rPr>
-              <a:t> </a:t>
-            </a:r>
-            <a:r>
-              <a:rPr lang="de-DE" dirty="0" err="1">
-                <a:solidFill>
-                  <a:schemeClr val="tx1">
-                    <a:lumMod val="75000"/>
-                  </a:schemeClr>
-                </a:solidFill>
-              </a:rPr>
-              <a:t>services</a:t>
-            </a:r>
-            <a:endParaRPr lang="de-DE" dirty="0">
-              <a:solidFill>
-                <a:schemeClr val="tx1">
-                  <a:lumMod val="75000"/>
-                </a:schemeClr>
-              </a:solidFill>
-            </a:endParaRPr>
-          </a:p>
-          <a:p>
-            <a:r>
-              <a:rPr lang="de-DE" dirty="0"/>
-              <a:t>/</a:t>
-            </a:r>
-            <a:r>
-              <a:rPr lang="de-DE" dirty="0" err="1"/>
+              <a:t>-- added later as the API grew</a:t>
+            </a:r>
+          </a:p>
+          <a:p>
+            <a:r>
+              <a:rPr lang="en-US" dirty="0"/>
+              <a:t>/ </a:t>
+            </a:r>
+            <a:r>
+              <a:rPr lang="en-US" dirty="0" err="1"/>
               <a:t>api</a:t>
             </a:r>
             <a:r>
-              <a:rPr lang="de-DE" dirty="0"/>
-              <a:t>/&lt;</a:t>
-            </a:r>
-            <a:r>
-              <a:rPr lang="de-DE" dirty="0" err="1"/>
+              <a:rPr lang="en-US" dirty="0"/>
+              <a:t> /(&lt;</a:t>
+            </a:r>
+            <a:r>
+              <a:rPr lang="en-US" dirty="0" err="1"/>
               <a:t>apigroup</a:t>
             </a:r>
             <a:r>
-              <a:rPr lang="de-DE" dirty="0"/>
-              <a:t>&gt; 		</a:t>
-            </a:r>
-            <a:r>
-              <a:rPr lang="de-DE" dirty="0">
-                <a:solidFill>
-                  <a:schemeClr val="tx1">
-                    <a:lumMod val="75000"/>
-                  </a:schemeClr>
-                </a:solidFill>
-              </a:rPr>
-              <a:t>-- </a:t>
-            </a:r>
-            <a:r>
-              <a:rPr lang="de-DE" dirty="0" err="1">
-                <a:solidFill>
-                  <a:schemeClr val="tx1">
-                    <a:lumMod val="75000"/>
-                  </a:schemeClr>
-                </a:solidFill>
-              </a:rPr>
-              <a:t>added</a:t>
-            </a:r>
-            <a:r>
-              <a:rPr lang="de-DE" dirty="0">
-                <a:solidFill>
-                  <a:schemeClr val="tx1">
-                    <a:lumMod val="75000"/>
-                  </a:schemeClr>
-                </a:solidFill>
-              </a:rPr>
-              <a:t> </a:t>
-            </a:r>
-            <a:r>
-              <a:rPr lang="de-DE" dirty="0" err="1">
-                <a:solidFill>
-                  <a:schemeClr val="tx1">
-                    <a:lumMod val="75000"/>
-                  </a:schemeClr>
-                </a:solidFill>
-              </a:rPr>
-              <a:t>later</a:t>
-            </a:r>
-            <a:r>
-              <a:rPr lang="de-DE" dirty="0">
-                <a:solidFill>
-                  <a:schemeClr val="tx1">
-                    <a:lumMod val="75000"/>
-                  </a:schemeClr>
-                </a:solidFill>
-              </a:rPr>
-              <a:t> </a:t>
-            </a:r>
-            <a:r>
-              <a:rPr lang="de-DE" dirty="0" err="1">
-                <a:solidFill>
-                  <a:schemeClr val="tx1">
-                    <a:lumMod val="75000"/>
-                  </a:schemeClr>
-                </a:solidFill>
-              </a:rPr>
-              <a:t>as</a:t>
-            </a:r>
-            <a:r>
-              <a:rPr lang="de-DE" dirty="0">
-                <a:solidFill>
-                  <a:schemeClr val="tx1">
-                    <a:lumMod val="75000"/>
-                  </a:schemeClr>
-                </a:solidFill>
-              </a:rPr>
-              <a:t> </a:t>
-            </a:r>
-            <a:r>
-              <a:rPr lang="de-DE" dirty="0" err="1">
-                <a:solidFill>
-                  <a:schemeClr val="tx1">
-                    <a:lumMod val="75000"/>
-                  </a:schemeClr>
-                </a:solidFill>
-              </a:rPr>
-              <a:t>the</a:t>
-            </a:r>
-            <a:r>
-              <a:rPr lang="de-DE" dirty="0">
-                <a:solidFill>
-                  <a:schemeClr val="tx1">
-                    <a:lumMod val="75000"/>
-                  </a:schemeClr>
-                </a:solidFill>
-              </a:rPr>
-              <a:t> API </a:t>
-            </a:r>
-            <a:r>
-              <a:rPr lang="de-DE" dirty="0" err="1">
-                <a:solidFill>
-                  <a:schemeClr val="tx1">
-                    <a:lumMod val="75000"/>
-                  </a:schemeClr>
-                </a:solidFill>
-              </a:rPr>
-              <a:t>grew</a:t>
-            </a:r>
-            <a:endParaRPr lang="de-DE" dirty="0">
-              <a:solidFill>
-                <a:schemeClr val="tx1">
-                  <a:lumMod val="75000"/>
-                </a:schemeClr>
-              </a:solidFill>
-            </a:endParaRPr>
-          </a:p>
-          <a:p>
-            <a:r>
-              <a:rPr lang="de-DE" dirty="0"/>
+              <a:rPr lang="en-US" dirty="0"/>
+              <a:t>&gt;/) </a:t>
+            </a:r>
+            <a:r>
+              <a:rPr lang="en-US" i="1" dirty="0"/>
+              <a:t>&lt;version&gt; </a:t>
+            </a:r>
+            <a:r>
+              <a:rPr lang="en-US" dirty="0"/>
+              <a:t>/ namespaces / </a:t>
+            </a:r>
+            <a:r>
+              <a:rPr lang="en-US" i="1" dirty="0"/>
+              <a:t>&lt;ns&gt; </a:t>
+            </a:r>
+            <a:r>
+              <a:rPr lang="en-US" dirty="0"/>
               <a:t>/ </a:t>
             </a:r>
             <a:r>
-              <a:rPr lang="de-DE" dirty="0" err="1"/>
-              <a:t>api</a:t>
-            </a:r>
-            <a:r>
-              <a:rPr lang="de-DE" dirty="0"/>
-              <a:t> /(&lt;</a:t>
-            </a:r>
-            <a:r>
-              <a:rPr lang="de-DE" dirty="0" err="1"/>
-              <a:t>apigroup</a:t>
-            </a:r>
-            <a:r>
-              <a:rPr lang="de-DE" dirty="0"/>
-              <a:t>&gt;/) </a:t>
-            </a:r>
-            <a:r>
-              <a:rPr lang="de-DE" i="1" dirty="0"/>
-              <a:t>&lt;</a:t>
-            </a:r>
-            <a:r>
-              <a:rPr lang="de-DE" i="1" dirty="0" err="1"/>
-              <a:t>version</a:t>
-            </a:r>
-            <a:r>
-              <a:rPr lang="de-DE" i="1" dirty="0"/>
-              <a:t>&gt; </a:t>
-            </a:r>
-            <a:r>
-              <a:rPr lang="de-DE" dirty="0"/>
+              <a:rPr lang="en-US" i="1" dirty="0"/>
+              <a:t>&lt;resource-type-name&gt; </a:t>
+            </a:r>
+            <a:r>
+              <a:rPr lang="en-US" dirty="0"/>
               <a:t>/ </a:t>
             </a:r>
             <a:r>
-              <a:rPr lang="de-DE" dirty="0" err="1"/>
-              <a:t>namespaces</a:t>
-            </a:r>
-            <a:r>
-              <a:rPr lang="de-DE" dirty="0"/>
-              <a:t> / </a:t>
-            </a:r>
-            <a:r>
-              <a:rPr lang="de-DE" i="1" dirty="0"/>
-              <a:t>&lt;</a:t>
-            </a:r>
-            <a:r>
-              <a:rPr lang="de-DE" i="1" dirty="0" err="1"/>
-              <a:t>ns</a:t>
-            </a:r>
-            <a:r>
-              <a:rPr lang="de-DE" i="1" dirty="0"/>
-              <a:t>&gt; </a:t>
-            </a:r>
-            <a:r>
-              <a:rPr lang="de-DE" dirty="0"/>
+              <a:rPr lang="en-US" i="1" dirty="0"/>
+              <a:t>&lt;resource-name&gt;</a:t>
+            </a:r>
+          </a:p>
+          <a:p>
+            <a:r>
+              <a:rPr lang="en-US" i="1" dirty="0"/>
+              <a:t>	 			            &lt;ns&gt; / &lt;resource-type-name&gt; / &lt;resource-name&gt;</a:t>
+            </a:r>
+          </a:p>
+          <a:p>
+            <a:r>
+              <a:rPr lang="en-US" i="1" dirty="0"/>
+              <a:t>				             &lt;ns&gt; </a:t>
+            </a:r>
+            <a:r>
+              <a:rPr lang="en-US" dirty="0"/>
               <a:t>/ </a:t>
             </a:r>
             <a:r>
-              <a:rPr lang="de-DE" i="1" dirty="0"/>
-              <a:t>&lt;</a:t>
-            </a:r>
-            <a:r>
-              <a:rPr lang="de-DE" i="1" dirty="0" err="1"/>
-              <a:t>resource</a:t>
-            </a:r>
-            <a:r>
-              <a:rPr lang="de-DE" i="1" dirty="0"/>
-              <a:t>-type-name&gt; </a:t>
-            </a:r>
-            <a:r>
-              <a:rPr lang="de-DE" dirty="0"/>
+              <a:rPr lang="en-US" i="1" dirty="0"/>
+              <a:t>&lt;resource-type-name&gt; </a:t>
+            </a:r>
+            <a:r>
+              <a:rPr lang="en-US" dirty="0"/>
               <a:t>/ </a:t>
             </a:r>
             <a:r>
-              <a:rPr lang="de-DE" i="1" dirty="0"/>
-              <a:t>&lt;</a:t>
-            </a:r>
-            <a:r>
-              <a:rPr lang="de-DE" i="1" dirty="0" err="1"/>
-              <a:t>resource</a:t>
-            </a:r>
-            <a:r>
-              <a:rPr lang="de-DE" i="1" dirty="0"/>
-              <a:t>-name&gt;</a:t>
-            </a:r>
-          </a:p>
-          <a:p>
-            <a:r>
-              <a:rPr lang="de-DE" i="1" dirty="0"/>
-              <a:t>	 			            &lt;</a:t>
-            </a:r>
-            <a:r>
-              <a:rPr lang="de-DE" i="1" dirty="0" err="1"/>
-              <a:t>ns</a:t>
-            </a:r>
-            <a:r>
-              <a:rPr lang="de-DE" i="1" dirty="0"/>
-              <a:t>&gt; / &lt;</a:t>
-            </a:r>
-            <a:r>
-              <a:rPr lang="de-DE" i="1" dirty="0" err="1"/>
-              <a:t>resource</a:t>
-            </a:r>
-            <a:r>
-              <a:rPr lang="de-DE" i="1" dirty="0"/>
-              <a:t>-type-name&gt; / &lt;</a:t>
-            </a:r>
-            <a:r>
-              <a:rPr lang="de-DE" i="1" dirty="0" err="1"/>
-              <a:t>resource</a:t>
-            </a:r>
-            <a:r>
-              <a:rPr lang="de-DE" i="1" dirty="0"/>
-              <a:t>-name&gt;</a:t>
-            </a:r>
-          </a:p>
-          <a:p>
-            <a:r>
-              <a:rPr lang="de-DE" i="1" dirty="0"/>
-              <a:t>				             &lt;</a:t>
-            </a:r>
-            <a:r>
-              <a:rPr lang="de-DE" i="1" dirty="0" err="1"/>
-              <a:t>ns</a:t>
-            </a:r>
-            <a:r>
-              <a:rPr lang="de-DE" i="1" dirty="0"/>
-              <a:t>&gt; </a:t>
-            </a:r>
-            <a:r>
-              <a:rPr lang="de-DE" dirty="0"/>
-              <a:t>/ </a:t>
-            </a:r>
-            <a:r>
-              <a:rPr lang="de-DE" i="1" dirty="0"/>
-              <a:t>&lt;</a:t>
-            </a:r>
-            <a:r>
-              <a:rPr lang="de-DE" i="1" dirty="0" err="1"/>
-              <a:t>resource</a:t>
-            </a:r>
-            <a:r>
-              <a:rPr lang="de-DE" i="1" dirty="0"/>
-              <a:t>-type-name&gt; </a:t>
-            </a:r>
-            <a:r>
-              <a:rPr lang="de-DE" dirty="0"/>
-              <a:t>/ </a:t>
-            </a:r>
-            <a:r>
-              <a:rPr lang="de-DE" i="1" dirty="0"/>
-              <a:t>&lt;</a:t>
-            </a:r>
-            <a:r>
-              <a:rPr lang="de-DE" i="1" dirty="0" err="1"/>
-              <a:t>resource</a:t>
-            </a:r>
-            <a:r>
-              <a:rPr lang="de-DE" i="1" dirty="0"/>
-              <a:t>-name&gt;</a:t>
-            </a:r>
-            <a:endParaRPr lang="de-DE" dirty="0"/>
+              <a:rPr lang="en-US" i="1" dirty="0"/>
+              <a:t>&lt;resource-name&gt;</a:t>
+            </a:r>
+            <a:endParaRPr lang="en-US" dirty="0"/>
           </a:p>
         </p:txBody>
       </p:sp>
@@ -31235,14 +30647,9 @@
           <a:lstStyle/>
           <a:p>
             <a:r>
-              <a:rPr lang="de-DE" dirty="0"/>
-              <a:t>API </a:t>
-            </a:r>
-            <a:r>
-              <a:rPr lang="de-DE" dirty="0" err="1"/>
-              <a:t>Structure</a:t>
-            </a:r>
-            <a:endParaRPr lang="de-DE" dirty="0"/>
+              <a:rPr lang="en-US" dirty="0"/>
+              <a:t>API Structure</a:t>
+            </a:r>
           </a:p>
         </p:txBody>
       </p:sp>

</xml_diff>

<commit_message>
improved API (server) explanation
</commit_message>
<xml_diff>
--- a/kubernetes/01_k8s_core_components.pptx
+++ b/kubernetes/01_k8s_core_components.pptx
@@ -5,10 +5,10 @@
     <p:sldMasterId id="2147483733" r:id="rId1"/>
   </p:sldMasterIdLst>
   <p:notesMasterIdLst>
-    <p:notesMasterId r:id="rId20"/>
+    <p:notesMasterId r:id="rId21"/>
   </p:notesMasterIdLst>
   <p:handoutMasterIdLst>
-    <p:handoutMasterId r:id="rId21"/>
+    <p:handoutMasterId r:id="rId22"/>
   </p:handoutMasterIdLst>
   <p:sldIdLst>
     <p:sldId id="433" r:id="rId2"/>
@@ -19,16 +19,17 @@
     <p:sldId id="364" r:id="rId7"/>
     <p:sldId id="468" r:id="rId8"/>
     <p:sldId id="445" r:id="rId9"/>
-    <p:sldId id="448" r:id="rId10"/>
-    <p:sldId id="449" r:id="rId11"/>
-    <p:sldId id="450" r:id="rId12"/>
-    <p:sldId id="439" r:id="rId13"/>
-    <p:sldId id="467" r:id="rId14"/>
-    <p:sldId id="441" r:id="rId15"/>
-    <p:sldId id="440" r:id="rId16"/>
-    <p:sldId id="442" r:id="rId17"/>
-    <p:sldId id="456" r:id="rId18"/>
-    <p:sldId id="265" r:id="rId19"/>
+    <p:sldId id="469" r:id="rId10"/>
+    <p:sldId id="448" r:id="rId11"/>
+    <p:sldId id="449" r:id="rId12"/>
+    <p:sldId id="450" r:id="rId13"/>
+    <p:sldId id="439" r:id="rId14"/>
+    <p:sldId id="467" r:id="rId15"/>
+    <p:sldId id="441" r:id="rId16"/>
+    <p:sldId id="440" r:id="rId17"/>
+    <p:sldId id="442" r:id="rId18"/>
+    <p:sldId id="456" r:id="rId19"/>
+    <p:sldId id="265" r:id="rId20"/>
   </p:sldIdLst>
   <p:sldSz cx="12195175" cy="6858000"/>
   <p:notesSz cx="6858000" cy="9144000"/>
@@ -1154,7 +1155,7 @@
         <a:p>
           <a:r>
             <a:rPr lang="en-US" dirty="0"/>
-            <a:t>Control loops</a:t>
+            <a:t>Control loop</a:t>
           </a:r>
         </a:p>
       </dgm:t>
@@ -1190,7 +1191,7 @@
         <a:p>
           <a:r>
             <a:rPr lang="en-US" dirty="0"/>
-            <a:t>Check API for changes</a:t>
+            <a:t>Watches API for changes</a:t>
           </a:r>
         </a:p>
       </dgm:t>
@@ -1507,14 +1508,14 @@
     <dgm:cxn modelId="{4CC0F50F-E639-46A7-BA9B-C38C48A8E5A7}" type="presOf" srcId="{FB9AAE57-5715-4E83-B795-233F80C28DD5}" destId="{5BFFEAEE-23B1-4DBB-A971-39909A154747}" srcOrd="0" destOrd="0" presId="urn:microsoft.com/office/officeart/2005/8/layout/hProcess4"/>
     <dgm:cxn modelId="{19129A15-A57B-4CA4-956E-3249B877D054}" srcId="{5F7701CA-FAE9-401E-8919-DA68891591F1}" destId="{06A4AA28-4648-46CF-81EC-A9DC778D7A58}" srcOrd="0" destOrd="0" parTransId="{DDE15C73-0CA4-4049-B9B1-41E65338FCA2}" sibTransId="{2DD8EFFD-B8DF-4DDF-B0A0-46123496D507}"/>
     <dgm:cxn modelId="{4D81CC28-0FE3-49F8-8446-3F350EEFCA66}" srcId="{3511B0DC-F6D6-48BD-9E3E-8060DA330747}" destId="{C6CB76E7-A6D6-4352-91C0-0ADD32857D4B}" srcOrd="1" destOrd="0" parTransId="{DC5DAB65-CE0D-449E-8136-60B6B6D7A8C1}" sibTransId="{60AE151D-67FE-4C59-8C08-CD278EDDCF9E}"/>
+    <dgm:cxn modelId="{CD5E4348-559C-4A1D-B671-C271C78CE60C}" type="presOf" srcId="{4DA7C20A-7791-417E-8B3D-4A6E6D60BD33}" destId="{97C182FE-34B2-4A5F-BF6F-C8F658CF5256}" srcOrd="0" destOrd="0" presId="urn:microsoft.com/office/officeart/2005/8/layout/hProcess4"/>
+    <dgm:cxn modelId="{370A7950-74C6-46AC-BD6B-CFC6FA4385FB}" type="presOf" srcId="{06A4AA28-4648-46CF-81EC-A9DC778D7A58}" destId="{76AF6D70-EF0F-4D94-8B10-5B3008C85ED0}" srcOrd="0" destOrd="0" presId="urn:microsoft.com/office/officeart/2005/8/layout/hProcess4"/>
+    <dgm:cxn modelId="{61AA9D58-A016-4FBC-9C02-0633F5D95AC3}" type="presOf" srcId="{5F7701CA-FAE9-401E-8919-DA68891591F1}" destId="{8740B661-5258-4F6A-BBF1-9BC2872E0547}" srcOrd="0" destOrd="0" presId="urn:microsoft.com/office/officeart/2005/8/layout/hProcess4"/>
+    <dgm:cxn modelId="{A6BBB958-741B-42BD-9B0E-CFBC186A3C54}" type="presOf" srcId="{E78D1906-0CE8-4399-8C8D-E3C236BEACE3}" destId="{BDE1A59F-632B-4E78-BDBB-6B8F36D66ACD}" srcOrd="1" destOrd="2" presId="urn:microsoft.com/office/officeart/2005/8/layout/hProcess4"/>
     <dgm:cxn modelId="{2AB9E25B-F590-47F7-B0D3-691E1853FC1F}" type="presOf" srcId="{E78D1906-0CE8-4399-8C8D-E3C236BEACE3}" destId="{2100B73E-41CC-441C-BAC0-823A501FB953}" srcOrd="0" destOrd="2" presId="urn:microsoft.com/office/officeart/2005/8/layout/hProcess4"/>
     <dgm:cxn modelId="{95085E67-5884-441F-B103-8E71061E819E}" type="presOf" srcId="{1E496758-F884-4589-8FBC-E44F78EEE5A6}" destId="{DE045CBA-ECA2-453C-BFCF-A4743461A41D}" srcOrd="0" destOrd="0" presId="urn:microsoft.com/office/officeart/2005/8/layout/hProcess4"/>
-    <dgm:cxn modelId="{CD5E4348-559C-4A1D-B671-C271C78CE60C}" type="presOf" srcId="{4DA7C20A-7791-417E-8B3D-4A6E6D60BD33}" destId="{97C182FE-34B2-4A5F-BF6F-C8F658CF5256}" srcOrd="0" destOrd="0" presId="urn:microsoft.com/office/officeart/2005/8/layout/hProcess4"/>
     <dgm:cxn modelId="{022BC16C-04DC-482D-9D4B-FA96E08F940C}" srcId="{3511B0DC-F6D6-48BD-9E3E-8060DA330747}" destId="{B2CD7ED9-4770-4D36-8561-1FBD7A58A734}" srcOrd="0" destOrd="0" parTransId="{BFC98D57-6DD8-4ED9-AB9C-ACEC6CAD1AC3}" sibTransId="{CA6AF4FE-8A82-4760-8116-56336E1EFEAA}"/>
-    <dgm:cxn modelId="{370A7950-74C6-46AC-BD6B-CFC6FA4385FB}" type="presOf" srcId="{06A4AA28-4648-46CF-81EC-A9DC778D7A58}" destId="{76AF6D70-EF0F-4D94-8B10-5B3008C85ED0}" srcOrd="0" destOrd="0" presId="urn:microsoft.com/office/officeart/2005/8/layout/hProcess4"/>
     <dgm:cxn modelId="{FD2FA777-862B-4D2E-BB7D-92BEC9536E89}" srcId="{5F7701CA-FAE9-401E-8919-DA68891591F1}" destId="{045C94F8-2FB8-4591-9445-135ADC651512}" srcOrd="1" destOrd="0" parTransId="{2DAE4E03-5591-4C7C-AEFB-59F1267FBB7D}" sibTransId="{F0692511-A122-4957-BB26-F4BA9C66E1B7}"/>
-    <dgm:cxn modelId="{61AA9D58-A016-4FBC-9C02-0633F5D95AC3}" type="presOf" srcId="{5F7701CA-FAE9-401E-8919-DA68891591F1}" destId="{8740B661-5258-4F6A-BBF1-9BC2872E0547}" srcOrd="0" destOrd="0" presId="urn:microsoft.com/office/officeart/2005/8/layout/hProcess4"/>
-    <dgm:cxn modelId="{A6BBB958-741B-42BD-9B0E-CFBC186A3C54}" type="presOf" srcId="{E78D1906-0CE8-4399-8C8D-E3C236BEACE3}" destId="{BDE1A59F-632B-4E78-BDBB-6B8F36D66ACD}" srcOrd="1" destOrd="2" presId="urn:microsoft.com/office/officeart/2005/8/layout/hProcess4"/>
     <dgm:cxn modelId="{4BAFAA84-A6FF-4EC7-9584-C02E3A6BB20F}" type="presOf" srcId="{B2CD7ED9-4770-4D36-8561-1FBD7A58A734}" destId="{2100B73E-41CC-441C-BAC0-823A501FB953}" srcOrd="0" destOrd="0" presId="urn:microsoft.com/office/officeart/2005/8/layout/hProcess4"/>
     <dgm:cxn modelId="{3DD8D885-928A-45E9-B1CE-E985BD54F0ED}" type="presOf" srcId="{045C94F8-2FB8-4591-9445-135ADC651512}" destId="{59F1278C-608A-40AD-AE92-1B1BA4D0FD3D}" srcOrd="1" destOrd="1" presId="urn:microsoft.com/office/officeart/2005/8/layout/hProcess4"/>
     <dgm:cxn modelId="{52C41288-D24D-4335-ACEA-B7BB0A819297}" type="presOf" srcId="{3511B0DC-F6D6-48BD-9E3E-8060DA330747}" destId="{77134645-C330-4227-A436-590F23FB91E4}" srcOrd="0" destOrd="0" presId="urn:microsoft.com/office/officeart/2005/8/layout/hProcess4"/>
@@ -1643,7 +1644,7 @@
           </a:pPr>
           <a:r>
             <a:rPr lang="en-US" sz="2500" kern="1200" dirty="0"/>
-            <a:t>Control loops</a:t>
+            <a:t>Control loop</a:t>
           </a:r>
         </a:p>
         <a:p>
@@ -1661,7 +1662,7 @@
           </a:pPr>
           <a:r>
             <a:rPr lang="en-US" sz="2500" kern="1200" dirty="0"/>
-            <a:t>Check API for changes</a:t>
+            <a:t>Watches API for changes</a:t>
           </a:r>
         </a:p>
       </dsp:txBody>
@@ -3835,7 +3836,7 @@
             <a:fld id="{47855BD9-AF71-426C-9B9B-B0E52B88852E}" type="slidenum">
               <a:rPr lang="de-DE" sz="1000" smtClean="0"/>
               <a:pPr algn="ctr"/>
-              <a:t>‹#›</a:t>
+              <a:t>‹Nr.›</a:t>
             </a:fld>
             <a:endParaRPr lang="de-DE" sz="1000" dirty="0"/>
           </a:p>
@@ -3984,7 +3985,7 @@
             <a:fld id="{7D8C2C35-2B8A-446E-BEC0-FD36716C29AC}" type="slidenum">
               <a:rPr lang="de-DE" smtClean="0"/>
               <a:pPr/>
-              <a:t>‹#›</a:t>
+              <a:t>‹Nr.›</a:t>
             </a:fld>
             <a:endParaRPr lang="de-DE" dirty="0"/>
           </a:p>
@@ -4240,87 +4241,99 @@
           <a:lstStyle/>
           <a:p>
             <a:r>
-              <a:rPr lang="en-US" noProof="0" dirty="0"/>
-              <a:t>beta: </a:t>
-            </a:r>
-          </a:p>
-          <a:p>
-            <a:pPr marL="285750" indent="-285750">
-              <a:buFontTx/>
-              <a:buChar char="-"/>
-            </a:pPr>
-            <a:r>
-              <a:rPr lang="en-US" noProof="0" dirty="0"/>
-              <a:t>aims for backwards compatibility, </a:t>
-            </a:r>
-          </a:p>
-          <a:p>
-            <a:pPr marL="285750" indent="-285750">
-              <a:buFontTx/>
-              <a:buChar char="-"/>
-            </a:pPr>
-            <a:r>
-              <a:rPr lang="en-US" noProof="0" dirty="0"/>
-              <a:t>may have bugs</a:t>
-            </a:r>
-          </a:p>
-          <a:p>
-            <a:pPr marL="285750" indent="-285750">
-              <a:buFontTx/>
-              <a:buChar char="-"/>
-            </a:pPr>
-            <a:r>
-              <a:rPr lang="en-US" noProof="0" dirty="0"/>
-              <a:t>used in production with caution</a:t>
-            </a:r>
-          </a:p>
-          <a:p>
-            <a:pPr marL="285750" indent="-285750">
-              <a:buFontTx/>
-              <a:buChar char="-"/>
-            </a:pPr>
-            <a:endParaRPr lang="en-US" noProof="0" dirty="0"/>
-          </a:p>
-          <a:p>
-            <a:pPr marL="0" indent="0">
-              <a:buFontTx/>
-              <a:buNone/>
-            </a:pPr>
-            <a:r>
-              <a:rPr lang="en-US" noProof="0" dirty="0"/>
-              <a:t>v1 / GA:</a:t>
-            </a:r>
-          </a:p>
-          <a:p>
-            <a:pPr marL="285750" indent="-285750">
-              <a:buFontTx/>
-              <a:buChar char="-"/>
-            </a:pPr>
-            <a:r>
-              <a:rPr lang="en-US" noProof="0" dirty="0"/>
-              <a:t>no bugs of course</a:t>
-            </a:r>
-          </a:p>
-          <a:p>
-            <a:pPr marL="285750" indent="-285750">
-              <a:buFontTx/>
-              <a:buChar char="-"/>
-            </a:pPr>
-            <a:r>
-              <a:rPr lang="en-US" noProof="0" dirty="0"/>
-              <a:t>available until deprecated (Kubernetes has a very strictly defined policy for deprecating features, in general 3 releases or max 1 year, see https://kubernetes.io/docs/reference/using-api/</a:t>
-            </a:r>
-            <a:r>
-              <a:rPr lang="en-US" noProof="0"/>
-              <a:t>deprecation-policy/)</a:t>
-            </a:r>
-          </a:p>
-          <a:p>
-            <a:pPr marL="285750" indent="-285750">
-              <a:buFontTx/>
-              <a:buChar char="-"/>
-            </a:pPr>
-            <a:endParaRPr lang="en-US" noProof="0" dirty="0"/>
+              <a:rPr lang="en-US" dirty="0"/>
+              <a:t>The </a:t>
+            </a:r>
+            <a:r>
+              <a:rPr lang="en-US" dirty="0" err="1"/>
+              <a:t>api</a:t>
+            </a:r>
+            <a:r>
+              <a:rPr lang="en-US" dirty="0"/>
+              <a:t> is structured in different groups/version. Within these, namespaces group a set of resources. Within a namespace, names have to be unique.</a:t>
+            </a:r>
+          </a:p>
+          <a:p>
+            <a:endParaRPr lang="en-US" dirty="0"/>
+          </a:p>
+          <a:p>
+            <a:r>
+              <a:rPr lang="en-US" dirty="0"/>
+              <a:t>The core API group, was the first and contains objects like pods or service. Later the API tree was split into topic specific groups to bundle resources e.g. for networking. The core API group hasn’t been touched though.</a:t>
+            </a:r>
+          </a:p>
+          <a:p>
+            <a:endParaRPr lang="en-US" dirty="0"/>
+          </a:p>
+          <a:p>
+            <a:r>
+              <a:rPr lang="en-US" b="1" dirty="0"/>
+              <a:t>Namespace</a:t>
+            </a:r>
+          </a:p>
+          <a:p>
+            <a:pPr lvl="1"/>
+            <a:r>
+              <a:rPr lang="en-US" dirty="0"/>
+              <a:t>Logical realm for applications to run within</a:t>
+            </a:r>
+          </a:p>
+          <a:p>
+            <a:pPr lvl="1"/>
+            <a:r>
+              <a:rPr lang="en-US" dirty="0"/>
+              <a:t>Isolate resources and restrict visibility to objects in the same namespace</a:t>
+            </a:r>
+          </a:p>
+          <a:p>
+            <a:pPr lvl="1"/>
+            <a:r>
+              <a:rPr lang="en-US" dirty="0"/>
+              <a:t>Basic user management is handled on namespace level</a:t>
+            </a:r>
+          </a:p>
+          <a:p>
+            <a:pPr lvl="1"/>
+            <a:r>
+              <a:rPr lang="en-US" dirty="0"/>
+              <a:t>Resource quotas / limits managed per namespace</a:t>
+            </a:r>
+          </a:p>
+          <a:p>
+            <a:pPr lvl="1"/>
+            <a:r>
+              <a:rPr lang="en-US" dirty="0"/>
+              <a:t>Uniqueness of names required per namespace</a:t>
+            </a:r>
+          </a:p>
+          <a:p>
+            <a:pPr lvl="1"/>
+            <a:r>
+              <a:rPr lang="en-US" dirty="0"/>
+              <a:t>Access to services in a different namespace via FQDN &lt;service-name&gt;.&lt;namespace&gt;</a:t>
+            </a:r>
+          </a:p>
+          <a:p>
+            <a:pPr lvl="1"/>
+            <a:r>
+              <a:rPr lang="en-US" dirty="0"/>
+              <a:t>Use –n (--namespace) &lt;namespace&gt; switch with </a:t>
+            </a:r>
+            <a:r>
+              <a:rPr lang="en-US" dirty="0" err="1"/>
+              <a:t>kubectl</a:t>
+            </a:r>
+            <a:r>
+              <a:rPr lang="en-US" dirty="0"/>
+              <a:t> to access resources</a:t>
+            </a:r>
+          </a:p>
+          <a:p>
+            <a:pPr lvl="1"/>
+            <a:endParaRPr lang="en-US" dirty="0"/>
+          </a:p>
+          <a:p>
+            <a:endParaRPr lang="en-US" dirty="0"/>
           </a:p>
         </p:txBody>
       </p:sp>
@@ -4351,7 +4364,7 @@
     </p:spTree>
     <p:extLst>
       <p:ext uri="{BB962C8B-B14F-4D97-AF65-F5344CB8AC3E}">
-        <p14:creationId xmlns:p14="http://schemas.microsoft.com/office/powerpoint/2010/main" val="2368785414"/>
+        <p14:creationId xmlns:p14="http://schemas.microsoft.com/office/powerpoint/2010/main" val="4011559529"/>
       </p:ext>
     </p:extLst>
   </p:cSld>
@@ -4402,176 +4415,91 @@
         </p:nvSpPr>
         <p:spPr/>
         <p:txBody>
-          <a:bodyPr>
-            <a:normAutofit fontScale="92500" lnSpcReduction="20000"/>
-          </a:bodyPr>
+          <a:bodyPr/>
           <a:lstStyle/>
           <a:p>
-            <a:pPr marL="0" lvl="1" indent="0">
+            <a:r>
+              <a:rPr lang="en-US" noProof="0" dirty="0"/>
+              <a:t>beta: </a:t>
+            </a:r>
+          </a:p>
+          <a:p>
+            <a:pPr marL="285750" indent="-285750">
+              <a:buFontTx/>
+              <a:buChar char="-"/>
+            </a:pPr>
+            <a:r>
+              <a:rPr lang="en-US" noProof="0" dirty="0"/>
+              <a:t>aims for backwards compatibility, </a:t>
+            </a:r>
+          </a:p>
+          <a:p>
+            <a:pPr marL="285750" indent="-285750">
+              <a:buFontTx/>
+              <a:buChar char="-"/>
+            </a:pPr>
+            <a:r>
+              <a:rPr lang="en-US" noProof="0" dirty="0"/>
+              <a:t>may have bugs</a:t>
+            </a:r>
+          </a:p>
+          <a:p>
+            <a:pPr marL="285750" indent="-285750">
+              <a:buFontTx/>
+              <a:buChar char="-"/>
+            </a:pPr>
+            <a:r>
+              <a:rPr lang="en-US" noProof="0" dirty="0"/>
+              <a:t>used in production with caution</a:t>
+            </a:r>
+          </a:p>
+          <a:p>
+            <a:pPr marL="285750" indent="-285750">
+              <a:buFontTx/>
+              <a:buChar char="-"/>
+            </a:pPr>
+            <a:endParaRPr lang="en-US" noProof="0" dirty="0"/>
+          </a:p>
+          <a:p>
+            <a:pPr marL="0" indent="0">
+              <a:buFontTx/>
               <a:buNone/>
             </a:pPr>
             <a:r>
-              <a:rPr lang="en-US" b="1" dirty="0"/>
-              <a:t>Basics</a:t>
-            </a:r>
-          </a:p>
-          <a:p>
-            <a:pPr lvl="1"/>
-            <a:r>
-              <a:rPr lang="en-US" dirty="0"/>
-              <a:t>Logical realm for applications to run within</a:t>
-            </a:r>
-          </a:p>
-          <a:p>
-            <a:pPr lvl="1"/>
-            <a:r>
-              <a:rPr lang="en-US" dirty="0"/>
-              <a:t>Isolate resources and restrict visibility to objects in the same namespace</a:t>
-            </a:r>
-          </a:p>
-          <a:p>
-            <a:pPr lvl="1"/>
-            <a:r>
-              <a:rPr lang="en-US" dirty="0"/>
-              <a:t>Basic user management is handled on namespace level</a:t>
-            </a:r>
-          </a:p>
-          <a:p>
-            <a:pPr lvl="1"/>
-            <a:r>
-              <a:rPr lang="en-US" dirty="0"/>
-              <a:t>Resource quotas / limits managed per namespace</a:t>
-            </a:r>
-          </a:p>
-          <a:p>
-            <a:pPr lvl="1"/>
-            <a:r>
-              <a:rPr lang="en-US" dirty="0"/>
-              <a:t>Uniqueness of names required per namespace</a:t>
-            </a:r>
-          </a:p>
-          <a:p>
-            <a:pPr lvl="1"/>
-            <a:r>
-              <a:rPr lang="en-US" dirty="0"/>
-              <a:t>Access to services in a different namespace via FQDN &lt;service-name&gt;.&lt;namespace&gt;</a:t>
-            </a:r>
-          </a:p>
-          <a:p>
-            <a:pPr lvl="1"/>
-            <a:r>
-              <a:rPr lang="en-US" dirty="0"/>
-              <a:t>Use –n (--namespace) &lt;namespace&gt; switch with </a:t>
-            </a:r>
-            <a:r>
-              <a:rPr lang="en-US" dirty="0" err="1"/>
-              <a:t>kubectl</a:t>
-            </a:r>
-            <a:r>
-              <a:rPr lang="en-US" dirty="0"/>
-              <a:t> to access resources</a:t>
-            </a:r>
-          </a:p>
-          <a:p>
-            <a:endParaRPr lang="en-US" dirty="0"/>
-          </a:p>
-          <a:p>
-            <a:r>
-              <a:rPr lang="en-US" b="1" dirty="0" err="1"/>
-              <a:t>Kube</a:t>
-            </a:r>
-            <a:r>
-              <a:rPr lang="en-US" b="1" dirty="0"/>
-              <a:t>-system</a:t>
-            </a:r>
-            <a:r>
-              <a:rPr lang="en-US" dirty="0"/>
-              <a:t>: </a:t>
-            </a:r>
-          </a:p>
-          <a:p>
-            <a:r>
-              <a:rPr lang="en-US" dirty="0"/>
-              <a:t>This namespace usually hosts components which are administrative or should be available as cluster wide services. Typically these are the DNS, network components like the </a:t>
-            </a:r>
-            <a:r>
-              <a:rPr lang="en-US" dirty="0" err="1"/>
-              <a:t>kube</a:t>
-            </a:r>
-            <a:r>
-              <a:rPr lang="en-US" dirty="0"/>
-              <a:t>-proxy &amp; calico or node-exporter (collecting node metrics)… But also addons like the ingress controller are hosted there. </a:t>
-            </a:r>
-            <a:r>
-              <a:rPr lang="en-US" dirty="0" err="1"/>
-              <a:t>Kube</a:t>
-            </a:r>
-            <a:r>
-              <a:rPr lang="en-US" dirty="0"/>
-              <a:t>-system exists in almost all clusters</a:t>
-            </a:r>
-          </a:p>
-          <a:p>
-            <a:endParaRPr lang="en-US" dirty="0"/>
-          </a:p>
-          <a:p>
-            <a:r>
-              <a:rPr lang="en-US" b="1" dirty="0"/>
-              <a:t>Default</a:t>
-            </a:r>
-            <a:r>
-              <a:rPr lang="en-US" dirty="0"/>
-              <a:t>:</a:t>
-            </a:r>
-          </a:p>
-          <a:p>
-            <a:r>
-              <a:rPr lang="en-US" dirty="0"/>
-              <a:t>Is just like any other namespace. However if no namespace target is specified (via </a:t>
-            </a:r>
-            <a:r>
-              <a:rPr lang="en-US" dirty="0" err="1"/>
-              <a:t>kubectl</a:t>
-            </a:r>
-            <a:r>
-              <a:rPr lang="en-US" dirty="0"/>
-              <a:t> -n or within the context of the </a:t>
-            </a:r>
-            <a:r>
-              <a:rPr lang="en-US" dirty="0" err="1"/>
-              <a:t>kube.config</a:t>
-            </a:r>
-            <a:r>
-              <a:rPr lang="en-US" dirty="0"/>
-              <a:t>), the default namespace is targeted. Default exists in almost all clusters.</a:t>
-            </a:r>
-          </a:p>
-          <a:p>
-            <a:endParaRPr lang="en-US" dirty="0"/>
-          </a:p>
-          <a:p>
-            <a:r>
-              <a:rPr lang="en-US" b="1" dirty="0"/>
-              <a:t>Part-0001</a:t>
-            </a:r>
-            <a:r>
-              <a:rPr lang="en-US" dirty="0"/>
-              <a:t>: </a:t>
-            </a:r>
-          </a:p>
-          <a:p>
-            <a:r>
-              <a:rPr lang="en-US" dirty="0"/>
-              <a:t>Participant namespaces are created as part of the training preparation. Each participant gets an individual namespace and the </a:t>
-            </a:r>
-            <a:r>
-              <a:rPr lang="en-US" dirty="0" err="1"/>
-              <a:t>kube.config</a:t>
-            </a:r>
-            <a:r>
-              <a:rPr lang="en-US" dirty="0"/>
-              <a:t> has a corresponding entry in the context section to send all requests to this namespace per default.</a:t>
-            </a:r>
+              <a:rPr lang="en-US" noProof="0" dirty="0"/>
+              <a:t>v1 / GA:</a:t>
+            </a:r>
+          </a:p>
+          <a:p>
+            <a:pPr marL="285750" indent="-285750">
+              <a:buFontTx/>
+              <a:buChar char="-"/>
+            </a:pPr>
+            <a:r>
+              <a:rPr lang="en-US" noProof="0" dirty="0"/>
+              <a:t>no bugs of course</a:t>
+            </a:r>
+          </a:p>
+          <a:p>
+            <a:pPr marL="285750" indent="-285750">
+              <a:buFontTx/>
+              <a:buChar char="-"/>
+            </a:pPr>
+            <a:r>
+              <a:rPr lang="en-US" noProof="0" dirty="0"/>
+              <a:t>available until deprecated (Kubernetes has a very strictly defined policy for deprecating features, in general 3 releases or max 1 year, see https://kubernetes.io/docs/reference/using-api/</a:t>
+            </a:r>
+            <a:r>
+              <a:rPr lang="en-US" noProof="0"/>
+              <a:t>deprecation-policy/)</a:t>
+            </a:r>
+          </a:p>
+          <a:p>
+            <a:pPr marL="285750" indent="-285750">
+              <a:buFontTx/>
+              <a:buChar char="-"/>
+            </a:pPr>
+            <a:endParaRPr lang="en-US" noProof="0" dirty="0"/>
           </a:p>
         </p:txBody>
       </p:sp>
@@ -4602,7 +4530,7 @@
     </p:spTree>
     <p:extLst>
       <p:ext uri="{BB962C8B-B14F-4D97-AF65-F5344CB8AC3E}">
-        <p14:creationId xmlns:p14="http://schemas.microsoft.com/office/powerpoint/2010/main" val="333919709"/>
+        <p14:creationId xmlns:p14="http://schemas.microsoft.com/office/powerpoint/2010/main" val="2368785414"/>
       </p:ext>
     </p:extLst>
   </p:cSld>
@@ -4653,12 +4581,66 @@
         </p:nvSpPr>
         <p:spPr/>
         <p:txBody>
-          <a:bodyPr/>
+          <a:bodyPr>
+            <a:normAutofit fontScale="92500" lnSpcReduction="20000"/>
+          </a:bodyPr>
           <a:lstStyle/>
           <a:p>
-            <a:r>
-              <a:rPr lang="en-US" dirty="0"/>
-              <a:t>The </a:t>
+            <a:pPr marL="0" lvl="1" indent="0">
+              <a:buNone/>
+            </a:pPr>
+            <a:r>
+              <a:rPr lang="en-US" b="1" dirty="0"/>
+              <a:t>Basics</a:t>
+            </a:r>
+          </a:p>
+          <a:p>
+            <a:pPr lvl="1"/>
+            <a:r>
+              <a:rPr lang="en-US" dirty="0"/>
+              <a:t>Logical realm for applications to run within</a:t>
+            </a:r>
+          </a:p>
+          <a:p>
+            <a:pPr lvl="1"/>
+            <a:r>
+              <a:rPr lang="en-US" dirty="0"/>
+              <a:t>Isolate resources and restrict visibility to objects in the same namespace</a:t>
+            </a:r>
+          </a:p>
+          <a:p>
+            <a:pPr lvl="1"/>
+            <a:r>
+              <a:rPr lang="en-US" dirty="0"/>
+              <a:t>Basic user management is handled on namespace level</a:t>
+            </a:r>
+          </a:p>
+          <a:p>
+            <a:pPr lvl="1"/>
+            <a:r>
+              <a:rPr lang="en-US" dirty="0"/>
+              <a:t>Resource quotas / limits managed per namespace</a:t>
+            </a:r>
+          </a:p>
+          <a:p>
+            <a:pPr lvl="1"/>
+            <a:r>
+              <a:rPr lang="en-US" dirty="0"/>
+              <a:t>Uniqueness of names required per namespace</a:t>
+            </a:r>
+          </a:p>
+          <a:p>
+            <a:pPr lvl="1"/>
+            <a:r>
+              <a:rPr lang="en-US" dirty="0"/>
+              <a:t>Access to services in a different namespace via FQDN &lt;service-name&gt;.&lt;namespace&gt;</a:t>
+            </a:r>
+          </a:p>
+          <a:p>
+            <a:pPr lvl="1"/>
+            <a:r>
+              <a:rPr lang="en-US" dirty="0"/>
+              <a:t>Use –n (--namespace) &lt;namespace&gt; switch with </a:t>
             </a:r>
             <a:r>
               <a:rPr lang="en-US" dirty="0" err="1"/>
@@ -4666,7 +4648,7 @@
             </a:r>
             <a:r>
               <a:rPr lang="en-US" dirty="0"/>
-              <a:t> binary allows to access the API in an easy way to get information or modify resources.</a:t>
+              <a:t> to access resources</a:t>
             </a:r>
           </a:p>
           <a:p>
@@ -4674,18 +4656,47 @@
           </a:p>
           <a:p>
             <a:r>
-              <a:rPr lang="en-US" dirty="0"/>
-              <a:t>It uses a config file to know, which API server to talk to and how to authenticate requests. Of course you can have multiple config files and switch between them.</a:t>
-            </a:r>
-          </a:p>
-          <a:p>
-            <a:r>
-              <a:rPr lang="en-US" dirty="0"/>
-              <a:t>Following ways exist to make use of a </a:t>
+              <a:rPr lang="en-US" b="1" dirty="0" err="1"/>
+              <a:t>Kube</a:t>
+            </a:r>
+            <a:r>
+              <a:rPr lang="en-US" b="1" dirty="0"/>
+              <a:t>-system</a:t>
+            </a:r>
+            <a:r>
+              <a:rPr lang="en-US" dirty="0"/>
+              <a:t>: </a:t>
+            </a:r>
+          </a:p>
+          <a:p>
+            <a:r>
+              <a:rPr lang="en-US" dirty="0"/>
+              <a:t>This namespace usually hosts components which are administrative or should be available as cluster wide services. Typically these are the DNS, network components like the </a:t>
             </a:r>
             <a:r>
               <a:rPr lang="en-US" dirty="0" err="1"/>
-              <a:t>kubeconfig</a:t>
+              <a:t>kube</a:t>
+            </a:r>
+            <a:r>
+              <a:rPr lang="en-US" dirty="0"/>
+              <a:t>-proxy &amp; calico or node-exporter (collecting node metrics)… But also addons like the ingress controller are hosted there. </a:t>
+            </a:r>
+            <a:r>
+              <a:rPr lang="en-US" dirty="0" err="1"/>
+              <a:t>Kube</a:t>
+            </a:r>
+            <a:r>
+              <a:rPr lang="en-US" dirty="0"/>
+              <a:t>-system exists in almost all clusters</a:t>
+            </a:r>
+          </a:p>
+          <a:p>
+            <a:endParaRPr lang="en-US" dirty="0"/>
+          </a:p>
+          <a:p>
+            <a:r>
+              <a:rPr lang="en-US" b="1" dirty="0"/>
+              <a:t>Default</a:t>
             </a:r>
             <a:r>
               <a:rPr lang="en-US" dirty="0"/>
@@ -4695,15 +4706,7 @@
           <a:p>
             <a:r>
               <a:rPr lang="en-US" dirty="0"/>
-              <a:t>- Specify --</a:t>
-            </a:r>
-            <a:r>
-              <a:rPr lang="en-US" dirty="0" err="1"/>
-              <a:t>kubeconfig</a:t>
-            </a:r>
-            <a:r>
-              <a:rPr lang="en-US" dirty="0"/>
-              <a:t>=&lt;config file&gt; flag for each </a:t>
+              <a:t>Is just like any other namespace. However if no namespace target is specified (via </a:t>
             </a:r>
             <a:r>
               <a:rPr lang="en-US" dirty="0" err="1"/>
@@ -4711,58 +4714,42 @@
             </a:r>
             <a:r>
               <a:rPr lang="en-US" dirty="0"/>
-              <a:t> command</a:t>
-            </a:r>
-          </a:p>
-          <a:p>
-            <a:r>
-              <a:rPr lang="en-US" dirty="0"/>
-              <a:t>- Export an environment variable KUBECONFIG pointing to one or many config files. In case of multiple files, use </a:t>
+              <a:t> -n or within the context of the </a:t>
             </a:r>
             <a:r>
               <a:rPr lang="en-US" dirty="0" err="1"/>
-              <a:t>kubectl</a:t>
-            </a:r>
-            <a:r>
-              <a:rPr lang="en-US" dirty="0"/>
-              <a:t> config use-context &lt;context-name&gt; to activate a </a:t>
+              <a:t>kube.config</a:t>
+            </a:r>
+            <a:r>
+              <a:rPr lang="en-US" dirty="0"/>
+              <a:t>), the default namespace is targeted. Default exists in almost all clusters.</a:t>
+            </a:r>
+          </a:p>
+          <a:p>
+            <a:endParaRPr lang="en-US" dirty="0"/>
+          </a:p>
+          <a:p>
+            <a:r>
+              <a:rPr lang="en-US" b="1" dirty="0"/>
+              <a:t>Part-0001</a:t>
+            </a:r>
+            <a:r>
+              <a:rPr lang="en-US" dirty="0"/>
+              <a:t>: </a:t>
+            </a:r>
+          </a:p>
+          <a:p>
+            <a:r>
+              <a:rPr lang="en-US" dirty="0"/>
+              <a:t>Participant namespaces are created as part of the training preparation. Each participant gets an individual namespace and the </a:t>
             </a:r>
             <a:r>
               <a:rPr lang="en-US" dirty="0" err="1"/>
-              <a:t>specifc</a:t>
-            </a:r>
-            <a:endParaRPr lang="en-US" dirty="0"/>
-          </a:p>
-          <a:p>
-            <a:r>
-              <a:rPr lang="en-US" dirty="0"/>
-              <a:t>- The default location of the file: ~/.</a:t>
-            </a:r>
-            <a:r>
-              <a:rPr lang="en-US" dirty="0" err="1"/>
-              <a:t>kube</a:t>
-            </a:r>
-            <a:r>
-              <a:rPr lang="en-US" dirty="0"/>
-              <a:t>/config</a:t>
-            </a:r>
-          </a:p>
-          <a:p>
-            <a:endParaRPr lang="en-US" dirty="0"/>
-          </a:p>
-          <a:p>
-            <a:r>
-              <a:rPr lang="en-US" dirty="0"/>
-              <a:t>The syntax follow an intuitive pattern – firstly, specify a command (what to do) and then add parameters which contain details of what to do. Then, add flags to modify the way it is done.</a:t>
-            </a:r>
-          </a:p>
-          <a:p>
-            <a:endParaRPr lang="en-US" dirty="0"/>
-          </a:p>
-          <a:p>
-            <a:r>
-              <a:rPr lang="en-US" dirty="0"/>
-              <a:t>Usually, the command is a verb and the parameters specify a resource type (like “node”) and then depending on the command a specific resource by name (sometimes optional)</a:t>
+              <a:t>kube.config</a:t>
+            </a:r>
+            <a:r>
+              <a:rPr lang="en-US" dirty="0"/>
+              <a:t> has a corresponding entry in the context section to send all requests to this namespace per default.</a:t>
             </a:r>
           </a:p>
         </p:txBody>
@@ -4774,7 +4761,7 @@
             <a:spLocks noGrp="1"/>
           </p:cNvSpPr>
           <p:nvPr>
-            <p:ph type="sldNum" sz="quarter" idx="5"/>
+            <p:ph type="sldNum" sz="quarter" idx="10"/>
           </p:nvPr>
         </p:nvSpPr>
         <p:spPr/>
@@ -4785,7 +4772,7 @@
             <a:fld id="{7D8C2C35-2B8A-446E-BEC0-FD36716C29AC}" type="slidenum">
               <a:rPr lang="de-DE" smtClean="0"/>
               <a:pPr/>
-              <a:t>13</a:t>
+              <a:t>12</a:t>
             </a:fld>
             <a:endParaRPr lang="de-DE" dirty="0"/>
           </a:p>
@@ -4794,7 +4781,7 @@
     </p:spTree>
     <p:extLst>
       <p:ext uri="{BB962C8B-B14F-4D97-AF65-F5344CB8AC3E}">
-        <p14:creationId xmlns:p14="http://schemas.microsoft.com/office/powerpoint/2010/main" val="2875379522"/>
+        <p14:creationId xmlns:p14="http://schemas.microsoft.com/office/powerpoint/2010/main" val="333919709"/>
       </p:ext>
     </p:extLst>
   </p:cSld>
@@ -4848,7 +4835,114 @@
           <a:bodyPr/>
           <a:lstStyle/>
           <a:p>
+            <a:r>
+              <a:rPr lang="en-US" dirty="0"/>
+              <a:t>The </a:t>
+            </a:r>
+            <a:r>
+              <a:rPr lang="en-US" dirty="0" err="1"/>
+              <a:t>kubectl</a:t>
+            </a:r>
+            <a:r>
+              <a:rPr lang="en-US" dirty="0"/>
+              <a:t> binary allows to access the API in an easy way to get information or modify resources.</a:t>
+            </a:r>
+          </a:p>
+          <a:p>
             <a:endParaRPr lang="en-US" dirty="0"/>
+          </a:p>
+          <a:p>
+            <a:r>
+              <a:rPr lang="en-US" dirty="0"/>
+              <a:t>It uses a config file to know, which API server to talk to and how to authenticate requests. Of course you can have multiple config files and switch between them.</a:t>
+            </a:r>
+          </a:p>
+          <a:p>
+            <a:r>
+              <a:rPr lang="en-US" dirty="0"/>
+              <a:t>Following ways exist to make use of a </a:t>
+            </a:r>
+            <a:r>
+              <a:rPr lang="en-US" dirty="0" err="1"/>
+              <a:t>kubeconfig</a:t>
+            </a:r>
+            <a:r>
+              <a:rPr lang="en-US" dirty="0"/>
+              <a:t>:</a:t>
+            </a:r>
+          </a:p>
+          <a:p>
+            <a:r>
+              <a:rPr lang="en-US" dirty="0"/>
+              <a:t>- Specify --</a:t>
+            </a:r>
+            <a:r>
+              <a:rPr lang="en-US" dirty="0" err="1"/>
+              <a:t>kubeconfig</a:t>
+            </a:r>
+            <a:r>
+              <a:rPr lang="en-US" dirty="0"/>
+              <a:t>=&lt;config file&gt; flag for each </a:t>
+            </a:r>
+            <a:r>
+              <a:rPr lang="en-US" dirty="0" err="1"/>
+              <a:t>kubectl</a:t>
+            </a:r>
+            <a:r>
+              <a:rPr lang="en-US" dirty="0"/>
+              <a:t> command</a:t>
+            </a:r>
+          </a:p>
+          <a:p>
+            <a:r>
+              <a:rPr lang="en-US" dirty="0"/>
+              <a:t>- Export an environment variable KUBECONFIG pointing to one or many config files. In case of multiple files, use </a:t>
+            </a:r>
+            <a:r>
+              <a:rPr lang="en-US" dirty="0" err="1"/>
+              <a:t>kubectl</a:t>
+            </a:r>
+            <a:r>
+              <a:rPr lang="en-US" dirty="0"/>
+              <a:t> config use-context &lt;context-name&gt; to activate a </a:t>
+            </a:r>
+            <a:r>
+              <a:rPr lang="en-US" dirty="0" err="1"/>
+              <a:t>specifc</a:t>
+            </a:r>
+            <a:endParaRPr lang="en-US" dirty="0"/>
+          </a:p>
+          <a:p>
+            <a:r>
+              <a:rPr lang="en-US" dirty="0"/>
+              <a:t>- The default location of the file: ~/.</a:t>
+            </a:r>
+            <a:r>
+              <a:rPr lang="en-US" dirty="0" err="1"/>
+              <a:t>kube</a:t>
+            </a:r>
+            <a:r>
+              <a:rPr lang="en-US" dirty="0"/>
+              <a:t>/config</a:t>
+            </a:r>
+          </a:p>
+          <a:p>
+            <a:endParaRPr lang="en-US" dirty="0"/>
+          </a:p>
+          <a:p>
+            <a:r>
+              <a:rPr lang="en-US" dirty="0"/>
+              <a:t>The syntax follow an intuitive pattern – firstly, specify a command (what to do) and then add parameters which contain details of what to do. Then, add flags to modify the way it is done.</a:t>
+            </a:r>
+          </a:p>
+          <a:p>
+            <a:endParaRPr lang="en-US" dirty="0"/>
+          </a:p>
+          <a:p>
+            <a:r>
+              <a:rPr lang="en-US" dirty="0"/>
+              <a:t>Usually, the command is a verb and the parameters specify a resource type (like “node”) and then depending on the command a specific resource by name (sometimes optional)</a:t>
+            </a:r>
           </a:p>
         </p:txBody>
       </p:sp>
@@ -4879,7 +4973,7 @@
     </p:spTree>
     <p:extLst>
       <p:ext uri="{BB962C8B-B14F-4D97-AF65-F5344CB8AC3E}">
-        <p14:creationId xmlns:p14="http://schemas.microsoft.com/office/powerpoint/2010/main" val="1524975748"/>
+        <p14:creationId xmlns:p14="http://schemas.microsoft.com/office/powerpoint/2010/main" val="2875379522"/>
       </p:ext>
     </p:extLst>
   </p:cSld>
@@ -4930,462 +5024,10 @@
         </p:nvSpPr>
         <p:spPr/>
         <p:txBody>
-          <a:bodyPr>
-            <a:normAutofit fontScale="85000" lnSpcReduction="10000"/>
-          </a:bodyPr>
+          <a:bodyPr/>
           <a:lstStyle/>
           <a:p>
-            <a:pPr marL="342900" indent="-342900">
-              <a:buSzPct val="100000"/>
-              <a:buFont typeface="Wingdings" panose="05000000000000000000" pitchFamily="2" charset="2"/>
-              <a:buChar char="§"/>
-            </a:pPr>
-            <a:r>
-              <a:rPr lang="en-US" dirty="0"/>
-              <a:t>Call </a:t>
-            </a:r>
-            <a:r>
-              <a:rPr lang="en-US" dirty="0" err="1"/>
-              <a:t>kubectl</a:t>
-            </a:r>
-            <a:r>
-              <a:rPr lang="en-US" dirty="0"/>
-              <a:t> without any sub-command and explain how to get more info </a:t>
-            </a:r>
-          </a:p>
-          <a:p>
-            <a:pPr marL="180000" lvl="1" indent="0">
-              <a:buSzPct val="100000"/>
-              <a:buFont typeface="Wingdings" panose="05000000000000000000" pitchFamily="2" charset="2"/>
-              <a:buNone/>
-            </a:pPr>
             <a:endParaRPr lang="en-US" dirty="0"/>
-          </a:p>
-          <a:p>
-            <a:pPr marL="342900" indent="-342900">
-              <a:buSzPct val="100000"/>
-              <a:buFont typeface="Wingdings" panose="05000000000000000000" pitchFamily="2" charset="2"/>
-              <a:buChar char="§"/>
-            </a:pPr>
-            <a:r>
-              <a:rPr lang="en-US" dirty="0"/>
-              <a:t>Show access to cluster with </a:t>
-            </a:r>
-            <a:r>
-              <a:rPr lang="en-US" dirty="0" err="1"/>
-              <a:t>kubectl</a:t>
-            </a:r>
-            <a:r>
-              <a:rPr lang="en-US" dirty="0"/>
-              <a:t> -&gt; </a:t>
-            </a:r>
-            <a:r>
-              <a:rPr lang="en-US" dirty="0" err="1"/>
-              <a:t>kubectl</a:t>
-            </a:r>
-            <a:r>
-              <a:rPr lang="en-US" dirty="0"/>
-              <a:t> get nodes</a:t>
-            </a:r>
-          </a:p>
-          <a:p>
-            <a:pPr marL="342900" indent="-342900">
-              <a:buSzPct val="100000"/>
-              <a:buFont typeface="Wingdings" panose="05000000000000000000" pitchFamily="2" charset="2"/>
-              <a:buChar char="§"/>
-            </a:pPr>
-            <a:r>
-              <a:rPr lang="en-US" dirty="0"/>
-              <a:t>Explain basic syntax of </a:t>
-            </a:r>
-            <a:r>
-              <a:rPr lang="en-US" dirty="0" err="1"/>
-              <a:t>kubectl</a:t>
-            </a:r>
-            <a:r>
-              <a:rPr lang="en-US" dirty="0"/>
-              <a:t> [verb] [resource type] [specific resource by name or label] [options / switches like –o </a:t>
-            </a:r>
-            <a:r>
-              <a:rPr lang="en-US" dirty="0" err="1"/>
-              <a:t>yaml</a:t>
-            </a:r>
-            <a:r>
-              <a:rPr lang="en-US" dirty="0"/>
-              <a:t>]</a:t>
-            </a:r>
-          </a:p>
-          <a:p>
-            <a:pPr marL="342900" marR="0" lvl="0" indent="-342900" algn="l" defTabSz="1088776" rtl="0" eaLnBrk="1" fontAlgn="auto" latinLnBrk="0" hangingPunct="1">
-              <a:lnSpc>
-                <a:spcPct val="100000"/>
-              </a:lnSpc>
-              <a:spcBef>
-                <a:spcPts val="0"/>
-              </a:spcBef>
-              <a:spcAft>
-                <a:spcPts val="0"/>
-              </a:spcAft>
-              <a:buClrTx/>
-              <a:buSzPct val="100000"/>
-              <a:buFont typeface="Wingdings" panose="05000000000000000000" pitchFamily="2" charset="2"/>
-              <a:buChar char="§"/>
-              <a:tabLst/>
-              <a:defRPr/>
-            </a:pPr>
-            <a:r>
-              <a:rPr lang="en-US" dirty="0"/>
-              <a:t>Show </a:t>
-            </a:r>
-            <a:r>
-              <a:rPr lang="en-US" dirty="0" err="1"/>
-              <a:t>kubectl</a:t>
-            </a:r>
-            <a:r>
-              <a:rPr lang="en-US" dirty="0"/>
-              <a:t> get &amp; describe nodes and talk about details of the node, like resource utilization or docker version</a:t>
-            </a:r>
-          </a:p>
-          <a:p>
-            <a:pPr marL="342900" marR="0" lvl="0" indent="-342900" algn="l" defTabSz="1088776" rtl="0" eaLnBrk="1" fontAlgn="auto" latinLnBrk="0" hangingPunct="1">
-              <a:lnSpc>
-                <a:spcPct val="100000"/>
-              </a:lnSpc>
-              <a:spcBef>
-                <a:spcPts val="0"/>
-              </a:spcBef>
-              <a:spcAft>
-                <a:spcPts val="0"/>
-              </a:spcAft>
-              <a:buClrTx/>
-              <a:buSzPct val="100000"/>
-              <a:buFont typeface="Wingdings" panose="05000000000000000000" pitchFamily="2" charset="2"/>
-              <a:buChar char="§"/>
-              <a:tabLst/>
-              <a:defRPr/>
-            </a:pPr>
-            <a:endParaRPr lang="en-US" dirty="0"/>
-          </a:p>
-          <a:p>
-            <a:pPr marL="342900" indent="-342900">
-              <a:buSzPct val="100000"/>
-              <a:buFont typeface="Wingdings" panose="05000000000000000000" pitchFamily="2" charset="2"/>
-              <a:buChar char="§"/>
-            </a:pPr>
-            <a:r>
-              <a:rPr lang="en-US" dirty="0"/>
-              <a:t>Show and explain </a:t>
-            </a:r>
-            <a:r>
-              <a:rPr lang="en-US" dirty="0" err="1"/>
-              <a:t>kubectl</a:t>
-            </a:r>
-            <a:r>
-              <a:rPr lang="en-US" dirty="0"/>
-              <a:t> config *</a:t>
-            </a:r>
-          </a:p>
-          <a:p>
-            <a:pPr marL="522900" lvl="1" indent="-342900">
-              <a:buSzPct val="100000"/>
-              <a:buFont typeface="Wingdings" panose="05000000000000000000" pitchFamily="2" charset="2"/>
-              <a:buChar char="§"/>
-            </a:pPr>
-            <a:r>
-              <a:rPr lang="en-US" dirty="0"/>
-              <a:t>Explain KUBECONFIG env variable &amp; the default location ~/.</a:t>
-            </a:r>
-            <a:r>
-              <a:rPr lang="en-US" dirty="0" err="1"/>
-              <a:t>kube</a:t>
-            </a:r>
-            <a:r>
-              <a:rPr lang="en-US" dirty="0"/>
-              <a:t>/config</a:t>
-            </a:r>
-          </a:p>
-          <a:p>
-            <a:pPr marL="522900" lvl="1" indent="-342900">
-              <a:buSzPct val="100000"/>
-              <a:buFont typeface="Wingdings" panose="05000000000000000000" pitchFamily="2" charset="2"/>
-              <a:buChar char="§"/>
-            </a:pPr>
-            <a:r>
-              <a:rPr lang="en-US" dirty="0"/>
-              <a:t>Show the </a:t>
-            </a:r>
-            <a:r>
-              <a:rPr lang="en-US" dirty="0" err="1"/>
-              <a:t>kubeconfig</a:t>
-            </a:r>
-            <a:r>
-              <a:rPr lang="en-US" dirty="0"/>
-              <a:t> </a:t>
-            </a:r>
-            <a:r>
-              <a:rPr lang="en-US" dirty="0" err="1"/>
-              <a:t>yaml</a:t>
-            </a:r>
-            <a:r>
-              <a:rPr lang="en-US" dirty="0"/>
-              <a:t> file with the current context and the namespace</a:t>
-            </a:r>
-          </a:p>
-          <a:p>
-            <a:pPr marL="342900" marR="0" lvl="0" indent="-342900" algn="l" defTabSz="1088776" rtl="0" eaLnBrk="1" fontAlgn="auto" latinLnBrk="0" hangingPunct="1">
-              <a:lnSpc>
-                <a:spcPct val="100000"/>
-              </a:lnSpc>
-              <a:spcBef>
-                <a:spcPts val="0"/>
-              </a:spcBef>
-              <a:spcAft>
-                <a:spcPts val="0"/>
-              </a:spcAft>
-              <a:buClrTx/>
-              <a:buSzPct val="100000"/>
-              <a:buFont typeface="Wingdings" panose="05000000000000000000" pitchFamily="2" charset="2"/>
-              <a:buChar char="§"/>
-              <a:tabLst/>
-              <a:defRPr/>
-            </a:pPr>
-            <a:endParaRPr lang="en-US" dirty="0"/>
-          </a:p>
-          <a:p>
-            <a:pPr marL="342900" marR="0" lvl="0" indent="-342900" algn="l" defTabSz="1088776" rtl="0" eaLnBrk="1" fontAlgn="auto" latinLnBrk="0" hangingPunct="1">
-              <a:lnSpc>
-                <a:spcPct val="100000"/>
-              </a:lnSpc>
-              <a:spcBef>
-                <a:spcPts val="0"/>
-              </a:spcBef>
-              <a:spcAft>
-                <a:spcPts val="0"/>
-              </a:spcAft>
-              <a:buClrTx/>
-              <a:buSzPct val="100000"/>
-              <a:buFont typeface="Wingdings" panose="05000000000000000000" pitchFamily="2" charset="2"/>
-              <a:buChar char="§"/>
-              <a:tabLst/>
-              <a:defRPr/>
-            </a:pPr>
-            <a:r>
-              <a:rPr lang="en-US" dirty="0"/>
-              <a:t>Show all namespaces in cluster, if not yet mentioned, explain that everyone has their own namespace. Please be a good citizen and don’t sabotage the others.</a:t>
-            </a:r>
-          </a:p>
-          <a:p>
-            <a:pPr marL="342900" marR="0" lvl="0" indent="-342900" algn="l" defTabSz="1088776" rtl="0" eaLnBrk="1" fontAlgn="auto" latinLnBrk="0" hangingPunct="1">
-              <a:lnSpc>
-                <a:spcPct val="100000"/>
-              </a:lnSpc>
-              <a:spcBef>
-                <a:spcPts val="0"/>
-              </a:spcBef>
-              <a:spcAft>
-                <a:spcPts val="0"/>
-              </a:spcAft>
-              <a:buClrTx/>
-              <a:buSzPct val="100000"/>
-              <a:buFont typeface="Wingdings" panose="05000000000000000000" pitchFamily="2" charset="2"/>
-              <a:buChar char="§"/>
-              <a:tabLst/>
-              <a:defRPr/>
-            </a:pPr>
-            <a:r>
-              <a:rPr lang="en-US" dirty="0"/>
-              <a:t>Query a pod from a dedicated namespace ( e.g. </a:t>
-            </a:r>
-            <a:r>
-              <a:rPr lang="en-US" dirty="0" err="1"/>
-              <a:t>kube</a:t>
-            </a:r>
-            <a:r>
-              <a:rPr lang="en-US" dirty="0"/>
-              <a:t>-system), explain “-n &lt;namespace&gt;” flag</a:t>
-            </a:r>
-          </a:p>
-          <a:p>
-            <a:pPr marL="342900" marR="0" lvl="0" indent="-342900" algn="l" defTabSz="1088776" rtl="0" eaLnBrk="1" fontAlgn="auto" latinLnBrk="0" hangingPunct="1">
-              <a:lnSpc>
-                <a:spcPct val="100000"/>
-              </a:lnSpc>
-              <a:spcBef>
-                <a:spcPts val="0"/>
-              </a:spcBef>
-              <a:spcAft>
-                <a:spcPts val="0"/>
-              </a:spcAft>
-              <a:buClrTx/>
-              <a:buSzPct val="100000"/>
-              <a:buFont typeface="Wingdings" panose="05000000000000000000" pitchFamily="2" charset="2"/>
-              <a:buChar char="§"/>
-              <a:tabLst/>
-              <a:defRPr/>
-            </a:pPr>
-            <a:endParaRPr lang="en-US" dirty="0"/>
-          </a:p>
-          <a:p>
-            <a:pPr marL="342900" marR="0" lvl="0" indent="-342900" algn="l" defTabSz="1088776" rtl="0" eaLnBrk="1" fontAlgn="auto" latinLnBrk="0" hangingPunct="1">
-              <a:lnSpc>
-                <a:spcPct val="100000"/>
-              </a:lnSpc>
-              <a:spcBef>
-                <a:spcPts val="0"/>
-              </a:spcBef>
-              <a:spcAft>
-                <a:spcPts val="0"/>
-              </a:spcAft>
-              <a:buClrTx/>
-              <a:buSzPct val="100000"/>
-              <a:buFont typeface="Wingdings" panose="05000000000000000000" pitchFamily="2" charset="2"/>
-              <a:buChar char="§"/>
-              <a:tabLst/>
-              <a:defRPr/>
-            </a:pPr>
-            <a:r>
-              <a:rPr lang="en-US" dirty="0"/>
-              <a:t>Run </a:t>
-            </a:r>
-            <a:r>
-              <a:rPr lang="en-US" dirty="0" err="1"/>
-              <a:t>kubectl</a:t>
-            </a:r>
-            <a:r>
-              <a:rPr lang="en-US" dirty="0"/>
-              <a:t> proxy &amp;</a:t>
-            </a:r>
-          </a:p>
-          <a:p>
-            <a:pPr marL="342900" marR="0" lvl="0" indent="-342900" algn="l" defTabSz="1088776" rtl="0" eaLnBrk="1" fontAlgn="auto" latinLnBrk="0" hangingPunct="1">
-              <a:lnSpc>
-                <a:spcPct val="100000"/>
-              </a:lnSpc>
-              <a:spcBef>
-                <a:spcPts val="0"/>
-              </a:spcBef>
-              <a:spcAft>
-                <a:spcPts val="0"/>
-              </a:spcAft>
-              <a:buClrTx/>
-              <a:buSzPct val="100000"/>
-              <a:buFont typeface="Wingdings" panose="05000000000000000000" pitchFamily="2" charset="2"/>
-              <a:buChar char="§"/>
-              <a:tabLst/>
-              <a:defRPr/>
-            </a:pPr>
-            <a:r>
-              <a:rPr lang="en-US" dirty="0"/>
-              <a:t>Open localhost:8001 in browser and show </a:t>
-            </a:r>
-            <a:r>
-              <a:rPr lang="en-US" dirty="0" err="1"/>
-              <a:t>api</a:t>
-            </a:r>
-            <a:r>
-              <a:rPr lang="en-US" dirty="0"/>
-              <a:t> tree, traverse through it and go to namespace </a:t>
-            </a:r>
-            <a:r>
-              <a:rPr lang="en-US" dirty="0" err="1"/>
-              <a:t>kube</a:t>
-            </a:r>
-            <a:r>
-              <a:rPr lang="en-US" dirty="0"/>
-              <a:t>-system and show some pods</a:t>
-            </a:r>
-          </a:p>
-          <a:p>
-            <a:pPr marL="342900" indent="-342900">
-              <a:buSzPct val="100000"/>
-              <a:buFont typeface="Wingdings" panose="05000000000000000000" pitchFamily="2" charset="2"/>
-              <a:buChar char="§"/>
-            </a:pPr>
-            <a:r>
-              <a:rPr lang="en-US" dirty="0"/>
-              <a:t>Query API server with curl (again via localhost)</a:t>
-            </a:r>
-          </a:p>
-          <a:p>
-            <a:pPr marL="342900" indent="-342900">
-              <a:buSzPct val="100000"/>
-              <a:buFont typeface="Wingdings" panose="05000000000000000000" pitchFamily="2" charset="2"/>
-              <a:buChar char="§"/>
-            </a:pPr>
-            <a:r>
-              <a:rPr lang="en-US" dirty="0"/>
-              <a:t>If you have </a:t>
-            </a:r>
-            <a:r>
-              <a:rPr lang="en-US" dirty="0" err="1"/>
-              <a:t>kubectl</a:t>
-            </a:r>
-            <a:r>
-              <a:rPr lang="en-US" dirty="0"/>
-              <a:t> version v1.11 or higher:</a:t>
-            </a:r>
-          </a:p>
-          <a:p>
-            <a:pPr marL="522900" lvl="1" indent="-342900">
-              <a:buSzPct val="100000"/>
-              <a:buFont typeface="Wingdings" panose="05000000000000000000" pitchFamily="2" charset="2"/>
-              <a:buChar char="§"/>
-            </a:pPr>
-            <a:r>
-              <a:rPr lang="en-US" dirty="0"/>
-              <a:t>Show </a:t>
-            </a:r>
-            <a:r>
-              <a:rPr lang="en-US" dirty="0" err="1"/>
-              <a:t>kubectl</a:t>
-            </a:r>
-            <a:r>
-              <a:rPr lang="en-US" dirty="0"/>
-              <a:t> </a:t>
-            </a:r>
-            <a:r>
-              <a:rPr lang="en-US" dirty="0" err="1"/>
-              <a:t>api</a:t>
-            </a:r>
-            <a:r>
-              <a:rPr lang="en-US" dirty="0"/>
-              <a:t>-versions =&gt; similar to what you did with the proxy, just easier</a:t>
-            </a:r>
-          </a:p>
-          <a:p>
-            <a:pPr marL="522900" lvl="1" indent="-342900">
-              <a:buSzPct val="100000"/>
-              <a:buFont typeface="Wingdings" panose="05000000000000000000" pitchFamily="2" charset="2"/>
-              <a:buChar char="§"/>
-            </a:pPr>
-            <a:r>
-              <a:rPr lang="en-US" dirty="0"/>
-              <a:t>Show </a:t>
-            </a:r>
-            <a:r>
-              <a:rPr lang="en-US" dirty="0" err="1"/>
-              <a:t>kubectl</a:t>
-            </a:r>
-            <a:r>
-              <a:rPr lang="en-US" dirty="0"/>
-              <a:t> </a:t>
-            </a:r>
-            <a:r>
-              <a:rPr lang="en-US" dirty="0" err="1"/>
-              <a:t>api</a:t>
-            </a:r>
-            <a:r>
-              <a:rPr lang="en-US" dirty="0"/>
-              <a:t>-resources =&gt; gives info about all the cluster resources </a:t>
-            </a:r>
-            <a:r>
-              <a:rPr lang="en-US" dirty="0" err="1"/>
-              <a:t>incl</a:t>
-            </a:r>
-            <a:r>
-              <a:rPr lang="en-US" dirty="0"/>
-              <a:t> short names!</a:t>
-            </a:r>
           </a:p>
         </p:txBody>
       </p:sp>
@@ -5396,7 +5038,7 @@
             <a:spLocks noGrp="1"/>
           </p:cNvSpPr>
           <p:nvPr>
-            <p:ph type="sldNum" sz="quarter" idx="10"/>
+            <p:ph type="sldNum" sz="quarter" idx="5"/>
           </p:nvPr>
         </p:nvSpPr>
         <p:spPr/>
@@ -5416,7 +5058,7 @@
     </p:spTree>
     <p:extLst>
       <p:ext uri="{BB962C8B-B14F-4D97-AF65-F5344CB8AC3E}">
-        <p14:creationId xmlns:p14="http://schemas.microsoft.com/office/powerpoint/2010/main" val="2072189787"/>
+        <p14:creationId xmlns:p14="http://schemas.microsoft.com/office/powerpoint/2010/main" val="1524975748"/>
       </p:ext>
     </p:extLst>
   </p:cSld>
@@ -5467,12 +5109,461 @@
         </p:nvSpPr>
         <p:spPr/>
         <p:txBody>
-          <a:bodyPr/>
+          <a:bodyPr>
+            <a:normAutofit fontScale="85000" lnSpcReduction="10000"/>
+          </a:bodyPr>
           <a:lstStyle/>
           <a:p>
-            <a:r>
-              <a:rPr lang="en-US" dirty="0"/>
-              <a:t>~10min</a:t>
+            <a:pPr marL="342900" indent="-342900">
+              <a:buSzPct val="100000"/>
+              <a:buFont typeface="Wingdings" panose="05000000000000000000" pitchFamily="2" charset="2"/>
+              <a:buChar char="§"/>
+            </a:pPr>
+            <a:r>
+              <a:rPr lang="en-US" dirty="0"/>
+              <a:t>Call </a:t>
+            </a:r>
+            <a:r>
+              <a:rPr lang="en-US" dirty="0" err="1"/>
+              <a:t>kubectl</a:t>
+            </a:r>
+            <a:r>
+              <a:rPr lang="en-US" dirty="0"/>
+              <a:t> without any sub-command and explain how to get more info </a:t>
+            </a:r>
+          </a:p>
+          <a:p>
+            <a:pPr marL="180000" lvl="1" indent="0">
+              <a:buSzPct val="100000"/>
+              <a:buFont typeface="Wingdings" panose="05000000000000000000" pitchFamily="2" charset="2"/>
+              <a:buNone/>
+            </a:pPr>
+            <a:endParaRPr lang="en-US" dirty="0"/>
+          </a:p>
+          <a:p>
+            <a:pPr marL="342900" indent="-342900">
+              <a:buSzPct val="100000"/>
+              <a:buFont typeface="Wingdings" panose="05000000000000000000" pitchFamily="2" charset="2"/>
+              <a:buChar char="§"/>
+            </a:pPr>
+            <a:r>
+              <a:rPr lang="en-US" dirty="0"/>
+              <a:t>Show access to cluster with </a:t>
+            </a:r>
+            <a:r>
+              <a:rPr lang="en-US" dirty="0" err="1"/>
+              <a:t>kubectl</a:t>
+            </a:r>
+            <a:r>
+              <a:rPr lang="en-US" dirty="0"/>
+              <a:t> -&gt; </a:t>
+            </a:r>
+            <a:r>
+              <a:rPr lang="en-US" dirty="0" err="1"/>
+              <a:t>kubectl</a:t>
+            </a:r>
+            <a:r>
+              <a:rPr lang="en-US" dirty="0"/>
+              <a:t> get nodes</a:t>
+            </a:r>
+          </a:p>
+          <a:p>
+            <a:pPr marL="342900" indent="-342900">
+              <a:buSzPct val="100000"/>
+              <a:buFont typeface="Wingdings" panose="05000000000000000000" pitchFamily="2" charset="2"/>
+              <a:buChar char="§"/>
+            </a:pPr>
+            <a:r>
+              <a:rPr lang="en-US" dirty="0"/>
+              <a:t>Explain basic syntax of </a:t>
+            </a:r>
+            <a:r>
+              <a:rPr lang="en-US" dirty="0" err="1"/>
+              <a:t>kubectl</a:t>
+            </a:r>
+            <a:r>
+              <a:rPr lang="en-US" dirty="0"/>
+              <a:t> [verb] [resource type] [specific resource by name or label] [options / switches like –o </a:t>
+            </a:r>
+            <a:r>
+              <a:rPr lang="en-US" dirty="0" err="1"/>
+              <a:t>yaml</a:t>
+            </a:r>
+            <a:r>
+              <a:rPr lang="en-US" dirty="0"/>
+              <a:t>]</a:t>
+            </a:r>
+          </a:p>
+          <a:p>
+            <a:pPr marL="342900" marR="0" lvl="0" indent="-342900" algn="l" defTabSz="1088776" rtl="0" eaLnBrk="1" fontAlgn="auto" latinLnBrk="0" hangingPunct="1">
+              <a:lnSpc>
+                <a:spcPct val="100000"/>
+              </a:lnSpc>
+              <a:spcBef>
+                <a:spcPts val="0"/>
+              </a:spcBef>
+              <a:spcAft>
+                <a:spcPts val="0"/>
+              </a:spcAft>
+              <a:buClrTx/>
+              <a:buSzPct val="100000"/>
+              <a:buFont typeface="Wingdings" panose="05000000000000000000" pitchFamily="2" charset="2"/>
+              <a:buChar char="§"/>
+              <a:tabLst/>
+              <a:defRPr/>
+            </a:pPr>
+            <a:r>
+              <a:rPr lang="en-US" dirty="0"/>
+              <a:t>Show </a:t>
+            </a:r>
+            <a:r>
+              <a:rPr lang="en-US" dirty="0" err="1"/>
+              <a:t>kubectl</a:t>
+            </a:r>
+            <a:r>
+              <a:rPr lang="en-US" dirty="0"/>
+              <a:t> get &amp; describe nodes and talk about details of the node, like resource utilization or docker version</a:t>
+            </a:r>
+          </a:p>
+          <a:p>
+            <a:pPr marL="342900" marR="0" lvl="0" indent="-342900" algn="l" defTabSz="1088776" rtl="0" eaLnBrk="1" fontAlgn="auto" latinLnBrk="0" hangingPunct="1">
+              <a:lnSpc>
+                <a:spcPct val="100000"/>
+              </a:lnSpc>
+              <a:spcBef>
+                <a:spcPts val="0"/>
+              </a:spcBef>
+              <a:spcAft>
+                <a:spcPts val="0"/>
+              </a:spcAft>
+              <a:buClrTx/>
+              <a:buSzPct val="100000"/>
+              <a:buFont typeface="Wingdings" panose="05000000000000000000" pitchFamily="2" charset="2"/>
+              <a:buChar char="§"/>
+              <a:tabLst/>
+              <a:defRPr/>
+            </a:pPr>
+            <a:endParaRPr lang="en-US" dirty="0"/>
+          </a:p>
+          <a:p>
+            <a:pPr marL="342900" indent="-342900">
+              <a:buSzPct val="100000"/>
+              <a:buFont typeface="Wingdings" panose="05000000000000000000" pitchFamily="2" charset="2"/>
+              <a:buChar char="§"/>
+            </a:pPr>
+            <a:r>
+              <a:rPr lang="en-US" dirty="0"/>
+              <a:t>Show and explain </a:t>
+            </a:r>
+            <a:r>
+              <a:rPr lang="en-US" dirty="0" err="1"/>
+              <a:t>kubectl</a:t>
+            </a:r>
+            <a:r>
+              <a:rPr lang="en-US" dirty="0"/>
+              <a:t> config *</a:t>
+            </a:r>
+          </a:p>
+          <a:p>
+            <a:pPr marL="522900" lvl="1" indent="-342900">
+              <a:buSzPct val="100000"/>
+              <a:buFont typeface="Wingdings" panose="05000000000000000000" pitchFamily="2" charset="2"/>
+              <a:buChar char="§"/>
+            </a:pPr>
+            <a:r>
+              <a:rPr lang="en-US" dirty="0"/>
+              <a:t>Explain KUBECONFIG env variable &amp; the default location ~/.</a:t>
+            </a:r>
+            <a:r>
+              <a:rPr lang="en-US" dirty="0" err="1"/>
+              <a:t>kube</a:t>
+            </a:r>
+            <a:r>
+              <a:rPr lang="en-US" dirty="0"/>
+              <a:t>/config</a:t>
+            </a:r>
+          </a:p>
+          <a:p>
+            <a:pPr marL="522900" lvl="1" indent="-342900">
+              <a:buSzPct val="100000"/>
+              <a:buFont typeface="Wingdings" panose="05000000000000000000" pitchFamily="2" charset="2"/>
+              <a:buChar char="§"/>
+            </a:pPr>
+            <a:r>
+              <a:rPr lang="en-US" dirty="0"/>
+              <a:t>Show the </a:t>
+            </a:r>
+            <a:r>
+              <a:rPr lang="en-US" dirty="0" err="1"/>
+              <a:t>kubeconfig</a:t>
+            </a:r>
+            <a:r>
+              <a:rPr lang="en-US" dirty="0"/>
+              <a:t> </a:t>
+            </a:r>
+            <a:r>
+              <a:rPr lang="en-US" dirty="0" err="1"/>
+              <a:t>yaml</a:t>
+            </a:r>
+            <a:r>
+              <a:rPr lang="en-US" dirty="0"/>
+              <a:t> file with the current context and the namespace</a:t>
+            </a:r>
+          </a:p>
+          <a:p>
+            <a:pPr marL="342900" marR="0" lvl="0" indent="-342900" algn="l" defTabSz="1088776" rtl="0" eaLnBrk="1" fontAlgn="auto" latinLnBrk="0" hangingPunct="1">
+              <a:lnSpc>
+                <a:spcPct val="100000"/>
+              </a:lnSpc>
+              <a:spcBef>
+                <a:spcPts val="0"/>
+              </a:spcBef>
+              <a:spcAft>
+                <a:spcPts val="0"/>
+              </a:spcAft>
+              <a:buClrTx/>
+              <a:buSzPct val="100000"/>
+              <a:buFont typeface="Wingdings" panose="05000000000000000000" pitchFamily="2" charset="2"/>
+              <a:buChar char="§"/>
+              <a:tabLst/>
+              <a:defRPr/>
+            </a:pPr>
+            <a:endParaRPr lang="en-US" dirty="0"/>
+          </a:p>
+          <a:p>
+            <a:pPr marL="342900" marR="0" lvl="0" indent="-342900" algn="l" defTabSz="1088776" rtl="0" eaLnBrk="1" fontAlgn="auto" latinLnBrk="0" hangingPunct="1">
+              <a:lnSpc>
+                <a:spcPct val="100000"/>
+              </a:lnSpc>
+              <a:spcBef>
+                <a:spcPts val="0"/>
+              </a:spcBef>
+              <a:spcAft>
+                <a:spcPts val="0"/>
+              </a:spcAft>
+              <a:buClrTx/>
+              <a:buSzPct val="100000"/>
+              <a:buFont typeface="Wingdings" panose="05000000000000000000" pitchFamily="2" charset="2"/>
+              <a:buChar char="§"/>
+              <a:tabLst/>
+              <a:defRPr/>
+            </a:pPr>
+            <a:r>
+              <a:rPr lang="en-US" dirty="0"/>
+              <a:t>Show all namespaces in cluster, if not yet mentioned, explain that everyone has their own namespace. Please be a good citizen and don’t sabotage the others.</a:t>
+            </a:r>
+          </a:p>
+          <a:p>
+            <a:pPr marL="342900" marR="0" lvl="0" indent="-342900" algn="l" defTabSz="1088776" rtl="0" eaLnBrk="1" fontAlgn="auto" latinLnBrk="0" hangingPunct="1">
+              <a:lnSpc>
+                <a:spcPct val="100000"/>
+              </a:lnSpc>
+              <a:spcBef>
+                <a:spcPts val="0"/>
+              </a:spcBef>
+              <a:spcAft>
+                <a:spcPts val="0"/>
+              </a:spcAft>
+              <a:buClrTx/>
+              <a:buSzPct val="100000"/>
+              <a:buFont typeface="Wingdings" panose="05000000000000000000" pitchFamily="2" charset="2"/>
+              <a:buChar char="§"/>
+              <a:tabLst/>
+              <a:defRPr/>
+            </a:pPr>
+            <a:r>
+              <a:rPr lang="en-US" dirty="0"/>
+              <a:t>Query a pod from a dedicated namespace ( e.g. </a:t>
+            </a:r>
+            <a:r>
+              <a:rPr lang="en-US" dirty="0" err="1"/>
+              <a:t>kube</a:t>
+            </a:r>
+            <a:r>
+              <a:rPr lang="en-US" dirty="0"/>
+              <a:t>-system), explain “-n &lt;namespace&gt;” flag</a:t>
+            </a:r>
+          </a:p>
+          <a:p>
+            <a:pPr marL="342900" marR="0" lvl="0" indent="-342900" algn="l" defTabSz="1088776" rtl="0" eaLnBrk="1" fontAlgn="auto" latinLnBrk="0" hangingPunct="1">
+              <a:lnSpc>
+                <a:spcPct val="100000"/>
+              </a:lnSpc>
+              <a:spcBef>
+                <a:spcPts val="0"/>
+              </a:spcBef>
+              <a:spcAft>
+                <a:spcPts val="0"/>
+              </a:spcAft>
+              <a:buClrTx/>
+              <a:buSzPct val="100000"/>
+              <a:buFont typeface="Wingdings" panose="05000000000000000000" pitchFamily="2" charset="2"/>
+              <a:buChar char="§"/>
+              <a:tabLst/>
+              <a:defRPr/>
+            </a:pPr>
+            <a:endParaRPr lang="en-US" dirty="0"/>
+          </a:p>
+          <a:p>
+            <a:pPr marL="342900" marR="0" lvl="0" indent="-342900" algn="l" defTabSz="1088776" rtl="0" eaLnBrk="1" fontAlgn="auto" latinLnBrk="0" hangingPunct="1">
+              <a:lnSpc>
+                <a:spcPct val="100000"/>
+              </a:lnSpc>
+              <a:spcBef>
+                <a:spcPts val="0"/>
+              </a:spcBef>
+              <a:spcAft>
+                <a:spcPts val="0"/>
+              </a:spcAft>
+              <a:buClrTx/>
+              <a:buSzPct val="100000"/>
+              <a:buFont typeface="Wingdings" panose="05000000000000000000" pitchFamily="2" charset="2"/>
+              <a:buChar char="§"/>
+              <a:tabLst/>
+              <a:defRPr/>
+            </a:pPr>
+            <a:r>
+              <a:rPr lang="en-US" dirty="0"/>
+              <a:t>Run </a:t>
+            </a:r>
+            <a:r>
+              <a:rPr lang="en-US" dirty="0" err="1"/>
+              <a:t>kubectl</a:t>
+            </a:r>
+            <a:r>
+              <a:rPr lang="en-US" dirty="0"/>
+              <a:t> proxy &amp;</a:t>
+            </a:r>
+          </a:p>
+          <a:p>
+            <a:pPr marL="342900" marR="0" lvl="0" indent="-342900" algn="l" defTabSz="1088776" rtl="0" eaLnBrk="1" fontAlgn="auto" latinLnBrk="0" hangingPunct="1">
+              <a:lnSpc>
+                <a:spcPct val="100000"/>
+              </a:lnSpc>
+              <a:spcBef>
+                <a:spcPts val="0"/>
+              </a:spcBef>
+              <a:spcAft>
+                <a:spcPts val="0"/>
+              </a:spcAft>
+              <a:buClrTx/>
+              <a:buSzPct val="100000"/>
+              <a:buFont typeface="Wingdings" panose="05000000000000000000" pitchFamily="2" charset="2"/>
+              <a:buChar char="§"/>
+              <a:tabLst/>
+              <a:defRPr/>
+            </a:pPr>
+            <a:r>
+              <a:rPr lang="en-US" dirty="0"/>
+              <a:t>Open localhost:8001 in browser and show </a:t>
+            </a:r>
+            <a:r>
+              <a:rPr lang="en-US" dirty="0" err="1"/>
+              <a:t>api</a:t>
+            </a:r>
+            <a:r>
+              <a:rPr lang="en-US" dirty="0"/>
+              <a:t> tree, traverse through it and go to namespace </a:t>
+            </a:r>
+            <a:r>
+              <a:rPr lang="en-US" dirty="0" err="1"/>
+              <a:t>kube</a:t>
+            </a:r>
+            <a:r>
+              <a:rPr lang="en-US" dirty="0"/>
+              <a:t>-system and show some pods</a:t>
+            </a:r>
+          </a:p>
+          <a:p>
+            <a:pPr marL="342900" indent="-342900">
+              <a:buSzPct val="100000"/>
+              <a:buFont typeface="Wingdings" panose="05000000000000000000" pitchFamily="2" charset="2"/>
+              <a:buChar char="§"/>
+            </a:pPr>
+            <a:r>
+              <a:rPr lang="en-US" dirty="0"/>
+              <a:t>Query API server with curl (again via localhost)</a:t>
+            </a:r>
+          </a:p>
+          <a:p>
+            <a:pPr marL="342900" indent="-342900">
+              <a:buSzPct val="100000"/>
+              <a:buFont typeface="Wingdings" panose="05000000000000000000" pitchFamily="2" charset="2"/>
+              <a:buChar char="§"/>
+            </a:pPr>
+            <a:r>
+              <a:rPr lang="en-US" dirty="0"/>
+              <a:t>If you have </a:t>
+            </a:r>
+            <a:r>
+              <a:rPr lang="en-US" dirty="0" err="1"/>
+              <a:t>kubectl</a:t>
+            </a:r>
+            <a:r>
+              <a:rPr lang="en-US" dirty="0"/>
+              <a:t> version v1.11 or higher:</a:t>
+            </a:r>
+          </a:p>
+          <a:p>
+            <a:pPr marL="522900" lvl="1" indent="-342900">
+              <a:buSzPct val="100000"/>
+              <a:buFont typeface="Wingdings" panose="05000000000000000000" pitchFamily="2" charset="2"/>
+              <a:buChar char="§"/>
+            </a:pPr>
+            <a:r>
+              <a:rPr lang="en-US" dirty="0"/>
+              <a:t>Show </a:t>
+            </a:r>
+            <a:r>
+              <a:rPr lang="en-US" dirty="0" err="1"/>
+              <a:t>kubectl</a:t>
+            </a:r>
+            <a:r>
+              <a:rPr lang="en-US" dirty="0"/>
+              <a:t> </a:t>
+            </a:r>
+            <a:r>
+              <a:rPr lang="en-US" dirty="0" err="1"/>
+              <a:t>api</a:t>
+            </a:r>
+            <a:r>
+              <a:rPr lang="en-US" dirty="0"/>
+              <a:t>-versions =&gt; similar to what you did with the proxy, just easier</a:t>
+            </a:r>
+          </a:p>
+          <a:p>
+            <a:pPr marL="522900" lvl="1" indent="-342900">
+              <a:buSzPct val="100000"/>
+              <a:buFont typeface="Wingdings" panose="05000000000000000000" pitchFamily="2" charset="2"/>
+              <a:buChar char="§"/>
+            </a:pPr>
+            <a:r>
+              <a:rPr lang="en-US" dirty="0"/>
+              <a:t>Show </a:t>
+            </a:r>
+            <a:r>
+              <a:rPr lang="en-US" dirty="0" err="1"/>
+              <a:t>kubectl</a:t>
+            </a:r>
+            <a:r>
+              <a:rPr lang="en-US" dirty="0"/>
+              <a:t> </a:t>
+            </a:r>
+            <a:r>
+              <a:rPr lang="en-US" dirty="0" err="1"/>
+              <a:t>api</a:t>
+            </a:r>
+            <a:r>
+              <a:rPr lang="en-US" dirty="0"/>
+              <a:t>-resources =&gt; gives info about all the cluster resources </a:t>
+            </a:r>
+            <a:r>
+              <a:rPr lang="en-US" dirty="0" err="1"/>
+              <a:t>incl</a:t>
+            </a:r>
+            <a:r>
+              <a:rPr lang="en-US" dirty="0"/>
+              <a:t> short names!</a:t>
             </a:r>
           </a:p>
         </p:txBody>
@@ -5495,7 +5586,95 @@
             <a:fld id="{7D8C2C35-2B8A-446E-BEC0-FD36716C29AC}" type="slidenum">
               <a:rPr lang="de-DE" smtClean="0"/>
               <a:pPr/>
-              <a:t>17</a:t>
+              <a:t>16</a:t>
+            </a:fld>
+            <a:endParaRPr lang="de-DE" dirty="0"/>
+          </a:p>
+        </p:txBody>
+      </p:sp>
+    </p:spTree>
+    <p:extLst>
+      <p:ext uri="{BB962C8B-B14F-4D97-AF65-F5344CB8AC3E}">
+        <p14:creationId xmlns:p14="http://schemas.microsoft.com/office/powerpoint/2010/main" val="2072189787"/>
+      </p:ext>
+    </p:extLst>
+  </p:cSld>
+  <p:clrMapOvr>
+    <a:masterClrMapping/>
+  </p:clrMapOvr>
+</p:notes>
+</file>
+
+<file path=ppt/notesSlides/notesSlide16.xml><?xml version="1.0" encoding="utf-8"?>
+<p:notes xmlns:a="http://schemas.openxmlformats.org/drawingml/2006/main" xmlns:r="http://schemas.openxmlformats.org/officeDocument/2006/relationships" xmlns:p="http://schemas.openxmlformats.org/presentationml/2006/main">
+  <p:cSld>
+    <p:spTree>
+      <p:nvGrpSpPr>
+        <p:cNvPr id="1" name=""/>
+        <p:cNvGrpSpPr/>
+        <p:nvPr/>
+      </p:nvGrpSpPr>
+      <p:grpSpPr>
+        <a:xfrm>
+          <a:off x="0" y="0"/>
+          <a:ext cx="0" cy="0"/>
+          <a:chOff x="0" y="0"/>
+          <a:chExt cx="0" cy="0"/>
+        </a:xfrm>
+      </p:grpSpPr>
+      <p:sp>
+        <p:nvSpPr>
+          <p:cNvPr id="2" name="Slide Image Placeholder 1"/>
+          <p:cNvSpPr>
+            <a:spLocks noGrp="1" noRot="1" noChangeAspect="1"/>
+          </p:cNvSpPr>
+          <p:nvPr>
+            <p:ph type="sldImg"/>
+          </p:nvPr>
+        </p:nvSpPr>
+        <p:spPr/>
+      </p:sp>
+      <p:sp>
+        <p:nvSpPr>
+          <p:cNvPr id="3" name="Notes Placeholder 2"/>
+          <p:cNvSpPr>
+            <a:spLocks noGrp="1"/>
+          </p:cNvSpPr>
+          <p:nvPr>
+            <p:ph type="body" idx="1"/>
+          </p:nvPr>
+        </p:nvSpPr>
+        <p:spPr/>
+        <p:txBody>
+          <a:bodyPr/>
+          <a:lstStyle/>
+          <a:p>
+            <a:r>
+              <a:rPr lang="en-US" dirty="0"/>
+              <a:t>~10min</a:t>
+            </a:r>
+          </a:p>
+        </p:txBody>
+      </p:sp>
+      <p:sp>
+        <p:nvSpPr>
+          <p:cNvPr id="4" name="Slide Number Placeholder 3"/>
+          <p:cNvSpPr>
+            <a:spLocks noGrp="1"/>
+          </p:cNvSpPr>
+          <p:nvPr>
+            <p:ph type="sldNum" sz="quarter" idx="10"/>
+          </p:nvPr>
+        </p:nvSpPr>
+        <p:spPr/>
+        <p:txBody>
+          <a:bodyPr/>
+          <a:lstStyle/>
+          <a:p>
+            <a:fld id="{7D8C2C35-2B8A-446E-BEC0-FD36716C29AC}" type="slidenum">
+              <a:rPr lang="de-DE" smtClean="0"/>
+              <a:pPr/>
+              <a:t>18</a:t>
             </a:fld>
             <a:endParaRPr lang="de-DE" dirty="0"/>
           </a:p>
@@ -5514,7 +5693,7 @@
 </p:notes>
 </file>
 
-<file path=ppt/notesSlides/notesSlide16.xml><?xml version="1.0" encoding="utf-8"?>
+<file path=ppt/notesSlides/notesSlide17.xml><?xml version="1.0" encoding="utf-8"?>
 <p:notes xmlns:a="http://schemas.openxmlformats.org/drawingml/2006/main" xmlns:r="http://schemas.openxmlformats.org/officeDocument/2006/relationships" xmlns:p="http://schemas.openxmlformats.org/presentationml/2006/main">
   <p:cSld>
     <p:spTree>
@@ -5549,7 +5728,7 @@
             <a:fld id="{7D8C2C35-2B8A-446E-BEC0-FD36716C29AC}" type="slidenum">
               <a:rPr lang="de-DE" smtClean="0"/>
               <a:pPr/>
-              <a:t>18</a:t>
+              <a:t>19</a:t>
             </a:fld>
             <a:endParaRPr lang="de-DE" dirty="0"/>
           </a:p>
@@ -7259,7 +7438,7 @@
       </p:grpSpPr>
       <p:sp>
         <p:nvSpPr>
-          <p:cNvPr id="2" name="Slide Image Placeholder 1"/>
+          <p:cNvPr id="2" name="Folienbildplatzhalter 1"/>
           <p:cNvSpPr>
             <a:spLocks noGrp="1" noRot="1" noChangeAspect="1"/>
           </p:cNvSpPr>
@@ -7271,7 +7450,7 @@
       </p:sp>
       <p:sp>
         <p:nvSpPr>
-          <p:cNvPr id="3" name="Notes Placeholder 2"/>
+          <p:cNvPr id="3" name="Notizenplatzhalter 2"/>
           <p:cNvSpPr>
             <a:spLocks noGrp="1"/>
           </p:cNvSpPr>
@@ -7281,114 +7460,111 @@
         </p:nvSpPr>
         <p:spPr/>
         <p:txBody>
-          <a:bodyPr/>
+          <a:bodyPr>
+            <a:normAutofit fontScale="92500" lnSpcReduction="10000"/>
+          </a:bodyPr>
           <a:lstStyle/>
           <a:p>
-            <a:r>
-              <a:rPr lang="en-US" dirty="0"/>
-              <a:t>The </a:t>
-            </a:r>
-            <a:r>
-              <a:rPr lang="en-US" dirty="0" err="1"/>
-              <a:t>api</a:t>
-            </a:r>
-            <a:r>
-              <a:rPr lang="en-US" dirty="0"/>
-              <a:t> is structured in different groups/version. Within these, namespaces group a set of resources. Within a namespace, names have to be unique.</a:t>
-            </a:r>
-          </a:p>
-          <a:p>
-            <a:endParaRPr lang="en-US" dirty="0"/>
-          </a:p>
-          <a:p>
-            <a:r>
-              <a:rPr lang="en-US" dirty="0"/>
-              <a:t>The core API group, was the first and contains objects like pods or service. Later the API tree was split into topic specific groups to bundle resources e.g. for networking. The core API group hasn’t been touched though.</a:t>
-            </a:r>
-          </a:p>
-          <a:p>
-            <a:endParaRPr lang="en-US" dirty="0"/>
-          </a:p>
-          <a:p>
-            <a:r>
-              <a:rPr lang="en-US" b="1" dirty="0"/>
-              <a:t>Namespace</a:t>
-            </a:r>
-          </a:p>
-          <a:p>
-            <a:pPr lvl="1"/>
-            <a:r>
-              <a:rPr lang="en-US" dirty="0"/>
-              <a:t>Logical realm for applications to run within</a:t>
-            </a:r>
-          </a:p>
-          <a:p>
-            <a:pPr lvl="1"/>
-            <a:r>
-              <a:rPr lang="en-US" dirty="0"/>
-              <a:t>Isolate resources and restrict visibility to objects in the same namespace</a:t>
-            </a:r>
-          </a:p>
-          <a:p>
-            <a:pPr lvl="1"/>
-            <a:r>
-              <a:rPr lang="en-US" dirty="0"/>
-              <a:t>Basic user management is handled on namespace level</a:t>
-            </a:r>
-          </a:p>
-          <a:p>
-            <a:pPr lvl="1"/>
-            <a:r>
-              <a:rPr lang="en-US" dirty="0"/>
-              <a:t>Resource quotas / limits managed per namespace</a:t>
-            </a:r>
-          </a:p>
-          <a:p>
-            <a:pPr lvl="1"/>
-            <a:r>
-              <a:rPr lang="en-US" dirty="0"/>
-              <a:t>Uniqueness of names required per namespace</a:t>
-            </a:r>
-          </a:p>
-          <a:p>
-            <a:pPr lvl="1"/>
-            <a:r>
-              <a:rPr lang="en-US" dirty="0"/>
-              <a:t>Access to services in a different namespace via FQDN &lt;service-name&gt;.&lt;namespace&gt;</a:t>
-            </a:r>
-          </a:p>
-          <a:p>
-            <a:pPr lvl="1"/>
-            <a:r>
-              <a:rPr lang="en-US" dirty="0"/>
-              <a:t>Use –n (--namespace) &lt;namespace&gt; switch with </a:t>
-            </a:r>
-            <a:r>
-              <a:rPr lang="en-US" dirty="0" err="1"/>
+            <a:br>
+              <a:rPr lang="en-US" noProof="0" dirty="0"/>
+            </a:br>
+            <a:r>
+              <a:rPr lang="en-US" noProof="0" dirty="0"/>
+              <a:t>The API Server is the interface to the cluster. Whether it is a user (via </a:t>
+            </a:r>
+            <a:r>
+              <a:rPr lang="en-US" noProof="0" dirty="0" err="1"/>
               <a:t>kubectl</a:t>
             </a:r>
             <a:r>
-              <a:rPr lang="en-US" dirty="0"/>
-              <a:t> to access resources</a:t>
-            </a:r>
-          </a:p>
-          <a:p>
-            <a:pPr lvl="1"/>
-            <a:endParaRPr lang="en-US" dirty="0"/>
-          </a:p>
-          <a:p>
-            <a:endParaRPr lang="en-US" dirty="0"/>
+              <a:rPr lang="en-US" noProof="0" dirty="0"/>
+              <a:t>) or a controller, every interaction with the clusters state is handled through the API server.</a:t>
+            </a:r>
+          </a:p>
+          <a:p>
+            <a:endParaRPr lang="en-US" noProof="0" dirty="0"/>
+          </a:p>
+          <a:p>
+            <a:r>
+              <a:rPr lang="en-US" noProof="0" dirty="0"/>
+              <a:t>Authorization &amp; Authentication:</a:t>
+            </a:r>
+          </a:p>
+          <a:p>
+            <a:r>
+              <a:rPr lang="en-US" noProof="0" dirty="0"/>
+              <a:t>Is the request equipped with proper credentials? Is the user allowed to perform the requested action?</a:t>
+            </a:r>
+          </a:p>
+          <a:p>
+            <a:endParaRPr lang="en-US" noProof="0" dirty="0"/>
+          </a:p>
+          <a:p>
+            <a:r>
+              <a:rPr lang="en-US" noProof="0" dirty="0"/>
+              <a:t>RESTful interface to all resources:</a:t>
+            </a:r>
+          </a:p>
+          <a:p>
+            <a:r>
+              <a:rPr lang="en-US" noProof="0" dirty="0"/>
+              <a:t>Provides an interface to query and modify all known resources within a single cluster. State changes will be persisted in </a:t>
+            </a:r>
+            <a:r>
+              <a:rPr lang="en-US" noProof="0" dirty="0" err="1"/>
+              <a:t>etcd</a:t>
+            </a:r>
+            <a:r>
+              <a:rPr lang="en-US" noProof="0" dirty="0"/>
+              <a:t> eventually.</a:t>
+            </a:r>
+          </a:p>
+          <a:p>
+            <a:r>
+              <a:rPr lang="en-US" noProof="0" dirty="0"/>
+              <a:t>In addition, the API allows long-running “watch” connections where it will stream events of changes to resource to the caller. This is heavily used by controllers and prevents excessive polling</a:t>
+            </a:r>
+          </a:p>
+          <a:p>
+            <a:endParaRPr lang="en-US" noProof="0" dirty="0"/>
+          </a:p>
+          <a:p>
+            <a:r>
+              <a:rPr lang="en-US" noProof="0" dirty="0"/>
+              <a:t>Admission &amp; Mutation:</a:t>
+            </a:r>
+          </a:p>
+          <a:p>
+            <a:r>
+              <a:rPr lang="en-US" noProof="0" dirty="0"/>
+              <a:t>Perform checks and validate, if a resource is configured properly. Validate a given configuration (allow /deny) and apply default values. Can also include custom configuration as well as defaulting values.</a:t>
+            </a:r>
+          </a:p>
+          <a:p>
+            <a:endParaRPr lang="en-US" noProof="0" dirty="0"/>
+          </a:p>
+          <a:p>
+            <a:r>
+              <a:rPr lang="en-US" noProof="0" dirty="0"/>
+              <a:t>Extensibility:</a:t>
+            </a:r>
+          </a:p>
+          <a:p>
+            <a:r>
+              <a:rPr lang="en-US" noProof="0" dirty="0"/>
+              <a:t>Register custom resources that become fully discoverable and automatically provide a RESTful interface for those.</a:t>
+            </a:r>
           </a:p>
         </p:txBody>
       </p:sp>
       <p:sp>
         <p:nvSpPr>
-          <p:cNvPr id="4" name="Slide Number Placeholder 3"/>
+          <p:cNvPr id="4" name="Foliennummernplatzhalter 3"/>
           <p:cNvSpPr>
             <a:spLocks noGrp="1"/>
           </p:cNvSpPr>
           <p:nvPr>
-            <p:ph type="sldNum" sz="quarter" idx="10"/>
+            <p:ph type="sldNum" sz="quarter" idx="5"/>
           </p:nvPr>
         </p:nvSpPr>
         <p:spPr/>
@@ -7408,7 +7584,7 @@
     </p:spTree>
     <p:extLst>
       <p:ext uri="{BB962C8B-B14F-4D97-AF65-F5344CB8AC3E}">
-        <p14:creationId xmlns:p14="http://schemas.microsoft.com/office/powerpoint/2010/main" val="4011559529"/>
+        <p14:creationId xmlns:p14="http://schemas.microsoft.com/office/powerpoint/2010/main" val="325271335"/>
       </p:ext>
     </p:extLst>
   </p:cSld>
@@ -14169,7 +14345,7 @@
               <a:pPr marL="0" lvl="0" indent="0" algn="r">
                 <a:buNone/>
               </a:pPr>
-              <a:t>‹#›</a:t>
+              <a:t>‹Nr.›</a:t>
             </a:fld>
             <a:endParaRPr lang="en-US" sz="900" noProof="0" dirty="0"/>
           </a:p>
@@ -15088,108 +15264,272 @@
             <p:ph type="body" sz="quarter" idx="10"/>
           </p:nvPr>
         </p:nvSpPr>
-        <p:spPr/>
+        <p:spPr>
+          <a:xfrm>
+            <a:off x="504000" y="1620000"/>
+            <a:ext cx="11185200" cy="4230000"/>
+          </a:xfrm>
+        </p:spPr>
         <p:txBody>
           <a:bodyPr/>
           <a:lstStyle/>
           <a:p>
-            <a:pPr marL="2511425" indent="-2511425" defTabSz="989013">
-              <a:tabLst>
-                <a:tab pos="1885950" algn="l"/>
-              </a:tabLst>
-            </a:pPr>
-            <a:r>
-              <a:rPr lang="en-US" sz="2900" dirty="0"/>
-              <a:t>v1</a:t>
-            </a:r>
-            <a:r>
-              <a:rPr lang="en-US" sz="2900" b="1" dirty="0"/>
-              <a:t>alpha</a:t>
-            </a:r>
-            <a:r>
-              <a:rPr lang="en-US" sz="2900" dirty="0"/>
-              <a:t>1	</a:t>
-            </a:r>
-            <a:r>
-              <a:rPr lang="en-US" sz="2900" dirty="0">
+            <a:r>
+              <a:rPr lang="en-US" b="1" dirty="0">
+                <a:latin typeface="Courier New" panose="02070309020205020404" pitchFamily="49" charset="0"/>
+                <a:cs typeface="Courier New" panose="02070309020205020404" pitchFamily="49" charset="0"/>
+              </a:rPr>
+              <a:t>/</a:t>
+            </a:r>
+            <a:r>
+              <a:rPr lang="en-US" b="1" dirty="0" err="1">
+                <a:latin typeface="Courier New" panose="02070309020205020404" pitchFamily="49" charset="0"/>
+                <a:cs typeface="Courier New" panose="02070309020205020404" pitchFamily="49" charset="0"/>
+              </a:rPr>
+              <a:t>api</a:t>
+            </a:r>
+            <a:r>
+              <a:rPr lang="en-US" b="1" dirty="0">
+                <a:latin typeface="Courier New" panose="02070309020205020404" pitchFamily="49" charset="0"/>
+                <a:cs typeface="Courier New" panose="02070309020205020404" pitchFamily="49" charset="0"/>
+              </a:rPr>
+              <a:t>/v1/</a:t>
+            </a:r>
+            <a:r>
+              <a:rPr lang="en-US" dirty="0">
+                <a:latin typeface="Courier New" panose="02070309020205020404" pitchFamily="49" charset="0"/>
+                <a:cs typeface="Courier New" panose="02070309020205020404" pitchFamily="49" charset="0"/>
+              </a:rPr>
+              <a:t>	</a:t>
+            </a:r>
+            <a:r>
+              <a:rPr lang="en-US" dirty="0"/>
+              <a:t>		 </a:t>
+            </a:r>
+            <a:r>
+              <a:rPr lang="en-US" dirty="0">
+                <a:solidFill>
+                  <a:schemeClr val="tx1">
+                    <a:lumMod val="75000"/>
+                  </a:schemeClr>
+                </a:solidFill>
+                <a:latin typeface="Courier New" panose="02070309020205020404" pitchFamily="49" charset="0"/>
+                <a:cs typeface="Courier New" panose="02070309020205020404" pitchFamily="49" charset="0"/>
+              </a:rPr>
+              <a:t>-- core objects like pods or nodes</a:t>
+            </a:r>
+          </a:p>
+          <a:p>
+            <a:r>
+              <a:rPr lang="en-US" b="1" dirty="0">
+                <a:latin typeface="Courier New" panose="02070309020205020404" pitchFamily="49" charset="0"/>
+                <a:cs typeface="Courier New" panose="02070309020205020404" pitchFamily="49" charset="0"/>
+              </a:rPr>
+              <a:t>/</a:t>
+            </a:r>
+            <a:r>
+              <a:rPr lang="en-US" b="1" dirty="0" err="1">
+                <a:latin typeface="Courier New" panose="02070309020205020404" pitchFamily="49" charset="0"/>
+                <a:cs typeface="Courier New" panose="02070309020205020404" pitchFamily="49" charset="0"/>
+              </a:rPr>
+              <a:t>apis</a:t>
+            </a:r>
+            <a:r>
+              <a:rPr lang="en-US" b="1" dirty="0">
+                <a:latin typeface="Courier New" panose="02070309020205020404" pitchFamily="49" charset="0"/>
+                <a:cs typeface="Courier New" panose="02070309020205020404" pitchFamily="49" charset="0"/>
+              </a:rPr>
+              <a:t>/&lt;</a:t>
+            </a:r>
+            <a:r>
+              <a:rPr lang="en-US" b="1" dirty="0" err="1">
+                <a:latin typeface="Courier New" panose="02070309020205020404" pitchFamily="49" charset="0"/>
+                <a:cs typeface="Courier New" panose="02070309020205020404" pitchFamily="49" charset="0"/>
+              </a:rPr>
+              <a:t>apigroup</a:t>
+            </a:r>
+            <a:r>
+              <a:rPr lang="en-US" b="1" dirty="0">
+                <a:latin typeface="Courier New" panose="02070309020205020404" pitchFamily="49" charset="0"/>
+                <a:cs typeface="Courier New" panose="02070309020205020404" pitchFamily="49" charset="0"/>
+              </a:rPr>
+              <a:t>&gt;/&lt;version&gt; </a:t>
+            </a:r>
+            <a:r>
+              <a:rPr lang="en-US" b="1" dirty="0"/>
+              <a:t>	</a:t>
+            </a:r>
+            <a:r>
+              <a:rPr lang="en-US" dirty="0">
+                <a:solidFill>
+                  <a:schemeClr val="tx1">
+                    <a:lumMod val="75000"/>
+                  </a:schemeClr>
+                </a:solidFill>
+                <a:latin typeface="Courier New" panose="02070309020205020404" pitchFamily="49" charset="0"/>
+                <a:cs typeface="Courier New" panose="02070309020205020404" pitchFamily="49" charset="0"/>
+              </a:rPr>
+              <a:t>-- added later as the API grew</a:t>
+            </a:r>
+          </a:p>
+          <a:p>
+            <a:r>
+              <a:rPr lang="en-US" b="1" dirty="0">
+                <a:latin typeface="Courier New" panose="02070309020205020404" pitchFamily="49" charset="0"/>
+                <a:cs typeface="Courier New" panose="02070309020205020404" pitchFamily="49" charset="0"/>
+              </a:rPr>
+              <a:t>/.../namespaces/&lt;name&gt;/...	</a:t>
+            </a:r>
+            <a:r>
+              <a:rPr lang="en-US" dirty="0">
+                <a:latin typeface="Courier New" panose="02070309020205020404" pitchFamily="49" charset="0"/>
+                <a:cs typeface="Courier New" panose="02070309020205020404" pitchFamily="49" charset="0"/>
+              </a:rPr>
+              <a:t>-- prefix to many resources for separation</a:t>
+            </a:r>
+          </a:p>
+          <a:p>
+            <a:endParaRPr lang="en-US" dirty="0">
+              <a:latin typeface="Courier New" panose="02070309020205020404" pitchFamily="49" charset="0"/>
+              <a:cs typeface="Courier New" panose="02070309020205020404" pitchFamily="49" charset="0"/>
+            </a:endParaRPr>
+          </a:p>
+          <a:p>
+            <a:r>
+              <a:rPr lang="en-US" dirty="0">
+                <a:latin typeface="Courier New" panose="02070309020205020404" pitchFamily="49" charset="0"/>
+                <a:cs typeface="Courier New" panose="02070309020205020404" pitchFamily="49" charset="0"/>
+              </a:rPr>
+              <a:t>/</a:t>
+            </a:r>
+            <a:r>
+              <a:rPr lang="en-US" dirty="0" err="1">
+                <a:latin typeface="Courier New" panose="02070309020205020404" pitchFamily="49" charset="0"/>
+                <a:cs typeface="Courier New" panose="02070309020205020404" pitchFamily="49" charset="0"/>
+              </a:rPr>
+              <a:t>api</a:t>
+            </a:r>
+            <a:r>
+              <a:rPr lang="en-US" dirty="0">
+                <a:latin typeface="Courier New" panose="02070309020205020404" pitchFamily="49" charset="0"/>
+                <a:cs typeface="Courier New" panose="02070309020205020404" pitchFamily="49" charset="0"/>
+              </a:rPr>
+              <a:t>/v1/nodes/worker-mowz3-z1-f47b7-584d5</a:t>
+            </a:r>
+          </a:p>
+          <a:p>
+            <a:r>
+              <a:rPr lang="en-US" dirty="0">
                 <a:solidFill>
                   <a:schemeClr val="tx1">
                     <a:lumMod val="75000"/>
                   </a:schemeClr>
                 </a:solidFill>
               </a:rPr>
-              <a:t>-- 	cluster may explode, volatile </a:t>
-            </a:r>
-            <a:r>
-              <a:rPr lang="en-US" sz="2900" dirty="0" err="1">
+              <a:t>/</a:t>
+            </a:r>
+            <a:r>
+              <a:rPr lang="en-US" dirty="0" err="1">
+                <a:solidFill>
+                  <a:schemeClr val="tx1">
+                    <a:lumMod val="75000"/>
+                  </a:schemeClr>
+                </a:solidFill>
+                <a:latin typeface="Courier New" panose="02070309020205020404" pitchFamily="49" charset="0"/>
+                <a:cs typeface="Courier New" panose="02070309020205020404" pitchFamily="49" charset="0"/>
+              </a:rPr>
+              <a:t>apis</a:t>
+            </a:r>
+            <a:r>
+              <a:rPr lang="en-US" dirty="0">
+                <a:solidFill>
+                  <a:schemeClr val="tx1">
+                    <a:lumMod val="75000"/>
+                  </a:schemeClr>
+                </a:solidFill>
+                <a:latin typeface="Courier New" panose="02070309020205020404" pitchFamily="49" charset="0"/>
+                <a:cs typeface="Courier New" panose="02070309020205020404" pitchFamily="49" charset="0"/>
+              </a:rPr>
+              <a:t>/apps/v1/namespaces/default/deployments/</a:t>
+            </a:r>
+            <a:r>
+              <a:rPr lang="en-US" dirty="0" err="1">
+                <a:solidFill>
+                  <a:schemeClr val="tx1">
+                    <a:lumMod val="75000"/>
+                  </a:schemeClr>
+                </a:solidFill>
+                <a:latin typeface="Courier New" panose="02070309020205020404" pitchFamily="49" charset="0"/>
+                <a:cs typeface="Courier New" panose="02070309020205020404" pitchFamily="49" charset="0"/>
+              </a:rPr>
+              <a:t>nginx</a:t>
+            </a:r>
+            <a:endParaRPr lang="en-US" dirty="0">
+              <a:solidFill>
+                <a:schemeClr val="tx1">
+                  <a:lumMod val="75000"/>
+                </a:schemeClr>
+              </a:solidFill>
+              <a:latin typeface="Courier New" panose="02070309020205020404" pitchFamily="49" charset="0"/>
+              <a:cs typeface="Courier New" panose="02070309020205020404" pitchFamily="49" charset="0"/>
+            </a:endParaRPr>
+          </a:p>
+          <a:p>
+            <a:r>
+              <a:rPr lang="en-US" dirty="0">
                 <a:solidFill>
                   <a:schemeClr val="tx1">
                     <a:lumMod val="75000"/>
                   </a:schemeClr>
                 </a:solidFill>
               </a:rPr>
-              <a:t>api</a:t>
-            </a:r>
-            <a:r>
-              <a:rPr lang="en-US" sz="2900" dirty="0">
+              <a:t>/</a:t>
+            </a:r>
+            <a:r>
+              <a:rPr lang="en-US" dirty="0" err="1">
                 <a:solidFill>
                   <a:schemeClr val="tx1">
                     <a:lumMod val="75000"/>
                   </a:schemeClr>
                 </a:solidFill>
+                <a:latin typeface="Courier New" panose="02070309020205020404" pitchFamily="49" charset="0"/>
+                <a:cs typeface="Courier New" panose="02070309020205020404" pitchFamily="49" charset="0"/>
               </a:rPr>
-              <a:t> changes expected</a:t>
-            </a:r>
-          </a:p>
-          <a:p>
-            <a:pPr marL="2511425" indent="-2511425" defTabSz="989013">
-              <a:tabLst>
-                <a:tab pos="1885950" algn="l"/>
-              </a:tabLst>
-            </a:pPr>
-            <a:r>
-              <a:rPr lang="en-US" sz="2900" dirty="0"/>
-              <a:t>v1</a:t>
-            </a:r>
-            <a:r>
-              <a:rPr lang="en-US" sz="2900" b="1" dirty="0"/>
-              <a:t>beta</a:t>
-            </a:r>
-            <a:r>
-              <a:rPr lang="en-US" sz="2900" dirty="0"/>
-              <a:t>1	</a:t>
-            </a:r>
-            <a:r>
-              <a:rPr lang="en-US" sz="2900" dirty="0">
+              <a:t>apis</a:t>
+            </a:r>
+            <a:r>
+              <a:rPr lang="en-US" dirty="0">
                 <a:solidFill>
                   <a:schemeClr val="tx1">
                     <a:lumMod val="75000"/>
                   </a:schemeClr>
                 </a:solidFill>
+                <a:latin typeface="Courier New" panose="02070309020205020404" pitchFamily="49" charset="0"/>
+                <a:cs typeface="Courier New" panose="02070309020205020404" pitchFamily="49" charset="0"/>
               </a:rPr>
-              <a:t>-- 	well tested and generally stable,  API semantics may still change in an incompatible fashion</a:t>
-            </a:r>
-          </a:p>
-          <a:p>
-            <a:pPr marL="2511425" indent="-2511425" defTabSz="989013">
-              <a:tabLst>
-                <a:tab pos="1885950" algn="l"/>
-              </a:tabLst>
-            </a:pPr>
-            <a:r>
-              <a:rPr lang="en-US" sz="2900" dirty="0"/>
-              <a:t>v1	</a:t>
-            </a:r>
-            <a:r>
-              <a:rPr lang="en-US" sz="2900" dirty="0">
+              <a:t>/apps/v1/namespaces/test/deployments/</a:t>
+            </a:r>
+            <a:r>
+              <a:rPr lang="en-US" dirty="0" err="1">
                 <a:solidFill>
                   <a:schemeClr val="tx1">
                     <a:lumMod val="75000"/>
                   </a:schemeClr>
                 </a:solidFill>
+                <a:latin typeface="Courier New" panose="02070309020205020404" pitchFamily="49" charset="0"/>
+                <a:cs typeface="Courier New" panose="02070309020205020404" pitchFamily="49" charset="0"/>
               </a:rPr>
-              <a:t>-- 	GA (general availability)</a:t>
-            </a:r>
+              <a:t>nginx</a:t>
+            </a:r>
+            <a:endParaRPr lang="en-US" dirty="0">
+              <a:solidFill>
+                <a:schemeClr val="tx1">
+                  <a:lumMod val="75000"/>
+                </a:schemeClr>
+              </a:solidFill>
+              <a:latin typeface="Courier New" panose="02070309020205020404" pitchFamily="49" charset="0"/>
+              <a:cs typeface="Courier New" panose="02070309020205020404" pitchFamily="49" charset="0"/>
+            </a:endParaRPr>
           </a:p>
         </p:txBody>
       </p:sp>
@@ -15216,6 +15556,185 @@
           <a:p>
             <a:r>
               <a:rPr lang="en-US" dirty="0"/>
+              <a:t>API Structure</a:t>
+            </a:r>
+          </a:p>
+        </p:txBody>
+      </p:sp>
+    </p:spTree>
+    <p:extLst>
+      <p:ext uri="{BB962C8B-B14F-4D97-AF65-F5344CB8AC3E}">
+        <p14:creationId xmlns:p14="http://schemas.microsoft.com/office/powerpoint/2010/main" val="355482527"/>
+      </p:ext>
+    </p:extLst>
+  </p:cSld>
+  <p:clrMapOvr>
+    <a:masterClrMapping/>
+  </p:clrMapOvr>
+</p:sld>
+</file>
+
+<file path=ppt/slides/slide11.xml><?xml version="1.0" encoding="utf-8"?>
+<p:sld xmlns:a="http://schemas.openxmlformats.org/drawingml/2006/main" xmlns:r="http://schemas.openxmlformats.org/officeDocument/2006/relationships" xmlns:p="http://schemas.openxmlformats.org/presentationml/2006/main">
+  <p:cSld>
+    <p:spTree>
+      <p:nvGrpSpPr>
+        <p:cNvPr id="1" name=""/>
+        <p:cNvGrpSpPr/>
+        <p:nvPr/>
+      </p:nvGrpSpPr>
+      <p:grpSpPr>
+        <a:xfrm>
+          <a:off x="0" y="0"/>
+          <a:ext cx="0" cy="0"/>
+          <a:chOff x="0" y="0"/>
+          <a:chExt cx="0" cy="0"/>
+        </a:xfrm>
+      </p:grpSpPr>
+      <p:sp>
+        <p:nvSpPr>
+          <p:cNvPr id="2" name="Text Placeholder 1">
+            <a:extLst>
+              <a:ext uri="{FF2B5EF4-FFF2-40B4-BE49-F238E27FC236}">
+                <a16:creationId xmlns:a16="http://schemas.microsoft.com/office/drawing/2014/main" id="{E187B6B1-1962-F343-B945-09936343593B}"/>
+              </a:ext>
+            </a:extLst>
+          </p:cNvPr>
+          <p:cNvSpPr>
+            <a:spLocks noGrp="1"/>
+          </p:cNvSpPr>
+          <p:nvPr>
+            <p:ph type="body" sz="quarter" idx="10"/>
+          </p:nvPr>
+        </p:nvSpPr>
+        <p:spPr/>
+        <p:txBody>
+          <a:bodyPr/>
+          <a:lstStyle/>
+          <a:p>
+            <a:pPr marL="2511425" indent="-2511425" defTabSz="989013">
+              <a:tabLst>
+                <a:tab pos="1885950" algn="l"/>
+              </a:tabLst>
+            </a:pPr>
+            <a:r>
+              <a:rPr lang="en-US" sz="2900" dirty="0"/>
+              <a:t>v1</a:t>
+            </a:r>
+            <a:r>
+              <a:rPr lang="en-US" sz="2900" b="1" dirty="0"/>
+              <a:t>alpha</a:t>
+            </a:r>
+            <a:r>
+              <a:rPr lang="en-US" sz="2900" dirty="0"/>
+              <a:t>1	</a:t>
+            </a:r>
+            <a:r>
+              <a:rPr lang="en-US" sz="2900" dirty="0">
+                <a:solidFill>
+                  <a:schemeClr val="tx1">
+                    <a:lumMod val="75000"/>
+                  </a:schemeClr>
+                </a:solidFill>
+              </a:rPr>
+              <a:t>-- 	cluster may explode, volatile </a:t>
+            </a:r>
+            <a:r>
+              <a:rPr lang="en-US" sz="2900" dirty="0" err="1">
+                <a:solidFill>
+                  <a:schemeClr val="tx1">
+                    <a:lumMod val="75000"/>
+                  </a:schemeClr>
+                </a:solidFill>
+              </a:rPr>
+              <a:t>api</a:t>
+            </a:r>
+            <a:r>
+              <a:rPr lang="en-US" sz="2900" dirty="0">
+                <a:solidFill>
+                  <a:schemeClr val="tx1">
+                    <a:lumMod val="75000"/>
+                  </a:schemeClr>
+                </a:solidFill>
+              </a:rPr>
+              <a:t> changes expected</a:t>
+            </a:r>
+          </a:p>
+          <a:p>
+            <a:pPr marL="2511425" indent="-2511425" defTabSz="989013">
+              <a:tabLst>
+                <a:tab pos="1885950" algn="l"/>
+              </a:tabLst>
+            </a:pPr>
+            <a:r>
+              <a:rPr lang="en-US" sz="2900" dirty="0"/>
+              <a:t>v1</a:t>
+            </a:r>
+            <a:r>
+              <a:rPr lang="en-US" sz="2900" b="1" dirty="0"/>
+              <a:t>beta</a:t>
+            </a:r>
+            <a:r>
+              <a:rPr lang="en-US" sz="2900" dirty="0"/>
+              <a:t>1	</a:t>
+            </a:r>
+            <a:r>
+              <a:rPr lang="en-US" sz="2900" dirty="0">
+                <a:solidFill>
+                  <a:schemeClr val="tx1">
+                    <a:lumMod val="75000"/>
+                  </a:schemeClr>
+                </a:solidFill>
+              </a:rPr>
+              <a:t>-- 	well tested and generally stable,  API semantics may still change in an incompatible fashion</a:t>
+            </a:r>
+          </a:p>
+          <a:p>
+            <a:pPr marL="2511425" indent="-2511425" defTabSz="989013">
+              <a:tabLst>
+                <a:tab pos="1885950" algn="l"/>
+              </a:tabLst>
+            </a:pPr>
+            <a:r>
+              <a:rPr lang="en-US" sz="2900" dirty="0"/>
+              <a:t>v1	</a:t>
+            </a:r>
+            <a:r>
+              <a:rPr lang="en-US" sz="2900" dirty="0">
+                <a:solidFill>
+                  <a:schemeClr val="tx1">
+                    <a:lumMod val="75000"/>
+                  </a:schemeClr>
+                </a:solidFill>
+              </a:rPr>
+              <a:t>-- 	GA (general availability)</a:t>
+            </a:r>
+          </a:p>
+        </p:txBody>
+      </p:sp>
+      <p:sp>
+        <p:nvSpPr>
+          <p:cNvPr id="3" name="Title 2">
+            <a:extLst>
+              <a:ext uri="{FF2B5EF4-FFF2-40B4-BE49-F238E27FC236}">
+                <a16:creationId xmlns:a16="http://schemas.microsoft.com/office/drawing/2014/main" id="{60ADE174-6361-924B-9F5E-46A0C40DC7AB}"/>
+              </a:ext>
+            </a:extLst>
+          </p:cNvPr>
+          <p:cNvSpPr>
+            <a:spLocks noGrp="1"/>
+          </p:cNvSpPr>
+          <p:nvPr>
+            <p:ph type="title"/>
+          </p:nvPr>
+        </p:nvSpPr>
+        <p:spPr/>
+        <p:txBody>
+          <a:bodyPr/>
+          <a:lstStyle/>
+          <a:p>
+            <a:r>
+              <a:rPr lang="en-US" dirty="0"/>
               <a:t>API Versioning</a:t>
             </a:r>
           </a:p>
@@ -15234,7 +15753,7 @@
 </p:sld>
 </file>
 
-<file path=ppt/slides/slide11.xml><?xml version="1.0" encoding="utf-8"?>
+<file path=ppt/slides/slide12.xml><?xml version="1.0" encoding="utf-8"?>
 <p:sld xmlns:a="http://schemas.openxmlformats.org/drawingml/2006/main" xmlns:r="http://schemas.openxmlformats.org/officeDocument/2006/relationships" xmlns:p="http://schemas.openxmlformats.org/presentationml/2006/main">
   <p:cSld>
     <p:spTree>
@@ -16617,7 +17136,7 @@
 </p:sld>
 </file>
 
-<file path=ppt/slides/slide12.xml><?xml version="1.0" encoding="utf-8"?>
+<file path=ppt/slides/slide13.xml><?xml version="1.0" encoding="utf-8"?>
 <p:sld xmlns:a="http://schemas.openxmlformats.org/drawingml/2006/main" xmlns:r="http://schemas.openxmlformats.org/officeDocument/2006/relationships" xmlns:p="http://schemas.openxmlformats.org/presentationml/2006/main">
   <p:cSld>
     <p:spTree>
@@ -16802,7 +17321,7 @@
 </p:sld>
 </file>
 
-<file path=ppt/slides/slide13.xml><?xml version="1.0" encoding="utf-8"?>
+<file path=ppt/slides/slide14.xml><?xml version="1.0" encoding="utf-8"?>
 <p:sld xmlns:a="http://schemas.openxmlformats.org/drawingml/2006/main" xmlns:r="http://schemas.openxmlformats.org/officeDocument/2006/relationships" xmlns:p="http://schemas.openxmlformats.org/presentationml/2006/main">
   <p:cSld>
     <p:spTree>
@@ -17812,7 +18331,7 @@
 </p:sld>
 </file>
 
-<file path=ppt/slides/slide14.xml><?xml version="1.0" encoding="utf-8"?>
+<file path=ppt/slides/slide15.xml><?xml version="1.0" encoding="utf-8"?>
 <p:sld xmlns:a="http://schemas.openxmlformats.org/drawingml/2006/main" xmlns:r="http://schemas.openxmlformats.org/officeDocument/2006/relationships" xmlns:p="http://schemas.openxmlformats.org/presentationml/2006/main">
   <p:cSld>
     <p:spTree>
@@ -19380,7 +19899,7 @@
 </p:sld>
 </file>
 
-<file path=ppt/slides/slide15.xml><?xml version="1.0" encoding="utf-8"?>
+<file path=ppt/slides/slide16.xml><?xml version="1.0" encoding="utf-8"?>
 <p:sld xmlns:a="http://schemas.openxmlformats.org/drawingml/2006/main" xmlns:r="http://schemas.openxmlformats.org/officeDocument/2006/relationships" xmlns:p="http://schemas.openxmlformats.org/presentationml/2006/main">
   <p:cSld>
     <p:spTree>
@@ -19462,7 +19981,7 @@
 </p:sld>
 </file>
 
-<file path=ppt/slides/slide16.xml><?xml version="1.0" encoding="utf-8"?>
+<file path=ppt/slides/slide17.xml><?xml version="1.0" encoding="utf-8"?>
 <p:sld xmlns:a="http://schemas.openxmlformats.org/drawingml/2006/main" xmlns:r="http://schemas.openxmlformats.org/officeDocument/2006/relationships" xmlns:p="http://schemas.openxmlformats.org/presentationml/2006/main">
   <p:cSld>
     <p:spTree>
@@ -20609,7 +21128,7 @@
 </p:sld>
 </file>
 
-<file path=ppt/slides/slide17.xml><?xml version="1.0" encoding="utf-8"?>
+<file path=ppt/slides/slide18.xml><?xml version="1.0" encoding="utf-8"?>
 <p:sld xmlns:a="http://schemas.openxmlformats.org/drawingml/2006/main" xmlns:r="http://schemas.openxmlformats.org/officeDocument/2006/relationships" xmlns:p="http://schemas.openxmlformats.org/presentationml/2006/main">
   <p:cSld>
     <p:spTree>
@@ -20697,7 +21216,7 @@
 </p:sld>
 </file>
 
-<file path=ppt/slides/slide18.xml><?xml version="1.0" encoding="utf-8"?>
+<file path=ppt/slides/slide19.xml><?xml version="1.0" encoding="utf-8"?>
 <p:sld xmlns:a="http://schemas.openxmlformats.org/drawingml/2006/main" xmlns:r="http://schemas.openxmlformats.org/officeDocument/2006/relationships" xmlns:p="http://schemas.openxmlformats.org/presentationml/2006/main" show="0">
   <p:cSld>
     <p:spTree>
@@ -29818,7 +30337,7 @@
           <p:nvPr>
             <p:extLst>
               <p:ext uri="{D42A27DB-BD31-4B8C-83A1-F6EECF244321}">
-                <p14:modId xmlns:p14="http://schemas.microsoft.com/office/powerpoint/2010/main" val="596726874"/>
+                <p14:modId xmlns:p14="http://schemas.microsoft.com/office/powerpoint/2010/main" val="1328628864"/>
               </p:ext>
             </p:extLst>
           </p:nvPr>
@@ -29865,172 +30384,10 @@
       </p:grpSpPr>
       <p:sp>
         <p:nvSpPr>
-          <p:cNvPr id="2" name="Text Placeholder 1">
+          <p:cNvPr id="3" name="Titel 2">
             <a:extLst>
               <a:ext uri="{FF2B5EF4-FFF2-40B4-BE49-F238E27FC236}">
-                <a16:creationId xmlns:a16="http://schemas.microsoft.com/office/drawing/2014/main" id="{E187B6B1-1962-F343-B945-09936343593B}"/>
-              </a:ext>
-            </a:extLst>
-          </p:cNvPr>
-          <p:cNvSpPr>
-            <a:spLocks noGrp="1"/>
-          </p:cNvSpPr>
-          <p:nvPr>
-            <p:ph type="body" sz="quarter" idx="10"/>
-          </p:nvPr>
-        </p:nvSpPr>
-        <p:spPr>
-          <a:xfrm>
-            <a:off x="504000" y="1620000"/>
-            <a:ext cx="11185200" cy="4230000"/>
-          </a:xfrm>
-        </p:spPr>
-        <p:txBody>
-          <a:bodyPr/>
-          <a:lstStyle/>
-          <a:p>
-            <a:r>
-              <a:rPr lang="en-US" dirty="0"/>
-              <a:t>/</a:t>
-            </a:r>
-            <a:r>
-              <a:rPr lang="en-US" dirty="0" err="1"/>
-              <a:t>api</a:t>
-            </a:r>
-            <a:r>
-              <a:rPr lang="en-US" dirty="0"/>
-              <a:t>/v1/			</a:t>
-            </a:r>
-            <a:r>
-              <a:rPr lang="en-US" dirty="0">
-                <a:solidFill>
-                  <a:schemeClr val="tx1">
-                    <a:lumMod val="75000"/>
-                  </a:schemeClr>
-                </a:solidFill>
-              </a:rPr>
-              <a:t>-- core objects like pods or services</a:t>
-            </a:r>
-          </a:p>
-          <a:p>
-            <a:r>
-              <a:rPr lang="en-US" dirty="0"/>
-              <a:t>/</a:t>
-            </a:r>
-            <a:r>
-              <a:rPr lang="en-US" dirty="0" err="1"/>
-              <a:t>api</a:t>
-            </a:r>
-            <a:r>
-              <a:rPr lang="en-US" dirty="0"/>
-              <a:t>/&lt;</a:t>
-            </a:r>
-            <a:r>
-              <a:rPr lang="en-US" dirty="0" err="1"/>
-              <a:t>apigroup</a:t>
-            </a:r>
-            <a:r>
-              <a:rPr lang="en-US" dirty="0"/>
-              <a:t>&gt; 		</a:t>
-            </a:r>
-            <a:r>
-              <a:rPr lang="en-US" dirty="0">
-                <a:solidFill>
-                  <a:schemeClr val="tx1">
-                    <a:lumMod val="75000"/>
-                  </a:schemeClr>
-                </a:solidFill>
-              </a:rPr>
-              <a:t>-- added later as the API grew</a:t>
-            </a:r>
-          </a:p>
-          <a:p>
-            <a:r>
-              <a:rPr lang="en-US" dirty="0"/>
-              <a:t>/ </a:t>
-            </a:r>
-            <a:r>
-              <a:rPr lang="en-US" dirty="0" err="1"/>
-              <a:t>api</a:t>
-            </a:r>
-            <a:r>
-              <a:rPr lang="en-US" dirty="0"/>
-              <a:t> /(&lt;</a:t>
-            </a:r>
-            <a:r>
-              <a:rPr lang="en-US" dirty="0" err="1"/>
-              <a:t>apigroup</a:t>
-            </a:r>
-            <a:r>
-              <a:rPr lang="en-US" dirty="0"/>
-              <a:t>&gt;/) </a:t>
-            </a:r>
-            <a:r>
-              <a:rPr lang="en-US" i="1" dirty="0"/>
-              <a:t>&lt;version&gt; </a:t>
-            </a:r>
-            <a:r>
-              <a:rPr lang="en-US" dirty="0"/>
-              <a:t>/ namespaces / </a:t>
-            </a:r>
-            <a:r>
-              <a:rPr lang="en-US" i="1" dirty="0"/>
-              <a:t>&lt;ns&gt; </a:t>
-            </a:r>
-            <a:r>
-              <a:rPr lang="en-US" dirty="0"/>
-              <a:t>/ </a:t>
-            </a:r>
-            <a:r>
-              <a:rPr lang="en-US" i="1" dirty="0"/>
-              <a:t>&lt;resource-type-name&gt; </a:t>
-            </a:r>
-            <a:r>
-              <a:rPr lang="en-US" dirty="0"/>
-              <a:t>/ </a:t>
-            </a:r>
-            <a:r>
-              <a:rPr lang="en-US" i="1" dirty="0"/>
-              <a:t>&lt;resource-name&gt;</a:t>
-            </a:r>
-          </a:p>
-          <a:p>
-            <a:r>
-              <a:rPr lang="en-US" i="1" dirty="0"/>
-              <a:t>	 			            &lt;ns&gt; / &lt;resource-type-name&gt; / &lt;resource-name&gt;</a:t>
-            </a:r>
-          </a:p>
-          <a:p>
-            <a:r>
-              <a:rPr lang="en-US" i="1" dirty="0"/>
-              <a:t>				             &lt;ns&gt; </a:t>
-            </a:r>
-            <a:r>
-              <a:rPr lang="en-US" dirty="0"/>
-              <a:t>/ </a:t>
-            </a:r>
-            <a:r>
-              <a:rPr lang="en-US" i="1" dirty="0"/>
-              <a:t>&lt;resource-type-name&gt; </a:t>
-            </a:r>
-            <a:r>
-              <a:rPr lang="en-US" dirty="0"/>
-              <a:t>/ </a:t>
-            </a:r>
-            <a:r>
-              <a:rPr lang="en-US" i="1" dirty="0"/>
-              <a:t>&lt;resource-name&gt;</a:t>
-            </a:r>
-            <a:endParaRPr lang="en-US" dirty="0"/>
-          </a:p>
-        </p:txBody>
-      </p:sp>
-      <p:sp>
-        <p:nvSpPr>
-          <p:cNvPr id="3" name="Title 2">
-            <a:extLst>
-              <a:ext uri="{FF2B5EF4-FFF2-40B4-BE49-F238E27FC236}">
-                <a16:creationId xmlns:a16="http://schemas.microsoft.com/office/drawing/2014/main" id="{60ADE174-6361-924B-9F5E-46A0C40DC7AB}"/>
+                <a16:creationId xmlns:a16="http://schemas.microsoft.com/office/drawing/2014/main" id="{9B3C3558-C095-714D-B5BC-58285D1A5815}"/>
               </a:ext>
             </a:extLst>
           </p:cNvPr>
@@ -30047,8 +30404,739 @@
           <a:lstStyle/>
           <a:p>
             <a:r>
-              <a:rPr lang="en-US" dirty="0"/>
-              <a:t>API Structure</a:t>
+              <a:rPr lang="de-DE" dirty="0"/>
+              <a:t>API Server</a:t>
+            </a:r>
+          </a:p>
+        </p:txBody>
+      </p:sp>
+      <p:sp>
+        <p:nvSpPr>
+          <p:cNvPr id="9" name="Rechteck 8">
+            <a:extLst>
+              <a:ext uri="{FF2B5EF4-FFF2-40B4-BE49-F238E27FC236}">
+                <a16:creationId xmlns:a16="http://schemas.microsoft.com/office/drawing/2014/main" id="{EABCBE22-9B04-084F-96CD-9D772E5EC758}"/>
+              </a:ext>
+            </a:extLst>
+          </p:cNvPr>
+          <p:cNvSpPr/>
+          <p:nvPr/>
+        </p:nvSpPr>
+        <p:spPr bwMode="gray">
+          <a:xfrm>
+            <a:off x="922275" y="2356231"/>
+            <a:ext cx="10349928" cy="1306286"/>
+          </a:xfrm>
+          <a:prstGeom prst="rect">
+            <a:avLst/>
+          </a:prstGeom>
+          <a:ln>
+            <a:headEnd/>
+            <a:tailEnd/>
+          </a:ln>
+        </p:spPr>
+        <p:style>
+          <a:lnRef idx="2">
+            <a:schemeClr val="accent2">
+              <a:shade val="50000"/>
+            </a:schemeClr>
+          </a:lnRef>
+          <a:fillRef idx="1">
+            <a:schemeClr val="accent2"/>
+          </a:fillRef>
+          <a:effectRef idx="0">
+            <a:schemeClr val="accent2"/>
+          </a:effectRef>
+          <a:fontRef idx="minor">
+            <a:schemeClr val="lt1"/>
+          </a:fontRef>
+        </p:style>
+        <p:txBody>
+          <a:bodyPr lIns="90000" tIns="72000" rIns="90000" bIns="72000" rtlCol="0" anchor="t"/>
+          <a:lstStyle/>
+          <a:p>
+            <a:pPr marR="0" algn="ctr" defTabSz="914400" eaLnBrk="1" fontAlgn="base" latinLnBrk="0" hangingPunct="1">
+              <a:lnSpc>
+                <a:spcPct val="150000"/>
+              </a:lnSpc>
+              <a:spcBef>
+                <a:spcPct val="50000"/>
+              </a:spcBef>
+              <a:spcAft>
+                <a:spcPct val="0"/>
+              </a:spcAft>
+              <a:buClr>
+                <a:srgbClr val="F0AB00"/>
+              </a:buClr>
+              <a:buSzPct val="80000"/>
+              <a:tabLst/>
+            </a:pPr>
+            <a:r>
+              <a:rPr kumimoji="0" lang="de-DE" sz="1800" b="1" i="0" u="none" strike="noStrike" kern="0" cap="none" spc="0" normalizeH="0" baseline="0" noProof="0" dirty="0">
+                <a:ln>
+                  <a:noFill/>
+                </a:ln>
+                <a:effectLst/>
+                <a:uLnTx/>
+                <a:uFillTx/>
+                <a:ea typeface="Arial Unicode MS" pitchFamily="34" charset="-128"/>
+                <a:cs typeface="Arial Unicode MS" pitchFamily="34" charset="-128"/>
+              </a:rPr>
+              <a:t>API Server</a:t>
+            </a:r>
+          </a:p>
+        </p:txBody>
+      </p:sp>
+      <p:sp>
+        <p:nvSpPr>
+          <p:cNvPr id="10" name="Rechteck 9">
+            <a:extLst>
+              <a:ext uri="{FF2B5EF4-FFF2-40B4-BE49-F238E27FC236}">
+                <a16:creationId xmlns:a16="http://schemas.microsoft.com/office/drawing/2014/main" id="{7F76FE9B-BFE8-F940-9B11-9902E3A988B8}"/>
+              </a:ext>
+            </a:extLst>
+          </p:cNvPr>
+          <p:cNvSpPr/>
+          <p:nvPr/>
+        </p:nvSpPr>
+        <p:spPr bwMode="gray">
+          <a:xfrm>
+            <a:off x="1314994" y="2933647"/>
+            <a:ext cx="2316480" cy="1245325"/>
+          </a:xfrm>
+          <a:prstGeom prst="rect">
+            <a:avLst/>
+          </a:prstGeom>
+          <a:ln>
+            <a:headEnd/>
+            <a:tailEnd/>
+          </a:ln>
+        </p:spPr>
+        <p:style>
+          <a:lnRef idx="2">
+            <a:schemeClr val="accent2"/>
+          </a:lnRef>
+          <a:fillRef idx="1">
+            <a:schemeClr val="lt1"/>
+          </a:fillRef>
+          <a:effectRef idx="0">
+            <a:schemeClr val="accent2"/>
+          </a:effectRef>
+          <a:fontRef idx="minor">
+            <a:schemeClr val="dk1"/>
+          </a:fontRef>
+        </p:style>
+        <p:txBody>
+          <a:bodyPr lIns="90000" tIns="72000" rIns="90000" bIns="72000" rtlCol="0" anchor="ctr"/>
+          <a:lstStyle/>
+          <a:p>
+            <a:pPr marR="0" algn="ctr" defTabSz="914400" eaLnBrk="1" fontAlgn="base" latinLnBrk="0" hangingPunct="1">
+              <a:lnSpc>
+                <a:spcPct val="100000"/>
+              </a:lnSpc>
+              <a:spcBef>
+                <a:spcPct val="50000"/>
+              </a:spcBef>
+              <a:spcAft>
+                <a:spcPct val="0"/>
+              </a:spcAft>
+              <a:buClr>
+                <a:srgbClr val="F0AB00"/>
+              </a:buClr>
+              <a:buSzPct val="80000"/>
+              <a:tabLst/>
+            </a:pPr>
+            <a:r>
+              <a:rPr kumimoji="0" lang="en-US" sz="1800" b="0" i="0" u="none" strike="noStrike" kern="0" cap="none" spc="0" normalizeH="0" baseline="0">
+                <a:ln>
+                  <a:noFill/>
+                </a:ln>
+                <a:effectLst/>
+                <a:uLnTx/>
+                <a:uFillTx/>
+                <a:ea typeface="Arial Unicode MS" pitchFamily="34" charset="-128"/>
+                <a:cs typeface="Arial Unicode MS" pitchFamily="34" charset="-128"/>
+              </a:rPr>
+              <a:t>Authorization &amp; Authentication</a:t>
+            </a:r>
+          </a:p>
+        </p:txBody>
+      </p:sp>
+      <p:sp>
+        <p:nvSpPr>
+          <p:cNvPr id="11" name="Rechteck 10">
+            <a:extLst>
+              <a:ext uri="{FF2B5EF4-FFF2-40B4-BE49-F238E27FC236}">
+                <a16:creationId xmlns:a16="http://schemas.microsoft.com/office/drawing/2014/main" id="{300BA241-3C38-6541-A50A-EC520A6D85F5}"/>
+              </a:ext>
+            </a:extLst>
+          </p:cNvPr>
+          <p:cNvSpPr/>
+          <p:nvPr/>
+        </p:nvSpPr>
+        <p:spPr bwMode="gray">
+          <a:xfrm>
+            <a:off x="3780759" y="2933647"/>
+            <a:ext cx="2316480" cy="1245325"/>
+          </a:xfrm>
+          <a:prstGeom prst="rect">
+            <a:avLst/>
+          </a:prstGeom>
+          <a:ln>
+            <a:headEnd/>
+            <a:tailEnd/>
+          </a:ln>
+        </p:spPr>
+        <p:style>
+          <a:lnRef idx="2">
+            <a:schemeClr val="accent2"/>
+          </a:lnRef>
+          <a:fillRef idx="1">
+            <a:schemeClr val="lt1"/>
+          </a:fillRef>
+          <a:effectRef idx="0">
+            <a:schemeClr val="accent2"/>
+          </a:effectRef>
+          <a:fontRef idx="minor">
+            <a:schemeClr val="dk1"/>
+          </a:fontRef>
+        </p:style>
+        <p:txBody>
+          <a:bodyPr lIns="90000" tIns="72000" rIns="90000" bIns="72000" rtlCol="0" anchor="ctr"/>
+          <a:lstStyle/>
+          <a:p>
+            <a:pPr marR="0" algn="ctr" defTabSz="914400" eaLnBrk="1" fontAlgn="base" latinLnBrk="0" hangingPunct="1">
+              <a:lnSpc>
+                <a:spcPct val="100000"/>
+              </a:lnSpc>
+              <a:spcBef>
+                <a:spcPct val="50000"/>
+              </a:spcBef>
+              <a:spcAft>
+                <a:spcPct val="0"/>
+              </a:spcAft>
+              <a:buClr>
+                <a:srgbClr val="F0AB00"/>
+              </a:buClr>
+              <a:buSzPct val="80000"/>
+              <a:tabLst/>
+            </a:pPr>
+            <a:r>
+              <a:rPr kumimoji="0" lang="en-US" sz="1800" b="0" i="0" u="none" strike="noStrike" kern="0" cap="none" spc="0" normalizeH="0" baseline="0" dirty="0">
+                <a:ln>
+                  <a:noFill/>
+                </a:ln>
+                <a:effectLst/>
+                <a:uLnTx/>
+                <a:uFillTx/>
+                <a:ea typeface="Arial Unicode MS" pitchFamily="34" charset="-128"/>
+                <a:cs typeface="Arial Unicode MS" pitchFamily="34" charset="-128"/>
+              </a:rPr>
+              <a:t>RESTful interface to all resources</a:t>
+            </a:r>
+          </a:p>
+        </p:txBody>
+      </p:sp>
+      <p:sp>
+        <p:nvSpPr>
+          <p:cNvPr id="13" name="Rechteck 12">
+            <a:extLst>
+              <a:ext uri="{FF2B5EF4-FFF2-40B4-BE49-F238E27FC236}">
+                <a16:creationId xmlns:a16="http://schemas.microsoft.com/office/drawing/2014/main" id="{70449EEC-C01B-744D-B641-9028A470CC57}"/>
+              </a:ext>
+            </a:extLst>
+          </p:cNvPr>
+          <p:cNvSpPr/>
+          <p:nvPr/>
+        </p:nvSpPr>
+        <p:spPr bwMode="gray">
+          <a:xfrm>
+            <a:off x="8713685" y="2933647"/>
+            <a:ext cx="2316480" cy="1245325"/>
+          </a:xfrm>
+          <a:prstGeom prst="rect">
+            <a:avLst/>
+          </a:prstGeom>
+          <a:ln>
+            <a:headEnd/>
+            <a:tailEnd/>
+          </a:ln>
+        </p:spPr>
+        <p:style>
+          <a:lnRef idx="2">
+            <a:schemeClr val="accent2"/>
+          </a:lnRef>
+          <a:fillRef idx="1">
+            <a:schemeClr val="lt1"/>
+          </a:fillRef>
+          <a:effectRef idx="0">
+            <a:schemeClr val="accent2"/>
+          </a:effectRef>
+          <a:fontRef idx="minor">
+            <a:schemeClr val="dk1"/>
+          </a:fontRef>
+        </p:style>
+        <p:txBody>
+          <a:bodyPr lIns="90000" tIns="72000" rIns="90000" bIns="72000" rtlCol="0" anchor="ctr"/>
+          <a:lstStyle/>
+          <a:p>
+            <a:pPr marR="0" algn="ctr" defTabSz="914400" eaLnBrk="1" fontAlgn="base" latinLnBrk="0" hangingPunct="1">
+              <a:lnSpc>
+                <a:spcPct val="100000"/>
+              </a:lnSpc>
+              <a:spcBef>
+                <a:spcPct val="50000"/>
+              </a:spcBef>
+              <a:spcAft>
+                <a:spcPct val="0"/>
+              </a:spcAft>
+              <a:buClr>
+                <a:srgbClr val="F0AB00"/>
+              </a:buClr>
+              <a:buSzPct val="80000"/>
+              <a:tabLst/>
+            </a:pPr>
+            <a:r>
+              <a:rPr kumimoji="0" lang="en-US" sz="1800" b="0" i="0" u="none" strike="noStrike" kern="0" cap="none" spc="0" normalizeH="0" baseline="0" dirty="0">
+                <a:ln>
+                  <a:noFill/>
+                </a:ln>
+                <a:effectLst/>
+                <a:uLnTx/>
+                <a:uFillTx/>
+                <a:ea typeface="Arial Unicode MS" pitchFamily="34" charset="-128"/>
+                <a:cs typeface="Arial Unicode MS" pitchFamily="34" charset="-128"/>
+              </a:rPr>
+              <a:t>Extensibility / register custom resources</a:t>
+            </a:r>
+          </a:p>
+        </p:txBody>
+      </p:sp>
+      <p:sp>
+        <p:nvSpPr>
+          <p:cNvPr id="14" name="Rechteck 13">
+            <a:extLst>
+              <a:ext uri="{FF2B5EF4-FFF2-40B4-BE49-F238E27FC236}">
+                <a16:creationId xmlns:a16="http://schemas.microsoft.com/office/drawing/2014/main" id="{4671CF31-0C83-F74D-9F46-20BCE21968F7}"/>
+              </a:ext>
+            </a:extLst>
+          </p:cNvPr>
+          <p:cNvSpPr/>
+          <p:nvPr/>
+        </p:nvSpPr>
+        <p:spPr bwMode="gray">
+          <a:xfrm>
+            <a:off x="6247222" y="2933647"/>
+            <a:ext cx="2316480" cy="1245325"/>
+          </a:xfrm>
+          <a:prstGeom prst="rect">
+            <a:avLst/>
+          </a:prstGeom>
+          <a:ln>
+            <a:headEnd/>
+            <a:tailEnd/>
+          </a:ln>
+        </p:spPr>
+        <p:style>
+          <a:lnRef idx="2">
+            <a:schemeClr val="accent2"/>
+          </a:lnRef>
+          <a:fillRef idx="1">
+            <a:schemeClr val="lt1"/>
+          </a:fillRef>
+          <a:effectRef idx="0">
+            <a:schemeClr val="accent2"/>
+          </a:effectRef>
+          <a:fontRef idx="minor">
+            <a:schemeClr val="dk1"/>
+          </a:fontRef>
+        </p:style>
+        <p:txBody>
+          <a:bodyPr lIns="90000" tIns="72000" rIns="90000" bIns="72000" rtlCol="0" anchor="ctr"/>
+          <a:lstStyle/>
+          <a:p>
+            <a:pPr marR="0" algn="ctr" defTabSz="914400" eaLnBrk="1" fontAlgn="base" latinLnBrk="0" hangingPunct="1">
+              <a:lnSpc>
+                <a:spcPct val="100000"/>
+              </a:lnSpc>
+              <a:spcBef>
+                <a:spcPct val="50000"/>
+              </a:spcBef>
+              <a:spcAft>
+                <a:spcPct val="0"/>
+              </a:spcAft>
+              <a:buClr>
+                <a:srgbClr val="F0AB00"/>
+              </a:buClr>
+              <a:buSzPct val="80000"/>
+              <a:tabLst/>
+            </a:pPr>
+            <a:r>
+              <a:rPr kumimoji="0" lang="en-US" sz="1800" b="0" i="0" u="none" strike="noStrike" kern="0" cap="none" spc="0" normalizeH="0" baseline="0" dirty="0">
+                <a:ln>
+                  <a:noFill/>
+                </a:ln>
+                <a:effectLst/>
+                <a:uLnTx/>
+                <a:uFillTx/>
+                <a:ea typeface="Arial Unicode MS" pitchFamily="34" charset="-128"/>
+                <a:cs typeface="Arial Unicode MS" pitchFamily="34" charset="-128"/>
+              </a:rPr>
+              <a:t>Admission &amp; Mutation</a:t>
+            </a:r>
+          </a:p>
+        </p:txBody>
+      </p:sp>
+      <p:pic>
+        <p:nvPicPr>
+          <p:cNvPr id="16" name="Grafik 15">
+            <a:extLst>
+              <a:ext uri="{FF2B5EF4-FFF2-40B4-BE49-F238E27FC236}">
+                <a16:creationId xmlns:a16="http://schemas.microsoft.com/office/drawing/2014/main" id="{9FE2E5DD-FCAC-5544-A95E-1426BD60AE0A}"/>
+              </a:ext>
+            </a:extLst>
+          </p:cNvPr>
+          <p:cNvPicPr>
+            <a:picLocks noChangeAspect="1"/>
+          </p:cNvPicPr>
+          <p:nvPr/>
+        </p:nvPicPr>
+        <p:blipFill>
+          <a:blip r:embed="rId3"/>
+          <a:stretch>
+            <a:fillRect/>
+          </a:stretch>
+        </p:blipFill>
+        <p:spPr>
+          <a:xfrm>
+            <a:off x="5220939" y="5132213"/>
+            <a:ext cx="1752600" cy="1498600"/>
+          </a:xfrm>
+          <a:prstGeom prst="rect">
+            <a:avLst/>
+          </a:prstGeom>
+        </p:spPr>
+      </p:pic>
+      <p:sp>
+        <p:nvSpPr>
+          <p:cNvPr id="17" name="Pfeil nach unten 16">
+            <a:extLst>
+              <a:ext uri="{FF2B5EF4-FFF2-40B4-BE49-F238E27FC236}">
+                <a16:creationId xmlns:a16="http://schemas.microsoft.com/office/drawing/2014/main" id="{90E2C602-AFB1-4E40-BD19-A5BC932CE719}"/>
+              </a:ext>
+            </a:extLst>
+          </p:cNvPr>
+          <p:cNvSpPr/>
+          <p:nvPr/>
+        </p:nvSpPr>
+        <p:spPr bwMode="gray">
+          <a:xfrm>
+            <a:off x="5875170" y="4333739"/>
+            <a:ext cx="444137" cy="649080"/>
+          </a:xfrm>
+          <a:prstGeom prst="downArrow">
+            <a:avLst/>
+          </a:prstGeom>
+          <a:solidFill>
+            <a:schemeClr val="accent1"/>
+          </a:solidFill>
+          <a:ln w="6350" algn="ctr">
+            <a:noFill/>
+            <a:miter lim="800000"/>
+            <a:headEnd/>
+            <a:tailEnd/>
+          </a:ln>
+        </p:spPr>
+        <p:txBody>
+          <a:bodyPr lIns="90000" tIns="72000" rIns="90000" bIns="72000" rtlCol="0" anchor="ctr"/>
+          <a:lstStyle/>
+          <a:p>
+            <a:pPr marR="0" algn="ctr" defTabSz="914400" eaLnBrk="1" fontAlgn="base" latinLnBrk="0" hangingPunct="1">
+              <a:lnSpc>
+                <a:spcPct val="100000"/>
+              </a:lnSpc>
+              <a:spcBef>
+                <a:spcPct val="50000"/>
+              </a:spcBef>
+              <a:spcAft>
+                <a:spcPct val="0"/>
+              </a:spcAft>
+              <a:buClr>
+                <a:srgbClr val="F0AB00"/>
+              </a:buClr>
+              <a:buSzPct val="80000"/>
+              <a:tabLst/>
+            </a:pPr>
+            <a:endParaRPr kumimoji="0" lang="de-DE" sz="1800" b="0" i="0" u="none" strike="noStrike" kern="0" cap="none" spc="0" normalizeH="0" baseline="0" noProof="0" dirty="0" err="1">
+              <a:ln>
+                <a:noFill/>
+              </a:ln>
+              <a:effectLst/>
+              <a:uLnTx/>
+              <a:uFillTx/>
+              <a:ea typeface="Arial Unicode MS" pitchFamily="34" charset="-128"/>
+              <a:cs typeface="Arial Unicode MS" pitchFamily="34" charset="-128"/>
+            </a:endParaRPr>
+          </a:p>
+        </p:txBody>
+      </p:sp>
+      <p:pic>
+        <p:nvPicPr>
+          <p:cNvPr id="4" name="Grafik 3" descr="Benutzer mit einfarbiger Füllung">
+            <a:extLst>
+              <a:ext uri="{FF2B5EF4-FFF2-40B4-BE49-F238E27FC236}">
+                <a16:creationId xmlns:a16="http://schemas.microsoft.com/office/drawing/2014/main" id="{8FBDFABB-A880-F24E-9460-1F585E865DC4}"/>
+              </a:ext>
+            </a:extLst>
+          </p:cNvPr>
+          <p:cNvPicPr>
+            <a:picLocks noChangeAspect="1"/>
+          </p:cNvPicPr>
+          <p:nvPr/>
+        </p:nvPicPr>
+        <p:blipFill>
+          <a:blip r:embed="rId4">
+            <a:extLst>
+              <a:ext uri="{96DAC541-7B7A-43D3-8B79-37D633B846F1}">
+                <asvg:svgBlip xmlns:asvg="http://schemas.microsoft.com/office/drawing/2016/SVG/main" r:embed="rId5"/>
+              </a:ext>
+            </a:extLst>
+          </a:blip>
+          <a:stretch>
+            <a:fillRect/>
+          </a:stretch>
+        </p:blipFill>
+        <p:spPr>
+          <a:xfrm>
+            <a:off x="4481799" y="974359"/>
+            <a:ext cx="914400" cy="914400"/>
+          </a:xfrm>
+          <a:prstGeom prst="rect">
+            <a:avLst/>
+          </a:prstGeom>
+        </p:spPr>
+      </p:pic>
+      <p:pic>
+        <p:nvPicPr>
+          <p:cNvPr id="6" name="Grafik 5" descr="Webdesign mit einfarbiger Füllung">
+            <a:extLst>
+              <a:ext uri="{FF2B5EF4-FFF2-40B4-BE49-F238E27FC236}">
+                <a16:creationId xmlns:a16="http://schemas.microsoft.com/office/drawing/2014/main" id="{F11A073E-07C2-614A-972E-3CC783FDBB66}"/>
+              </a:ext>
+            </a:extLst>
+          </p:cNvPr>
+          <p:cNvPicPr>
+            <a:picLocks noChangeAspect="1"/>
+          </p:cNvPicPr>
+          <p:nvPr/>
+        </p:nvPicPr>
+        <p:blipFill>
+          <a:blip r:embed="rId6">
+            <a:extLst>
+              <a:ext uri="{96DAC541-7B7A-43D3-8B79-37D633B846F1}">
+                <asvg:svgBlip xmlns:asvg="http://schemas.microsoft.com/office/drawing/2016/SVG/main" r:embed="rId7"/>
+              </a:ext>
+            </a:extLst>
+          </a:blip>
+          <a:stretch>
+            <a:fillRect/>
+          </a:stretch>
+        </p:blipFill>
+        <p:spPr>
+          <a:xfrm>
+            <a:off x="6798977" y="974359"/>
+            <a:ext cx="914400" cy="914400"/>
+          </a:xfrm>
+          <a:prstGeom prst="rect">
+            <a:avLst/>
+          </a:prstGeom>
+        </p:spPr>
+      </p:pic>
+      <p:cxnSp>
+        <p:nvCxnSpPr>
+          <p:cNvPr id="8" name="Gewinkelte Verbindung 7">
+            <a:extLst>
+              <a:ext uri="{FF2B5EF4-FFF2-40B4-BE49-F238E27FC236}">
+                <a16:creationId xmlns:a16="http://schemas.microsoft.com/office/drawing/2014/main" id="{AD8F7F17-D4C3-9447-BF0A-62ED0726F70C}"/>
+              </a:ext>
+            </a:extLst>
+          </p:cNvPr>
+          <p:cNvCxnSpPr>
+            <a:stCxn id="4" idx="3"/>
+            <a:endCxn id="9" idx="0"/>
+          </p:cNvCxnSpPr>
+          <p:nvPr/>
+        </p:nvCxnSpPr>
+        <p:spPr>
+          <a:xfrm>
+            <a:off x="5396199" y="1431559"/>
+            <a:ext cx="701040" cy="924672"/>
+          </a:xfrm>
+          <a:prstGeom prst="bentConnector2">
+            <a:avLst/>
+          </a:prstGeom>
+          <a:ln w="38100">
+            <a:headEnd type="none" w="med" len="med"/>
+            <a:tailEnd type="triangle"/>
+          </a:ln>
+        </p:spPr>
+        <p:style>
+          <a:lnRef idx="1">
+            <a:schemeClr val="accent2"/>
+          </a:lnRef>
+          <a:fillRef idx="0">
+            <a:schemeClr val="accent2"/>
+          </a:fillRef>
+          <a:effectRef idx="0">
+            <a:schemeClr val="accent2"/>
+          </a:effectRef>
+          <a:fontRef idx="minor">
+            <a:schemeClr val="tx1"/>
+          </a:fontRef>
+        </p:style>
+      </p:cxnSp>
+      <p:cxnSp>
+        <p:nvCxnSpPr>
+          <p:cNvPr id="18" name="Gewinkelte Verbindung 17">
+            <a:extLst>
+              <a:ext uri="{FF2B5EF4-FFF2-40B4-BE49-F238E27FC236}">
+                <a16:creationId xmlns:a16="http://schemas.microsoft.com/office/drawing/2014/main" id="{6F6E005C-3B95-8244-9E3A-3D54FB17E46A}"/>
+              </a:ext>
+            </a:extLst>
+          </p:cNvPr>
+          <p:cNvCxnSpPr>
+            <a:cxnSpLocks/>
+            <a:stCxn id="6" idx="1"/>
+            <a:endCxn id="9" idx="0"/>
+          </p:cNvCxnSpPr>
+          <p:nvPr/>
+        </p:nvCxnSpPr>
+        <p:spPr>
+          <a:xfrm rot="10800000" flipV="1">
+            <a:off x="6097239" y="1431559"/>
+            <a:ext cx="701738" cy="924672"/>
+          </a:xfrm>
+          <a:prstGeom prst="bentConnector2">
+            <a:avLst/>
+          </a:prstGeom>
+          <a:ln w="38100">
+            <a:headEnd type="none" w="med" len="med"/>
+            <a:tailEnd type="triangle"/>
+          </a:ln>
+        </p:spPr>
+        <p:style>
+          <a:lnRef idx="1">
+            <a:schemeClr val="accent2"/>
+          </a:lnRef>
+          <a:fillRef idx="0">
+            <a:schemeClr val="accent2"/>
+          </a:fillRef>
+          <a:effectRef idx="0">
+            <a:schemeClr val="accent2"/>
+          </a:effectRef>
+          <a:fontRef idx="minor">
+            <a:schemeClr val="tx1"/>
+          </a:fontRef>
+        </p:style>
+      </p:cxnSp>
+      <p:sp>
+        <p:nvSpPr>
+          <p:cNvPr id="20" name="Textfeld 19">
+            <a:extLst>
+              <a:ext uri="{FF2B5EF4-FFF2-40B4-BE49-F238E27FC236}">
+                <a16:creationId xmlns:a16="http://schemas.microsoft.com/office/drawing/2014/main" id="{17655D40-1288-4D4F-91BB-2573547648B0}"/>
+              </a:ext>
+            </a:extLst>
+          </p:cNvPr>
+          <p:cNvSpPr txBox="1"/>
+          <p:nvPr/>
+        </p:nvSpPr>
+        <p:spPr>
+          <a:xfrm>
+            <a:off x="4116176" y="736947"/>
+            <a:ext cx="1645645" cy="276999"/>
+          </a:xfrm>
+          <a:prstGeom prst="rect">
+            <a:avLst/>
+          </a:prstGeom>
+          <a:noFill/>
+        </p:spPr>
+        <p:txBody>
+          <a:bodyPr wrap="square" lIns="0" tIns="0" rIns="0" bIns="0" rtlCol="0">
+            <a:spAutoFit/>
+          </a:bodyPr>
+          <a:lstStyle/>
+          <a:p>
+            <a:pPr algn="ctr" fontAlgn="base">
+              <a:spcBef>
+                <a:spcPct val="50000"/>
+              </a:spcBef>
+              <a:spcAft>
+                <a:spcPct val="0"/>
+              </a:spcAft>
+              <a:buClr>
+                <a:srgbClr val="F0AB00"/>
+              </a:buClr>
+              <a:buSzPct val="80000"/>
+            </a:pPr>
+            <a:r>
+              <a:rPr lang="de-DE" sz="1800" kern="0" dirty="0">
+                <a:latin typeface="Courier New" panose="02070309020205020404" pitchFamily="49" charset="0"/>
+                <a:ea typeface="Arial Unicode MS" pitchFamily="34" charset="-128"/>
+                <a:cs typeface="Courier New" panose="02070309020205020404" pitchFamily="49" charset="0"/>
+              </a:rPr>
+              <a:t>HTTP Verbs</a:t>
+            </a:r>
+          </a:p>
+        </p:txBody>
+      </p:sp>
+      <p:sp>
+        <p:nvSpPr>
+          <p:cNvPr id="15" name="Textfeld 14">
+            <a:extLst>
+              <a:ext uri="{FF2B5EF4-FFF2-40B4-BE49-F238E27FC236}">
+                <a16:creationId xmlns:a16="http://schemas.microsoft.com/office/drawing/2014/main" id="{810000F1-A82E-7D4F-A8C9-CAC362578145}"/>
+              </a:ext>
+            </a:extLst>
+          </p:cNvPr>
+          <p:cNvSpPr txBox="1"/>
+          <p:nvPr/>
+        </p:nvSpPr>
+        <p:spPr>
+          <a:xfrm>
+            <a:off x="6448108" y="738291"/>
+            <a:ext cx="1645645" cy="276999"/>
+          </a:xfrm>
+          <a:prstGeom prst="rect">
+            <a:avLst/>
+          </a:prstGeom>
+          <a:noFill/>
+        </p:spPr>
+        <p:txBody>
+          <a:bodyPr wrap="square" lIns="0" tIns="0" rIns="0" bIns="0" rtlCol="0">
+            <a:spAutoFit/>
+          </a:bodyPr>
+          <a:lstStyle/>
+          <a:p>
+            <a:pPr algn="ctr" fontAlgn="base">
+              <a:spcBef>
+                <a:spcPct val="50000"/>
+              </a:spcBef>
+              <a:spcAft>
+                <a:spcPct val="0"/>
+              </a:spcAft>
+              <a:buClr>
+                <a:srgbClr val="F0AB00"/>
+              </a:buClr>
+              <a:buSzPct val="80000"/>
+            </a:pPr>
+            <a:r>
+              <a:rPr lang="de-DE" sz="1800" kern="0" dirty="0">
+                <a:latin typeface="Courier New" panose="02070309020205020404" pitchFamily="49" charset="0"/>
+                <a:ea typeface="Arial Unicode MS" pitchFamily="34" charset="-128"/>
+                <a:cs typeface="Courier New" panose="02070309020205020404" pitchFamily="49" charset="0"/>
+              </a:rPr>
+              <a:t>Watch</a:t>
             </a:r>
           </a:p>
         </p:txBody>
@@ -30056,7 +31144,7 @@
     </p:spTree>
     <p:extLst>
       <p:ext uri="{BB962C8B-B14F-4D97-AF65-F5344CB8AC3E}">
-        <p14:creationId xmlns:p14="http://schemas.microsoft.com/office/powerpoint/2010/main" val="355482527"/>
+        <p14:creationId xmlns:p14="http://schemas.microsoft.com/office/powerpoint/2010/main" val="3782367453"/>
       </p:ext>
     </p:extLst>
   </p:cSld>

</xml_diff>

<commit_message>
switch PVC to rwop
</commit_message>
<xml_diff>
--- a/kubernetes/01_k8s_core_components.pptx
+++ b/kubernetes/01_k8s_core_components.pptx
@@ -24507,7 +24507,7 @@
                 <a:tabLst/>
               </a:pPr>
               <a:r>
-                <a:rPr kumimoji="0" lang="en-US" sz="1400" b="0" i="0" u="none" strike="noStrike" kern="0" cap="none" spc="0" normalizeH="0" baseline="0" noProof="0" dirty="0" err="1">
+                <a:rPr kumimoji="0" lang="en-US" sz="1400" b="0" i="0" u="none" strike="noStrike" kern="0" cap="none" spc="0" normalizeH="0" baseline="0" noProof="0">
                   <a:ln>
                     <a:noFill/>
                   </a:ln>
@@ -24519,19 +24519,16 @@
                 </a:rPr>
                 <a:t>PodSecurity</a:t>
               </a:r>
-              <a:r>
-                <a:rPr kumimoji="0" lang="en-US" sz="1400" b="0" i="0" u="none" strike="noStrike" kern="0" cap="none" spc="0" normalizeH="0" baseline="0" noProof="0" dirty="0">
-                  <a:ln>
-                    <a:noFill/>
-                  </a:ln>
-                  <a:effectLst/>
-                  <a:uLnTx/>
-                  <a:uFillTx/>
-                  <a:ea typeface="Arial Unicode MS" pitchFamily="34" charset="-128"/>
-                  <a:cs typeface="Arial Unicode MS" pitchFamily="34" charset="-128"/>
-                </a:rPr>
-                <a:t> Policy</a:t>
-              </a:r>
+              <a:endParaRPr kumimoji="0" lang="en-US" sz="1400" b="0" i="0" u="none" strike="noStrike" kern="0" cap="none" spc="0" normalizeH="0" baseline="0" noProof="0" dirty="0">
+                <a:ln>
+                  <a:noFill/>
+                </a:ln>
+                <a:effectLst/>
+                <a:uLnTx/>
+                <a:uFillTx/>
+                <a:ea typeface="Arial Unicode MS" pitchFamily="34" charset="-128"/>
+                <a:cs typeface="Arial Unicode MS" pitchFamily="34" charset="-128"/>
+              </a:endParaRPr>
             </a:p>
           </p:txBody>
         </p:sp>

</xml_diff>